<commit_message>
Add slide on general categories of sensitive data not to share with AI
</commit_message>
<xml_diff>
--- a/AI At Work.pptx
+++ b/AI At Work.pptx
@@ -16,6 +16,7 @@
     <p:sldId id="260" r:id="rId9"/>
     <p:sldId id="261" r:id="rId10"/>
     <p:sldId id="262" r:id="rId11"/>
+    <p:sldId id="268" r:id="rId18"/>
     <p:sldId id="263" r:id="rId12"/>
     <p:sldId id="264" r:id="rId13"/>
     <p:sldId id="266" r:id="rId14"/>
@@ -2696,7 +2697,7 @@
                 <a:ea typeface="Arial" panose="020B0604020202020204" pitchFamily="34" charset="-122"/>
                 <a:cs typeface="Arial" panose="020B0604020202020204" pitchFamily="34" charset="-120"/>
               </a:rPr>
-              <a:t>10</a:t>
+              <a:t>11</a:t>
             </a:r>
             <a:endParaRPr lang="en-US" sz="900" dirty="0"/>
           </a:p>
@@ -2797,6 +2798,1007 @@
               <a:t>If you were wondering, yes, this presentation was made with AI help.</a:t>
             </a:r>
             <a:endParaRPr lang="en-US" sz="1800" dirty="0"/>
+          </a:p>
+        </p:txBody>
+      </p:sp>
+    </p:spTree>
+  </p:cSld>
+  <p:clrMapOvr>
+    <a:masterClrMapping/>
+  </p:clrMapOvr>
+</p:sld>
+</file>
+
+<file path=ppt/slides/slide12.xml><?xml version="1.0" encoding="utf-8"?>
+<p:sld xmlns:a="http://schemas.openxmlformats.org/drawingml/2006/main" xmlns:r="http://schemas.openxmlformats.org/officeDocument/2006/relationships" xmlns:p="http://schemas.openxmlformats.org/presentationml/2006/main">
+  <p:cSld>
+    <p:bg>
+      <p:bgPr>
+        <a:solidFill>
+          <a:srgbClr val="FFFFFF"/>
+        </a:solidFill>
+        <a:effectLst/>
+      </p:bgPr>
+    </p:bg>
+    <p:spTree>
+      <p:nvGrpSpPr>
+        <p:cNvPr id="1" name=""/>
+        <p:cNvGrpSpPr/>
+        <p:nvPr/>
+      </p:nvGrpSpPr>
+      <p:grpSpPr>
+        <a:xfrm>
+          <a:off x="0" y="0"/>
+          <a:ext cx="0" cy="0"/>
+          <a:chOff x="0" y="0"/>
+          <a:chExt cx="0" cy="0"/>
+        </a:xfrm>
+      </p:grpSpPr>
+      <p:pic>
+        <p:nvPicPr>
+          <p:cNvPr id="2" name="Image 0" descr="/home/claude/work/assets/tpl_content.jpg"/>
+          <p:cNvPicPr>
+            <a:picLocks noChangeAspect="1"/>
+          </p:cNvPicPr>
+          <p:nvPr/>
+        </p:nvPicPr>
+        <p:blipFill>
+          <a:blip r:embed="rId1"/>
+          <a:stretch>
+            <a:fillRect/>
+          </a:stretch>
+        </p:blipFill>
+        <p:spPr>
+          <a:xfrm>
+            <a:off x="0" y="0"/>
+            <a:ext cx="12188952" cy="6858000"/>
+          </a:xfrm>
+          <a:prstGeom prst="rect">
+            <a:avLst/>
+          </a:prstGeom>
+        </p:spPr>
+      </p:pic>
+      <p:sp>
+        <p:nvSpPr>
+          <p:cNvPr id="3" name="Text 0"/>
+          <p:cNvSpPr txBox="1"/>
+          <p:nvPr/>
+        </p:nvSpPr>
+        <p:spPr>
+          <a:xfrm>
+            <a:off x="320040" y="219456"/>
+            <a:ext cx="10607040" cy="731520"/>
+          </a:xfrm>
+          <a:prstGeom prst="rect">
+            <a:avLst/>
+          </a:prstGeom>
+          <a:noFill/>
+        </p:spPr>
+        <p:txBody>
+          <a:bodyPr wrap="square" lIns="0" tIns="0" rIns="0" bIns="0" rtlCol="0" anchor="ctr"/>
+          <a:lstStyle/>
+          <a:p>
+            <a:pPr marL="0" indent="0" algn="ctr">
+              <a:buNone/>
+            </a:pPr>
+            <a:r>
+              <a:rPr lang="en-US" sz="3000" dirty="0">
+                <a:solidFill>
+                  <a:srgbClr val="FFFFFF"/>
+                </a:solidFill>
+                <a:latin typeface="Arial" panose="020B0604020202020204" pitchFamily="34" charset="0"/>
+                <a:ea typeface="Arial" panose="020B0604020202020204" pitchFamily="34" charset="-122"/>
+                <a:cs typeface="Arial" panose="020B0604020202020204" pitchFamily="34" charset="-120"/>
+              </a:rPr>
+              <a:t>What generally counts as sensitive</a:t>
+            </a:r>
+            <a:endParaRPr lang="en-US" sz="3000" dirty="0"/>
+          </a:p>
+        </p:txBody>
+      </p:sp>
+      <p:sp>
+        <p:nvSpPr>
+          <p:cNvPr id="4" name="Shape 1"/>
+          <p:cNvSpPr/>
+          <p:nvPr/>
+        </p:nvSpPr>
+        <p:spPr>
+          <a:xfrm>
+            <a:off x="640080" y="1600200"/>
+            <a:ext cx="5074920" cy="1783080"/>
+          </a:xfrm>
+          <a:prstGeom prst="roundRect">
+            <a:avLst>
+              <a:gd name="adj" fmla="val 6154"/>
+            </a:avLst>
+          </a:prstGeom>
+          <a:solidFill>
+            <a:srgbClr val="F2F5FA"/>
+          </a:solidFill>
+          <a:effectLst>
+            <a:outerShdw blurRad="76200" dist="25400" dir="5400000" algn="bl" rotWithShape="0">
+              <a:srgbClr val="000000">
+                <a:alpha val="8000"/>
+              </a:srgbClr>
+            </a:outerShdw>
+          </a:effectLst>
+        </p:spPr>
+      </p:sp>
+      <p:pic>
+        <p:nvPicPr>
+          <p:cNvPr id="5" name="Image 1" descr="/home/claude/work/assets/badge_gradient.png"/>
+          <p:cNvPicPr>
+            <a:picLocks noChangeAspect="1"/>
+          </p:cNvPicPr>
+          <p:nvPr/>
+        </p:nvPicPr>
+        <p:blipFill>
+          <a:blip r:embed="rId2"/>
+          <a:stretch>
+            <a:fillRect/>
+          </a:stretch>
+        </p:blipFill>
+        <p:spPr>
+          <a:xfrm>
+            <a:off x="896112" y="1828800"/>
+            <a:ext cx="457200" cy="457200"/>
+          </a:xfrm>
+          <a:prstGeom prst="rect">
+            <a:avLst/>
+          </a:prstGeom>
+          <a:effectLst>
+            <a:outerShdw blurRad="76200" dist="25400" dir="5400000" algn="bl" rotWithShape="0">
+              <a:srgbClr val="3A2E6E">
+                <a:alpha val="30000"/>
+              </a:srgbClr>
+            </a:outerShdw>
+          </a:effectLst>
+        </p:spPr>
+      </p:pic>
+      <p:sp>
+        <p:nvSpPr>
+          <p:cNvPr id="6" name="Text 2"/>
+          <p:cNvSpPr txBox="1"/>
+          <p:nvPr/>
+        </p:nvSpPr>
+        <p:spPr>
+          <a:xfrm>
+            <a:off x="896112" y="1828800"/>
+            <a:ext cx="457200" cy="457200"/>
+          </a:xfrm>
+          <a:prstGeom prst="rect">
+            <a:avLst/>
+          </a:prstGeom>
+          <a:noFill/>
+        </p:spPr>
+        <p:txBody>
+          <a:bodyPr wrap="square" lIns="0" tIns="0" rIns="0" bIns="0" rtlCol="0" anchor="ctr"/>
+          <a:lstStyle/>
+          <a:p>
+            <a:pPr marL="0" indent="0" algn="ctr">
+              <a:buNone/>
+            </a:pPr>
+            <a:r>
+              <a:rPr lang="en-US" sz="1600" b="1" dirty="0">
+                <a:solidFill>
+                  <a:srgbClr val="FFFFFF"/>
+                </a:solidFill>
+                <a:latin typeface="Arial" panose="020B0604020202020204" pitchFamily="34" charset="0"/>
+                <a:ea typeface="Arial" panose="020B0604020202020204" pitchFamily="34" charset="-122"/>
+                <a:cs typeface="Arial" panose="020B0604020202020204" pitchFamily="34" charset="-120"/>
+              </a:rPr>
+              <a:t>1</a:t>
+            </a:r>
+            <a:endParaRPr lang="en-US" sz="1600" dirty="0"/>
+          </a:p>
+        </p:txBody>
+      </p:sp>
+      <p:sp>
+        <p:nvSpPr>
+          <p:cNvPr id="7" name="Text 3"/>
+          <p:cNvSpPr txBox="1"/>
+          <p:nvPr/>
+        </p:nvSpPr>
+        <p:spPr>
+          <a:xfrm>
+            <a:off x="1536192" y="1801368"/>
+            <a:ext cx="3931920" cy="457200"/>
+          </a:xfrm>
+          <a:prstGeom prst="rect">
+            <a:avLst/>
+          </a:prstGeom>
+          <a:noFill/>
+        </p:spPr>
+        <p:txBody>
+          <a:bodyPr wrap="square" lIns="0" tIns="0" rIns="0" bIns="0" rtlCol="0" anchor="ctr"/>
+          <a:lstStyle/>
+          <a:p>
+            <a:pPr marL="0" indent="0">
+              <a:buNone/>
+            </a:pPr>
+            <a:r>
+              <a:rPr lang="en-US" sz="1600" b="1" dirty="0">
+                <a:solidFill>
+                  <a:srgbClr val="00081D"/>
+                </a:solidFill>
+                <a:latin typeface="Arial" panose="020B0604020202020204" pitchFamily="34" charset="0"/>
+                <a:ea typeface="Arial" panose="020B0604020202020204" pitchFamily="34" charset="-122"/>
+                <a:cs typeface="Arial" panose="020B0604020202020204" pitchFamily="34" charset="-120"/>
+              </a:rPr>
+              <a:t>Client &amp; personal data</a:t>
+            </a:r>
+            <a:endParaRPr lang="en-US" sz="1600" dirty="0"/>
+          </a:p>
+        </p:txBody>
+      </p:sp>
+      <p:sp>
+        <p:nvSpPr>
+          <p:cNvPr id="8" name="Text 4"/>
+          <p:cNvSpPr txBox="1"/>
+          <p:nvPr/>
+        </p:nvSpPr>
+        <p:spPr>
+          <a:xfrm>
+            <a:off x="932688" y="2331720"/>
+            <a:ext cx="4489704" cy="868680"/>
+          </a:xfrm>
+          <a:prstGeom prst="rect">
+            <a:avLst/>
+          </a:prstGeom>
+          <a:noFill/>
+        </p:spPr>
+        <p:txBody>
+          <a:bodyPr wrap="square" lIns="0" tIns="0" rIns="0" bIns="0" rtlCol="0" anchor="ctr"/>
+          <a:lstStyle/>
+          <a:p>
+            <a:pPr marL="0" indent="0">
+              <a:lnSpc>
+                <a:spcPts val="1550"/>
+              </a:lnSpc>
+              <a:buNone/>
+            </a:pPr>
+            <a:r>
+              <a:rPr lang="en-US" sz="1150" dirty="0">
+                <a:solidFill>
+                  <a:srgbClr val="56606E"/>
+                </a:solidFill>
+                <a:latin typeface="Arial" panose="020B0604020202020204" pitchFamily="34" charset="0"/>
+                <a:ea typeface="Arial" panose="020B0604020202020204" pitchFamily="34" charset="-122"/>
+                <a:cs typeface="Arial" panose="020B0604020202020204" pitchFamily="34" charset="-120"/>
+              </a:rPr>
+              <a:t>Names, employers, contact details — anyone identifiable, colleague or client.</a:t>
+            </a:r>
+            <a:endParaRPr lang="en-US" sz="1150" dirty="0"/>
+          </a:p>
+        </p:txBody>
+      </p:sp>
+      <p:sp>
+        <p:nvSpPr>
+          <p:cNvPr id="9" name="Shape 5"/>
+          <p:cNvSpPr/>
+          <p:nvPr/>
+        </p:nvSpPr>
+        <p:spPr>
+          <a:xfrm>
+            <a:off x="6172200" y="1600200"/>
+            <a:ext cx="5074920" cy="1783080"/>
+          </a:xfrm>
+          <a:prstGeom prst="roundRect">
+            <a:avLst>
+              <a:gd name="adj" fmla="val 6154"/>
+            </a:avLst>
+          </a:prstGeom>
+          <a:solidFill>
+            <a:srgbClr val="F2F5FA"/>
+          </a:solidFill>
+          <a:effectLst>
+            <a:outerShdw blurRad="76200" dist="25400" dir="5400000" algn="bl" rotWithShape="0">
+              <a:srgbClr val="000000">
+                <a:alpha val="8000"/>
+              </a:srgbClr>
+            </a:outerShdw>
+          </a:effectLst>
+        </p:spPr>
+      </p:sp>
+      <p:pic>
+        <p:nvPicPr>
+          <p:cNvPr id="10" name="Image 2" descr="/home/claude/work/assets/badge_gradient.png"/>
+          <p:cNvPicPr>
+            <a:picLocks noChangeAspect="1"/>
+          </p:cNvPicPr>
+          <p:nvPr/>
+        </p:nvPicPr>
+        <p:blipFill>
+          <a:blip r:embed="rId2"/>
+          <a:stretch>
+            <a:fillRect/>
+          </a:stretch>
+        </p:blipFill>
+        <p:spPr>
+          <a:xfrm>
+            <a:off x="6428232" y="1828800"/>
+            <a:ext cx="457200" cy="457200"/>
+          </a:xfrm>
+          <a:prstGeom prst="rect">
+            <a:avLst/>
+          </a:prstGeom>
+          <a:effectLst>
+            <a:outerShdw blurRad="76200" dist="25400" dir="5400000" algn="bl" rotWithShape="0">
+              <a:srgbClr val="3A2E6E">
+                <a:alpha val="30000"/>
+              </a:srgbClr>
+            </a:outerShdw>
+          </a:effectLst>
+        </p:spPr>
+      </p:pic>
+      <p:sp>
+        <p:nvSpPr>
+          <p:cNvPr id="11" name="Text 6"/>
+          <p:cNvSpPr txBox="1"/>
+          <p:nvPr/>
+        </p:nvSpPr>
+        <p:spPr>
+          <a:xfrm>
+            <a:off x="6428232" y="1828800"/>
+            <a:ext cx="457200" cy="457200"/>
+          </a:xfrm>
+          <a:prstGeom prst="rect">
+            <a:avLst/>
+          </a:prstGeom>
+          <a:noFill/>
+        </p:spPr>
+        <p:txBody>
+          <a:bodyPr wrap="square" lIns="0" tIns="0" rIns="0" bIns="0" rtlCol="0" anchor="ctr"/>
+          <a:lstStyle/>
+          <a:p>
+            <a:pPr marL="0" indent="0" algn="ctr">
+              <a:buNone/>
+            </a:pPr>
+            <a:r>
+              <a:rPr lang="en-US" sz="1600" b="1" dirty="0">
+                <a:solidFill>
+                  <a:srgbClr val="FFFFFF"/>
+                </a:solidFill>
+                <a:latin typeface="Arial" panose="020B0604020202020204" pitchFamily="34" charset="0"/>
+                <a:ea typeface="Arial" panose="020B0604020202020204" pitchFamily="34" charset="-122"/>
+                <a:cs typeface="Arial" panose="020B0604020202020204" pitchFamily="34" charset="-120"/>
+              </a:rPr>
+              <a:t>2</a:t>
+            </a:r>
+            <a:endParaRPr lang="en-US" sz="1600" dirty="0"/>
+          </a:p>
+        </p:txBody>
+      </p:sp>
+      <p:sp>
+        <p:nvSpPr>
+          <p:cNvPr id="12" name="Text 7"/>
+          <p:cNvSpPr txBox="1"/>
+          <p:nvPr/>
+        </p:nvSpPr>
+        <p:spPr>
+          <a:xfrm>
+            <a:off x="7068312" y="1801368"/>
+            <a:ext cx="3931920" cy="457200"/>
+          </a:xfrm>
+          <a:prstGeom prst="rect">
+            <a:avLst/>
+          </a:prstGeom>
+          <a:noFill/>
+        </p:spPr>
+        <p:txBody>
+          <a:bodyPr wrap="square" lIns="0" tIns="0" rIns="0" bIns="0" rtlCol="0" anchor="ctr"/>
+          <a:lstStyle/>
+          <a:p>
+            <a:pPr marL="0" indent="0">
+              <a:buNone/>
+            </a:pPr>
+            <a:r>
+              <a:rPr lang="en-US" sz="1600" b="1" dirty="0">
+                <a:solidFill>
+                  <a:srgbClr val="00081D"/>
+                </a:solidFill>
+                <a:latin typeface="Arial" panose="020B0604020202020204" pitchFamily="34" charset="0"/>
+                <a:ea typeface="Arial" panose="020B0604020202020204" pitchFamily="34" charset="-122"/>
+                <a:cs typeface="Arial" panose="020B0604020202020204" pitchFamily="34" charset="-120"/>
+              </a:rPr>
+              <a:t>Account &amp; case numbers</a:t>
+            </a:r>
+            <a:endParaRPr lang="en-US" sz="1600" dirty="0"/>
+          </a:p>
+        </p:txBody>
+      </p:sp>
+      <p:sp>
+        <p:nvSpPr>
+          <p:cNvPr id="13" name="Text 8"/>
+          <p:cNvSpPr txBox="1"/>
+          <p:nvPr/>
+        </p:nvSpPr>
+        <p:spPr>
+          <a:xfrm>
+            <a:off x="6464808" y="2331720"/>
+            <a:ext cx="4489704" cy="868680"/>
+          </a:xfrm>
+          <a:prstGeom prst="rect">
+            <a:avLst/>
+          </a:prstGeom>
+          <a:noFill/>
+        </p:spPr>
+        <p:txBody>
+          <a:bodyPr wrap="square" lIns="0" tIns="0" rIns="0" bIns="0" rtlCol="0" anchor="ctr"/>
+          <a:lstStyle/>
+          <a:p>
+            <a:pPr marL="0" indent="0">
+              <a:lnSpc>
+                <a:spcPts val="1550"/>
+              </a:lnSpc>
+              <a:buNone/>
+            </a:pPr>
+            <a:r>
+              <a:rPr lang="en-US" sz="1150" dirty="0">
+                <a:solidFill>
+                  <a:srgbClr val="56606E"/>
+                </a:solidFill>
+                <a:latin typeface="Arial" panose="020B0604020202020204" pitchFamily="34" charset="0"/>
+                <a:ea typeface="Arial" panose="020B0604020202020204" pitchFamily="34" charset="-122"/>
+                <a:cs typeface="Arial" panose="020B0604020202020204" pitchFamily="34" charset="-120"/>
+              </a:rPr>
+              <a:t>Account IDs, case references, policy numbers — anything that maps back to a specific record.</a:t>
+            </a:r>
+            <a:endParaRPr lang="en-US" sz="1150" dirty="0"/>
+          </a:p>
+        </p:txBody>
+      </p:sp>
+      <p:sp>
+        <p:nvSpPr>
+          <p:cNvPr id="14" name="Shape 9"/>
+          <p:cNvSpPr/>
+          <p:nvPr/>
+        </p:nvSpPr>
+        <p:spPr>
+          <a:xfrm>
+            <a:off x="640080" y="3611880"/>
+            <a:ext cx="5074920" cy="1783080"/>
+          </a:xfrm>
+          <a:prstGeom prst="roundRect">
+            <a:avLst>
+              <a:gd name="adj" fmla="val 6154"/>
+            </a:avLst>
+          </a:prstGeom>
+          <a:solidFill>
+            <a:srgbClr val="F2F5FA"/>
+          </a:solidFill>
+          <a:effectLst>
+            <a:outerShdw blurRad="76200" dist="25400" dir="5400000" algn="bl" rotWithShape="0">
+              <a:srgbClr val="000000">
+                <a:alpha val="8000"/>
+              </a:srgbClr>
+            </a:outerShdw>
+          </a:effectLst>
+        </p:spPr>
+      </p:sp>
+      <p:pic>
+        <p:nvPicPr>
+          <p:cNvPr id="15" name="Image 3" descr="/home/claude/work/assets/badge_gradient.png"/>
+          <p:cNvPicPr>
+            <a:picLocks noChangeAspect="1"/>
+          </p:cNvPicPr>
+          <p:nvPr/>
+        </p:nvPicPr>
+        <p:blipFill>
+          <a:blip r:embed="rId2"/>
+          <a:stretch>
+            <a:fillRect/>
+          </a:stretch>
+        </p:blipFill>
+        <p:spPr>
+          <a:xfrm>
+            <a:off x="896112" y="3840480"/>
+            <a:ext cx="457200" cy="457200"/>
+          </a:xfrm>
+          <a:prstGeom prst="rect">
+            <a:avLst/>
+          </a:prstGeom>
+          <a:effectLst>
+            <a:outerShdw blurRad="76200" dist="25400" dir="5400000" algn="bl" rotWithShape="0">
+              <a:srgbClr val="3A2E6E">
+                <a:alpha val="30000"/>
+              </a:srgbClr>
+            </a:outerShdw>
+          </a:effectLst>
+        </p:spPr>
+      </p:pic>
+      <p:sp>
+        <p:nvSpPr>
+          <p:cNvPr id="16" name="Text 10"/>
+          <p:cNvSpPr txBox="1"/>
+          <p:nvPr/>
+        </p:nvSpPr>
+        <p:spPr>
+          <a:xfrm>
+            <a:off x="896112" y="3840480"/>
+            <a:ext cx="457200" cy="457200"/>
+          </a:xfrm>
+          <a:prstGeom prst="rect">
+            <a:avLst/>
+          </a:prstGeom>
+          <a:noFill/>
+        </p:spPr>
+        <p:txBody>
+          <a:bodyPr wrap="square" lIns="0" tIns="0" rIns="0" bIns="0" rtlCol="0" anchor="ctr"/>
+          <a:lstStyle/>
+          <a:p>
+            <a:pPr marL="0" indent="0" algn="ctr">
+              <a:buNone/>
+            </a:pPr>
+            <a:r>
+              <a:rPr lang="en-US" sz="1600" b="1" dirty="0">
+                <a:solidFill>
+                  <a:srgbClr val="FFFFFF"/>
+                </a:solidFill>
+                <a:latin typeface="Arial" panose="020B0604020202020204" pitchFamily="34" charset="0"/>
+                <a:ea typeface="Arial" panose="020B0604020202020204" pitchFamily="34" charset="-122"/>
+                <a:cs typeface="Arial" panose="020B0604020202020204" pitchFamily="34" charset="-120"/>
+              </a:rPr>
+              <a:t>3</a:t>
+            </a:r>
+            <a:endParaRPr lang="en-US" sz="1600" dirty="0"/>
+          </a:p>
+        </p:txBody>
+      </p:sp>
+      <p:sp>
+        <p:nvSpPr>
+          <p:cNvPr id="17" name="Text 11"/>
+          <p:cNvSpPr txBox="1"/>
+          <p:nvPr/>
+        </p:nvSpPr>
+        <p:spPr>
+          <a:xfrm>
+            <a:off x="1536192" y="3813048"/>
+            <a:ext cx="3931920" cy="457200"/>
+          </a:xfrm>
+          <a:prstGeom prst="rect">
+            <a:avLst/>
+          </a:prstGeom>
+          <a:noFill/>
+        </p:spPr>
+        <p:txBody>
+          <a:bodyPr wrap="square" lIns="0" tIns="0" rIns="0" bIns="0" rtlCol="0" anchor="ctr"/>
+          <a:lstStyle/>
+          <a:p>
+            <a:pPr marL="0" indent="0">
+              <a:buNone/>
+            </a:pPr>
+            <a:r>
+              <a:rPr lang="en-US" sz="1600" b="1" dirty="0">
+                <a:solidFill>
+                  <a:srgbClr val="00081D"/>
+                </a:solidFill>
+                <a:latin typeface="Arial" panose="020B0604020202020204" pitchFamily="34" charset="0"/>
+                <a:ea typeface="Arial" panose="020B0604020202020204" pitchFamily="34" charset="-122"/>
+                <a:cs typeface="Arial" panose="020B0604020202020204" pitchFamily="34" charset="-120"/>
+              </a:rPr>
+              <a:t>Exact financial figures</a:t>
+            </a:r>
+            <a:endParaRPr lang="en-US" sz="1600" dirty="0"/>
+          </a:p>
+        </p:txBody>
+      </p:sp>
+      <p:sp>
+        <p:nvSpPr>
+          <p:cNvPr id="18" name="Text 12"/>
+          <p:cNvSpPr txBox="1"/>
+          <p:nvPr/>
+        </p:nvSpPr>
+        <p:spPr>
+          <a:xfrm>
+            <a:off x="932688" y="4343400"/>
+            <a:ext cx="4489704" cy="868680"/>
+          </a:xfrm>
+          <a:prstGeom prst="rect">
+            <a:avLst/>
+          </a:prstGeom>
+          <a:noFill/>
+        </p:spPr>
+        <p:txBody>
+          <a:bodyPr wrap="square" lIns="0" tIns="0" rIns="0" bIns="0" rtlCol="0" anchor="ctr"/>
+          <a:lstStyle/>
+          <a:p>
+            <a:pPr marL="0" indent="0">
+              <a:lnSpc>
+                <a:spcPts val="1550"/>
+              </a:lnSpc>
+              <a:buNone/>
+            </a:pPr>
+            <a:r>
+              <a:rPr lang="en-US" sz="1150" dirty="0">
+                <a:solidFill>
+                  <a:srgbClr val="56606E"/>
+                </a:solidFill>
+                <a:latin typeface="Arial" panose="020B0604020202020204" pitchFamily="34" charset="0"/>
+                <a:ea typeface="Arial" panose="020B0604020202020204" pitchFamily="34" charset="-122"/>
+                <a:cs typeface="Arial" panose="020B0604020202020204" pitchFamily="34" charset="-120"/>
+              </a:rPr>
+              <a:t>Real balances, amounts, dates or valuations — round them or describe them instead.</a:t>
+            </a:r>
+            <a:endParaRPr lang="en-US" sz="1150" dirty="0"/>
+          </a:p>
+        </p:txBody>
+      </p:sp>
+      <p:sp>
+        <p:nvSpPr>
+          <p:cNvPr id="19" name="Shape 13"/>
+          <p:cNvSpPr/>
+          <p:nvPr/>
+        </p:nvSpPr>
+        <p:spPr>
+          <a:xfrm>
+            <a:off x="6172200" y="3611880"/>
+            <a:ext cx="5074920" cy="1783080"/>
+          </a:xfrm>
+          <a:prstGeom prst="roundRect">
+            <a:avLst>
+              <a:gd name="adj" fmla="val 6154"/>
+            </a:avLst>
+          </a:prstGeom>
+          <a:solidFill>
+            <a:srgbClr val="F2F5FA"/>
+          </a:solidFill>
+          <a:effectLst>
+            <a:outerShdw blurRad="76200" dist="25400" dir="5400000" algn="bl" rotWithShape="0">
+              <a:srgbClr val="000000">
+                <a:alpha val="8000"/>
+              </a:srgbClr>
+            </a:outerShdw>
+          </a:effectLst>
+        </p:spPr>
+      </p:sp>
+      <p:pic>
+        <p:nvPicPr>
+          <p:cNvPr id="20" name="Image 4" descr="/home/claude/work/assets/badge_gradient.png"/>
+          <p:cNvPicPr>
+            <a:picLocks noChangeAspect="1"/>
+          </p:cNvPicPr>
+          <p:nvPr/>
+        </p:nvPicPr>
+        <p:blipFill>
+          <a:blip r:embed="rId2"/>
+          <a:stretch>
+            <a:fillRect/>
+          </a:stretch>
+        </p:blipFill>
+        <p:spPr>
+          <a:xfrm>
+            <a:off x="6428232" y="3840480"/>
+            <a:ext cx="457200" cy="457200"/>
+          </a:xfrm>
+          <a:prstGeom prst="rect">
+            <a:avLst/>
+          </a:prstGeom>
+          <a:effectLst>
+            <a:outerShdw blurRad="76200" dist="25400" dir="5400000" algn="bl" rotWithShape="0">
+              <a:srgbClr val="3A2E6E">
+                <a:alpha val="30000"/>
+              </a:srgbClr>
+            </a:outerShdw>
+          </a:effectLst>
+        </p:spPr>
+      </p:pic>
+      <p:sp>
+        <p:nvSpPr>
+          <p:cNvPr id="21" name="Text 14"/>
+          <p:cNvSpPr txBox="1"/>
+          <p:nvPr/>
+        </p:nvSpPr>
+        <p:spPr>
+          <a:xfrm>
+            <a:off x="6428232" y="3840480"/>
+            <a:ext cx="457200" cy="457200"/>
+          </a:xfrm>
+          <a:prstGeom prst="rect">
+            <a:avLst/>
+          </a:prstGeom>
+          <a:noFill/>
+        </p:spPr>
+        <p:txBody>
+          <a:bodyPr wrap="square" lIns="0" tIns="0" rIns="0" bIns="0" rtlCol="0" anchor="ctr"/>
+          <a:lstStyle/>
+          <a:p>
+            <a:pPr marL="0" indent="0" algn="ctr">
+              <a:buNone/>
+            </a:pPr>
+            <a:r>
+              <a:rPr lang="en-US" sz="1600" b="1" dirty="0">
+                <a:solidFill>
+                  <a:srgbClr val="FFFFFF"/>
+                </a:solidFill>
+                <a:latin typeface="Arial" panose="020B0604020202020204" pitchFamily="34" charset="0"/>
+                <a:ea typeface="Arial" panose="020B0604020202020204" pitchFamily="34" charset="-122"/>
+                <a:cs typeface="Arial" panose="020B0604020202020204" pitchFamily="34" charset="-120"/>
+              </a:rPr>
+              <a:t>4</a:t>
+            </a:r>
+            <a:endParaRPr lang="en-US" sz="1600" dirty="0"/>
+          </a:p>
+        </p:txBody>
+      </p:sp>
+      <p:sp>
+        <p:nvSpPr>
+          <p:cNvPr id="22" name="Text 15"/>
+          <p:cNvSpPr txBox="1"/>
+          <p:nvPr/>
+        </p:nvSpPr>
+        <p:spPr>
+          <a:xfrm>
+            <a:off x="7068312" y="3813048"/>
+            <a:ext cx="3931920" cy="457200"/>
+          </a:xfrm>
+          <a:prstGeom prst="rect">
+            <a:avLst/>
+          </a:prstGeom>
+          <a:noFill/>
+        </p:spPr>
+        <p:txBody>
+          <a:bodyPr wrap="square" lIns="0" tIns="0" rIns="0" bIns="0" rtlCol="0" anchor="ctr"/>
+          <a:lstStyle/>
+          <a:p>
+            <a:pPr marL="0" indent="0">
+              <a:buNone/>
+            </a:pPr>
+            <a:r>
+              <a:rPr lang="en-US" sz="1600" b="1" dirty="0">
+                <a:solidFill>
+                  <a:srgbClr val="00081D"/>
+                </a:solidFill>
+                <a:latin typeface="Arial" panose="020B0604020202020204" pitchFamily="34" charset="0"/>
+                <a:ea typeface="Arial" panose="020B0604020202020204" pitchFamily="34" charset="-122"/>
+                <a:cs typeface="Arial" panose="020B0604020202020204" pitchFamily="34" charset="-120"/>
+              </a:rPr>
+              <a:t>Credentials &amp; internal info</a:t>
+            </a:r>
+            <a:endParaRPr lang="en-US" sz="1600" dirty="0"/>
+          </a:p>
+        </p:txBody>
+      </p:sp>
+      <p:sp>
+        <p:nvSpPr>
+          <p:cNvPr id="23" name="Text 16"/>
+          <p:cNvSpPr txBox="1"/>
+          <p:nvPr/>
+        </p:nvSpPr>
+        <p:spPr>
+          <a:xfrm>
+            <a:off x="6464808" y="4343400"/>
+            <a:ext cx="4489704" cy="868680"/>
+          </a:xfrm>
+          <a:prstGeom prst="rect">
+            <a:avLst/>
+          </a:prstGeom>
+          <a:noFill/>
+        </p:spPr>
+        <p:txBody>
+          <a:bodyPr wrap="square" lIns="0" tIns="0" rIns="0" bIns="0" rtlCol="0" anchor="ctr"/>
+          <a:lstStyle/>
+          <a:p>
+            <a:pPr marL="0" indent="0">
+              <a:lnSpc>
+                <a:spcPts val="1550"/>
+              </a:lnSpc>
+              <a:buNone/>
+            </a:pPr>
+            <a:r>
+              <a:rPr lang="en-US" sz="1150" dirty="0">
+                <a:solidFill>
+                  <a:srgbClr val="56606E"/>
+                </a:solidFill>
+                <a:latin typeface="Arial" panose="020B0604020202020204" pitchFamily="34" charset="0"/>
+                <a:ea typeface="Arial" panose="020B0604020202020204" pitchFamily="34" charset="-122"/>
+                <a:cs typeface="Arial" panose="020B0604020202020204" pitchFamily="34" charset="-120"/>
+              </a:rPr>
+              <a:t>Logins, passwords, API keys, and anything not yet public: deals, strategy, unreleased results.</a:t>
+            </a:r>
+            <a:endParaRPr lang="en-US" sz="1150" dirty="0"/>
+          </a:p>
+        </p:txBody>
+      </p:sp>
+      <p:sp>
+        <p:nvSpPr>
+          <p:cNvPr id="24" name="Shape 17"/>
+          <p:cNvSpPr/>
+          <p:nvPr/>
+        </p:nvSpPr>
+        <p:spPr>
+          <a:xfrm>
+            <a:off x="640080" y="5623560"/>
+            <a:ext cx="10607040" cy="1005840"/>
+          </a:xfrm>
+          <a:prstGeom prst="roundRect">
+            <a:avLst>
+              <a:gd name="adj" fmla="val 10909"/>
+            </a:avLst>
+          </a:prstGeom>
+          <a:solidFill>
+            <a:srgbClr val="FEEDED"/>
+          </a:solidFill>
+          <a:effectLst>
+            <a:outerShdw blurRad="101600" dist="38100" dir="5400000" algn="bl" rotWithShape="0">
+              <a:srgbClr val="1A2B33">
+                <a:alpha val="12000"/>
+              </a:srgbClr>
+            </a:outerShdw>
+          </a:effectLst>
+        </p:spPr>
+      </p:sp>
+      <p:sp>
+        <p:nvSpPr>
+          <p:cNvPr id="25" name="Shape 18"/>
+          <p:cNvSpPr/>
+          <p:nvPr/>
+        </p:nvSpPr>
+        <p:spPr>
+          <a:xfrm>
+            <a:off x="896112" y="5879592"/>
+            <a:ext cx="457200" cy="457200"/>
+          </a:xfrm>
+          <a:prstGeom prst="ellipse">
+            <a:avLst/>
+          </a:prstGeom>
+          <a:solidFill>
+            <a:srgbClr val="FE5A5B"/>
+          </a:solidFill>
+        </p:spPr>
+      </p:sp>
+      <p:sp>
+        <p:nvSpPr>
+          <p:cNvPr id="26" name="Text 19"/>
+          <p:cNvSpPr txBox="1"/>
+          <p:nvPr/>
+        </p:nvSpPr>
+        <p:spPr>
+          <a:xfrm>
+            <a:off x="896112" y="5879592"/>
+            <a:ext cx="457200" cy="457200"/>
+          </a:xfrm>
+          <a:prstGeom prst="rect">
+            <a:avLst/>
+          </a:prstGeom>
+          <a:noFill/>
+        </p:spPr>
+        <p:txBody>
+          <a:bodyPr wrap="square" lIns="0" tIns="0" rIns="0" bIns="0" rtlCol="0" anchor="ctr"/>
+          <a:lstStyle/>
+          <a:p>
+            <a:pPr marL="0" indent="0" algn="ctr">
+              <a:buNone/>
+            </a:pPr>
+            <a:r>
+              <a:rPr lang="en-US" sz="1600" b="1" dirty="0">
+                <a:solidFill>
+                  <a:srgbClr val="FFFFFF"/>
+                </a:solidFill>
+                <a:latin typeface="Arial" panose="020B0604020202020204" pitchFamily="34" charset="0"/>
+                <a:ea typeface="Arial" panose="020B0604020202020204" pitchFamily="34" charset="-122"/>
+                <a:cs typeface="Arial" panose="020B0604020202020204" pitchFamily="34" charset="-120"/>
+              </a:rPr>
+              <a:t>!</a:t>
+            </a:r>
+            <a:endParaRPr lang="en-US" sz="1600" dirty="0"/>
+          </a:p>
+        </p:txBody>
+      </p:sp>
+      <p:sp>
+        <p:nvSpPr>
+          <p:cNvPr id="27" name="Text 20"/>
+          <p:cNvSpPr txBox="1"/>
+          <p:nvPr/>
+        </p:nvSpPr>
+        <p:spPr>
+          <a:xfrm>
+            <a:off x="1536192" y="5760720"/>
+            <a:ext cx="2743200" cy="731520"/>
+          </a:xfrm>
+          <a:prstGeom prst="rect">
+            <a:avLst/>
+          </a:prstGeom>
+          <a:noFill/>
+        </p:spPr>
+        <p:txBody>
+          <a:bodyPr wrap="square" lIns="0" tIns="0" rIns="0" bIns="0" rtlCol="0" anchor="ctr"/>
+          <a:lstStyle/>
+          <a:p>
+            <a:pPr marL="0" indent="0">
+              <a:buNone/>
+            </a:pPr>
+            <a:r>
+              <a:rPr lang="en-US" sz="1600" b="1" dirty="0">
+                <a:solidFill>
+                  <a:srgbClr val="FE5A5B"/>
+                </a:solidFill>
+                <a:latin typeface="Arial" panose="020B0604020202020204" pitchFamily="34" charset="0"/>
+                <a:ea typeface="Arial" panose="020B0604020202020204" pitchFamily="34" charset="-122"/>
+                <a:cs typeface="Arial" panose="020B0604020202020204" pitchFamily="34" charset="-120"/>
+              </a:rPr>
+              <a:t>Rule of thumb</a:t>
+            </a:r>
+            <a:endParaRPr lang="en-US" sz="1600" dirty="0"/>
+          </a:p>
+        </p:txBody>
+      </p:sp>
+      <p:sp>
+        <p:nvSpPr>
+          <p:cNvPr id="28" name="Text 21"/>
+          <p:cNvSpPr txBox="1"/>
+          <p:nvPr/>
+        </p:nvSpPr>
+        <p:spPr>
+          <a:xfrm>
+            <a:off x="4480560" y="5623560"/>
+            <a:ext cx="6492240" cy="1005840"/>
+          </a:xfrm>
+          <a:prstGeom prst="rect">
+            <a:avLst/>
+          </a:prstGeom>
+          <a:noFill/>
+        </p:spPr>
+        <p:txBody>
+          <a:bodyPr wrap="square" lIns="0" tIns="0" rIns="0" bIns="0" rtlCol="0" anchor="ctr"/>
+          <a:lstStyle/>
+          <a:p>
+            <a:pPr marL="0" indent="0">
+              <a:lnSpc>
+                <a:spcPts val="1550"/>
+              </a:lnSpc>
+              <a:buNone/>
+            </a:pPr>
+            <a:r>
+              <a:rPr lang="en-US" sz="1200" dirty="0">
+                <a:solidFill>
+                  <a:srgbClr val="0B1B33"/>
+                </a:solidFill>
+                <a:latin typeface="Arial" panose="020B0604020202020204" pitchFamily="34" charset="0"/>
+                <a:ea typeface="Arial" panose="020B0604020202020204" pitchFamily="34" charset="-122"/>
+                <a:cs typeface="Arial" panose="020B0604020202020204" pitchFamily="34" charset="-120"/>
+              </a:rPr>
+              <a:t>If you wouldn't post it on the company intranet for everyone to see, don't paste it into an AI chat tool either.</a:t>
+            </a:r>
+            <a:endParaRPr lang="en-US" sz="1200" dirty="0"/>
+          </a:p>
+        </p:txBody>
+      </p:sp>
+      <p:sp>
+        <p:nvSpPr>
+          <p:cNvPr id="29" name="Text 22"/>
+          <p:cNvSpPr txBox="1"/>
+          <p:nvPr/>
+        </p:nvSpPr>
+        <p:spPr>
+          <a:xfrm>
+            <a:off x="11320272" y="6556248"/>
+            <a:ext cx="457200" cy="256032"/>
+          </a:xfrm>
+          <a:prstGeom prst="rect">
+            <a:avLst/>
+          </a:prstGeom>
+          <a:noFill/>
+        </p:spPr>
+        <p:txBody>
+          <a:bodyPr wrap="square" lIns="0" tIns="0" rIns="0" bIns="0" rtlCol="0" anchor="ctr"/>
+          <a:lstStyle/>
+          <a:p>
+            <a:pPr marL="0" indent="0" algn="r">
+              <a:buNone/>
+            </a:pPr>
+            <a:r>
+              <a:rPr lang="en-US" sz="900" dirty="0">
+                <a:solidFill>
+                  <a:srgbClr val="8FA3B8"/>
+                </a:solidFill>
+                <a:latin typeface="Arial" panose="020B0604020202020204" pitchFamily="34" charset="0"/>
+                <a:ea typeface="Arial" panose="020B0604020202020204" pitchFamily="34" charset="-122"/>
+                <a:cs typeface="Arial" panose="020B0604020202020204" pitchFamily="34" charset="-120"/>
+              </a:rPr>
+              <a:t>9</a:t>
+            </a:r>
+            <a:endParaRPr lang="en-US" sz="900" dirty="0"/>
           </a:p>
         </p:txBody>
       </p:sp>
@@ -9719,7 +10721,7 @@
                 <a:ea typeface="Arial" panose="020B0604020202020204" pitchFamily="34" charset="-122"/>
                 <a:cs typeface="Arial" panose="020B0604020202020204" pitchFamily="34" charset="-120"/>
               </a:rPr>
-              <a:t>9</a:t>
+              <a:t>10</a:t>
             </a:r>
             <a:endParaRPr lang="en-US" sz="900" dirty="0"/>
           </a:p>

</xml_diff>

<commit_message>
Fold general sensitive-data categories into slide 8 instead of a separate slide
</commit_message>
<xml_diff>
--- a/AI At Work.pptx
+++ b/AI At Work.pptx
@@ -16,7 +16,6 @@
     <p:sldId id="260" r:id="rId9"/>
     <p:sldId id="261" r:id="rId10"/>
     <p:sldId id="262" r:id="rId11"/>
-    <p:sldId id="268" r:id="rId18"/>
     <p:sldId id="263" r:id="rId12"/>
     <p:sldId id="264" r:id="rId13"/>
     <p:sldId id="266" r:id="rId14"/>
@@ -2697,7 +2696,7 @@
                 <a:ea typeface="Arial" panose="020B0604020202020204" pitchFamily="34" charset="-122"/>
                 <a:cs typeface="Arial" panose="020B0604020202020204" pitchFamily="34" charset="-120"/>
               </a:rPr>
-              <a:t>11</a:t>
+              <a:t>10</a:t>
             </a:r>
             <a:endParaRPr lang="en-US" sz="900" dirty="0"/>
           </a:p>
@@ -2798,1007 +2797,6 @@
               <a:t>If you were wondering, yes, this presentation was made with AI help.</a:t>
             </a:r>
             <a:endParaRPr lang="en-US" sz="1800" dirty="0"/>
-          </a:p>
-        </p:txBody>
-      </p:sp>
-    </p:spTree>
-  </p:cSld>
-  <p:clrMapOvr>
-    <a:masterClrMapping/>
-  </p:clrMapOvr>
-</p:sld>
-</file>
-
-<file path=ppt/slides/slide12.xml><?xml version="1.0" encoding="utf-8"?>
-<p:sld xmlns:a="http://schemas.openxmlformats.org/drawingml/2006/main" xmlns:r="http://schemas.openxmlformats.org/officeDocument/2006/relationships" xmlns:p="http://schemas.openxmlformats.org/presentationml/2006/main">
-  <p:cSld>
-    <p:bg>
-      <p:bgPr>
-        <a:solidFill>
-          <a:srgbClr val="FFFFFF"/>
-        </a:solidFill>
-        <a:effectLst/>
-      </p:bgPr>
-    </p:bg>
-    <p:spTree>
-      <p:nvGrpSpPr>
-        <p:cNvPr id="1" name=""/>
-        <p:cNvGrpSpPr/>
-        <p:nvPr/>
-      </p:nvGrpSpPr>
-      <p:grpSpPr>
-        <a:xfrm>
-          <a:off x="0" y="0"/>
-          <a:ext cx="0" cy="0"/>
-          <a:chOff x="0" y="0"/>
-          <a:chExt cx="0" cy="0"/>
-        </a:xfrm>
-      </p:grpSpPr>
-      <p:pic>
-        <p:nvPicPr>
-          <p:cNvPr id="2" name="Image 0" descr="/home/claude/work/assets/tpl_content.jpg"/>
-          <p:cNvPicPr>
-            <a:picLocks noChangeAspect="1"/>
-          </p:cNvPicPr>
-          <p:nvPr/>
-        </p:nvPicPr>
-        <p:blipFill>
-          <a:blip r:embed="rId1"/>
-          <a:stretch>
-            <a:fillRect/>
-          </a:stretch>
-        </p:blipFill>
-        <p:spPr>
-          <a:xfrm>
-            <a:off x="0" y="0"/>
-            <a:ext cx="12188952" cy="6858000"/>
-          </a:xfrm>
-          <a:prstGeom prst="rect">
-            <a:avLst/>
-          </a:prstGeom>
-        </p:spPr>
-      </p:pic>
-      <p:sp>
-        <p:nvSpPr>
-          <p:cNvPr id="3" name="Text 0"/>
-          <p:cNvSpPr txBox="1"/>
-          <p:nvPr/>
-        </p:nvSpPr>
-        <p:spPr>
-          <a:xfrm>
-            <a:off x="320040" y="219456"/>
-            <a:ext cx="10607040" cy="731520"/>
-          </a:xfrm>
-          <a:prstGeom prst="rect">
-            <a:avLst/>
-          </a:prstGeom>
-          <a:noFill/>
-        </p:spPr>
-        <p:txBody>
-          <a:bodyPr wrap="square" lIns="0" tIns="0" rIns="0" bIns="0" rtlCol="0" anchor="ctr"/>
-          <a:lstStyle/>
-          <a:p>
-            <a:pPr marL="0" indent="0" algn="ctr">
-              <a:buNone/>
-            </a:pPr>
-            <a:r>
-              <a:rPr lang="en-US" sz="3000" dirty="0">
-                <a:solidFill>
-                  <a:srgbClr val="FFFFFF"/>
-                </a:solidFill>
-                <a:latin typeface="Arial" panose="020B0604020202020204" pitchFamily="34" charset="0"/>
-                <a:ea typeface="Arial" panose="020B0604020202020204" pitchFamily="34" charset="-122"/>
-                <a:cs typeface="Arial" panose="020B0604020202020204" pitchFamily="34" charset="-120"/>
-              </a:rPr>
-              <a:t>What generally counts as sensitive</a:t>
-            </a:r>
-            <a:endParaRPr lang="en-US" sz="3000" dirty="0"/>
-          </a:p>
-        </p:txBody>
-      </p:sp>
-      <p:sp>
-        <p:nvSpPr>
-          <p:cNvPr id="4" name="Shape 1"/>
-          <p:cNvSpPr/>
-          <p:nvPr/>
-        </p:nvSpPr>
-        <p:spPr>
-          <a:xfrm>
-            <a:off x="640080" y="1600200"/>
-            <a:ext cx="5074920" cy="1783080"/>
-          </a:xfrm>
-          <a:prstGeom prst="roundRect">
-            <a:avLst>
-              <a:gd name="adj" fmla="val 6154"/>
-            </a:avLst>
-          </a:prstGeom>
-          <a:solidFill>
-            <a:srgbClr val="F2F5FA"/>
-          </a:solidFill>
-          <a:effectLst>
-            <a:outerShdw blurRad="76200" dist="25400" dir="5400000" algn="bl" rotWithShape="0">
-              <a:srgbClr val="000000">
-                <a:alpha val="8000"/>
-              </a:srgbClr>
-            </a:outerShdw>
-          </a:effectLst>
-        </p:spPr>
-      </p:sp>
-      <p:pic>
-        <p:nvPicPr>
-          <p:cNvPr id="5" name="Image 1" descr="/home/claude/work/assets/badge_gradient.png"/>
-          <p:cNvPicPr>
-            <a:picLocks noChangeAspect="1"/>
-          </p:cNvPicPr>
-          <p:nvPr/>
-        </p:nvPicPr>
-        <p:blipFill>
-          <a:blip r:embed="rId2"/>
-          <a:stretch>
-            <a:fillRect/>
-          </a:stretch>
-        </p:blipFill>
-        <p:spPr>
-          <a:xfrm>
-            <a:off x="896112" y="1828800"/>
-            <a:ext cx="457200" cy="457200"/>
-          </a:xfrm>
-          <a:prstGeom prst="rect">
-            <a:avLst/>
-          </a:prstGeom>
-          <a:effectLst>
-            <a:outerShdw blurRad="76200" dist="25400" dir="5400000" algn="bl" rotWithShape="0">
-              <a:srgbClr val="3A2E6E">
-                <a:alpha val="30000"/>
-              </a:srgbClr>
-            </a:outerShdw>
-          </a:effectLst>
-        </p:spPr>
-      </p:pic>
-      <p:sp>
-        <p:nvSpPr>
-          <p:cNvPr id="6" name="Text 2"/>
-          <p:cNvSpPr txBox="1"/>
-          <p:nvPr/>
-        </p:nvSpPr>
-        <p:spPr>
-          <a:xfrm>
-            <a:off x="896112" y="1828800"/>
-            <a:ext cx="457200" cy="457200"/>
-          </a:xfrm>
-          <a:prstGeom prst="rect">
-            <a:avLst/>
-          </a:prstGeom>
-          <a:noFill/>
-        </p:spPr>
-        <p:txBody>
-          <a:bodyPr wrap="square" lIns="0" tIns="0" rIns="0" bIns="0" rtlCol="0" anchor="ctr"/>
-          <a:lstStyle/>
-          <a:p>
-            <a:pPr marL="0" indent="0" algn="ctr">
-              <a:buNone/>
-            </a:pPr>
-            <a:r>
-              <a:rPr lang="en-US" sz="1600" b="1" dirty="0">
-                <a:solidFill>
-                  <a:srgbClr val="FFFFFF"/>
-                </a:solidFill>
-                <a:latin typeface="Arial" panose="020B0604020202020204" pitchFamily="34" charset="0"/>
-                <a:ea typeface="Arial" panose="020B0604020202020204" pitchFamily="34" charset="-122"/>
-                <a:cs typeface="Arial" panose="020B0604020202020204" pitchFamily="34" charset="-120"/>
-              </a:rPr>
-              <a:t>1</a:t>
-            </a:r>
-            <a:endParaRPr lang="en-US" sz="1600" dirty="0"/>
-          </a:p>
-        </p:txBody>
-      </p:sp>
-      <p:sp>
-        <p:nvSpPr>
-          <p:cNvPr id="7" name="Text 3"/>
-          <p:cNvSpPr txBox="1"/>
-          <p:nvPr/>
-        </p:nvSpPr>
-        <p:spPr>
-          <a:xfrm>
-            <a:off x="1536192" y="1801368"/>
-            <a:ext cx="3931920" cy="457200"/>
-          </a:xfrm>
-          <a:prstGeom prst="rect">
-            <a:avLst/>
-          </a:prstGeom>
-          <a:noFill/>
-        </p:spPr>
-        <p:txBody>
-          <a:bodyPr wrap="square" lIns="0" tIns="0" rIns="0" bIns="0" rtlCol="0" anchor="ctr"/>
-          <a:lstStyle/>
-          <a:p>
-            <a:pPr marL="0" indent="0">
-              <a:buNone/>
-            </a:pPr>
-            <a:r>
-              <a:rPr lang="en-US" sz="1600" b="1" dirty="0">
-                <a:solidFill>
-                  <a:srgbClr val="00081D"/>
-                </a:solidFill>
-                <a:latin typeface="Arial" panose="020B0604020202020204" pitchFamily="34" charset="0"/>
-                <a:ea typeface="Arial" panose="020B0604020202020204" pitchFamily="34" charset="-122"/>
-                <a:cs typeface="Arial" panose="020B0604020202020204" pitchFamily="34" charset="-120"/>
-              </a:rPr>
-              <a:t>Client &amp; personal data</a:t>
-            </a:r>
-            <a:endParaRPr lang="en-US" sz="1600" dirty="0"/>
-          </a:p>
-        </p:txBody>
-      </p:sp>
-      <p:sp>
-        <p:nvSpPr>
-          <p:cNvPr id="8" name="Text 4"/>
-          <p:cNvSpPr txBox="1"/>
-          <p:nvPr/>
-        </p:nvSpPr>
-        <p:spPr>
-          <a:xfrm>
-            <a:off x="932688" y="2331720"/>
-            <a:ext cx="4489704" cy="868680"/>
-          </a:xfrm>
-          <a:prstGeom prst="rect">
-            <a:avLst/>
-          </a:prstGeom>
-          <a:noFill/>
-        </p:spPr>
-        <p:txBody>
-          <a:bodyPr wrap="square" lIns="0" tIns="0" rIns="0" bIns="0" rtlCol="0" anchor="ctr"/>
-          <a:lstStyle/>
-          <a:p>
-            <a:pPr marL="0" indent="0">
-              <a:lnSpc>
-                <a:spcPts val="1550"/>
-              </a:lnSpc>
-              <a:buNone/>
-            </a:pPr>
-            <a:r>
-              <a:rPr lang="en-US" sz="1150" dirty="0">
-                <a:solidFill>
-                  <a:srgbClr val="56606E"/>
-                </a:solidFill>
-                <a:latin typeface="Arial" panose="020B0604020202020204" pitchFamily="34" charset="0"/>
-                <a:ea typeface="Arial" panose="020B0604020202020204" pitchFamily="34" charset="-122"/>
-                <a:cs typeface="Arial" panose="020B0604020202020204" pitchFamily="34" charset="-120"/>
-              </a:rPr>
-              <a:t>Names, employers, contact details — anyone identifiable, colleague or client.</a:t>
-            </a:r>
-            <a:endParaRPr lang="en-US" sz="1150" dirty="0"/>
-          </a:p>
-        </p:txBody>
-      </p:sp>
-      <p:sp>
-        <p:nvSpPr>
-          <p:cNvPr id="9" name="Shape 5"/>
-          <p:cNvSpPr/>
-          <p:nvPr/>
-        </p:nvSpPr>
-        <p:spPr>
-          <a:xfrm>
-            <a:off x="6172200" y="1600200"/>
-            <a:ext cx="5074920" cy="1783080"/>
-          </a:xfrm>
-          <a:prstGeom prst="roundRect">
-            <a:avLst>
-              <a:gd name="adj" fmla="val 6154"/>
-            </a:avLst>
-          </a:prstGeom>
-          <a:solidFill>
-            <a:srgbClr val="F2F5FA"/>
-          </a:solidFill>
-          <a:effectLst>
-            <a:outerShdw blurRad="76200" dist="25400" dir="5400000" algn="bl" rotWithShape="0">
-              <a:srgbClr val="000000">
-                <a:alpha val="8000"/>
-              </a:srgbClr>
-            </a:outerShdw>
-          </a:effectLst>
-        </p:spPr>
-      </p:sp>
-      <p:pic>
-        <p:nvPicPr>
-          <p:cNvPr id="10" name="Image 2" descr="/home/claude/work/assets/badge_gradient.png"/>
-          <p:cNvPicPr>
-            <a:picLocks noChangeAspect="1"/>
-          </p:cNvPicPr>
-          <p:nvPr/>
-        </p:nvPicPr>
-        <p:blipFill>
-          <a:blip r:embed="rId2"/>
-          <a:stretch>
-            <a:fillRect/>
-          </a:stretch>
-        </p:blipFill>
-        <p:spPr>
-          <a:xfrm>
-            <a:off x="6428232" y="1828800"/>
-            <a:ext cx="457200" cy="457200"/>
-          </a:xfrm>
-          <a:prstGeom prst="rect">
-            <a:avLst/>
-          </a:prstGeom>
-          <a:effectLst>
-            <a:outerShdw blurRad="76200" dist="25400" dir="5400000" algn="bl" rotWithShape="0">
-              <a:srgbClr val="3A2E6E">
-                <a:alpha val="30000"/>
-              </a:srgbClr>
-            </a:outerShdw>
-          </a:effectLst>
-        </p:spPr>
-      </p:pic>
-      <p:sp>
-        <p:nvSpPr>
-          <p:cNvPr id="11" name="Text 6"/>
-          <p:cNvSpPr txBox="1"/>
-          <p:nvPr/>
-        </p:nvSpPr>
-        <p:spPr>
-          <a:xfrm>
-            <a:off x="6428232" y="1828800"/>
-            <a:ext cx="457200" cy="457200"/>
-          </a:xfrm>
-          <a:prstGeom prst="rect">
-            <a:avLst/>
-          </a:prstGeom>
-          <a:noFill/>
-        </p:spPr>
-        <p:txBody>
-          <a:bodyPr wrap="square" lIns="0" tIns="0" rIns="0" bIns="0" rtlCol="0" anchor="ctr"/>
-          <a:lstStyle/>
-          <a:p>
-            <a:pPr marL="0" indent="0" algn="ctr">
-              <a:buNone/>
-            </a:pPr>
-            <a:r>
-              <a:rPr lang="en-US" sz="1600" b="1" dirty="0">
-                <a:solidFill>
-                  <a:srgbClr val="FFFFFF"/>
-                </a:solidFill>
-                <a:latin typeface="Arial" panose="020B0604020202020204" pitchFamily="34" charset="0"/>
-                <a:ea typeface="Arial" panose="020B0604020202020204" pitchFamily="34" charset="-122"/>
-                <a:cs typeface="Arial" panose="020B0604020202020204" pitchFamily="34" charset="-120"/>
-              </a:rPr>
-              <a:t>2</a:t>
-            </a:r>
-            <a:endParaRPr lang="en-US" sz="1600" dirty="0"/>
-          </a:p>
-        </p:txBody>
-      </p:sp>
-      <p:sp>
-        <p:nvSpPr>
-          <p:cNvPr id="12" name="Text 7"/>
-          <p:cNvSpPr txBox="1"/>
-          <p:nvPr/>
-        </p:nvSpPr>
-        <p:spPr>
-          <a:xfrm>
-            <a:off x="7068312" y="1801368"/>
-            <a:ext cx="3931920" cy="457200"/>
-          </a:xfrm>
-          <a:prstGeom prst="rect">
-            <a:avLst/>
-          </a:prstGeom>
-          <a:noFill/>
-        </p:spPr>
-        <p:txBody>
-          <a:bodyPr wrap="square" lIns="0" tIns="0" rIns="0" bIns="0" rtlCol="0" anchor="ctr"/>
-          <a:lstStyle/>
-          <a:p>
-            <a:pPr marL="0" indent="0">
-              <a:buNone/>
-            </a:pPr>
-            <a:r>
-              <a:rPr lang="en-US" sz="1600" b="1" dirty="0">
-                <a:solidFill>
-                  <a:srgbClr val="00081D"/>
-                </a:solidFill>
-                <a:latin typeface="Arial" panose="020B0604020202020204" pitchFamily="34" charset="0"/>
-                <a:ea typeface="Arial" panose="020B0604020202020204" pitchFamily="34" charset="-122"/>
-                <a:cs typeface="Arial" panose="020B0604020202020204" pitchFamily="34" charset="-120"/>
-              </a:rPr>
-              <a:t>Account &amp; case numbers</a:t>
-            </a:r>
-            <a:endParaRPr lang="en-US" sz="1600" dirty="0"/>
-          </a:p>
-        </p:txBody>
-      </p:sp>
-      <p:sp>
-        <p:nvSpPr>
-          <p:cNvPr id="13" name="Text 8"/>
-          <p:cNvSpPr txBox="1"/>
-          <p:nvPr/>
-        </p:nvSpPr>
-        <p:spPr>
-          <a:xfrm>
-            <a:off x="6464808" y="2331720"/>
-            <a:ext cx="4489704" cy="868680"/>
-          </a:xfrm>
-          <a:prstGeom prst="rect">
-            <a:avLst/>
-          </a:prstGeom>
-          <a:noFill/>
-        </p:spPr>
-        <p:txBody>
-          <a:bodyPr wrap="square" lIns="0" tIns="0" rIns="0" bIns="0" rtlCol="0" anchor="ctr"/>
-          <a:lstStyle/>
-          <a:p>
-            <a:pPr marL="0" indent="0">
-              <a:lnSpc>
-                <a:spcPts val="1550"/>
-              </a:lnSpc>
-              <a:buNone/>
-            </a:pPr>
-            <a:r>
-              <a:rPr lang="en-US" sz="1150" dirty="0">
-                <a:solidFill>
-                  <a:srgbClr val="56606E"/>
-                </a:solidFill>
-                <a:latin typeface="Arial" panose="020B0604020202020204" pitchFamily="34" charset="0"/>
-                <a:ea typeface="Arial" panose="020B0604020202020204" pitchFamily="34" charset="-122"/>
-                <a:cs typeface="Arial" panose="020B0604020202020204" pitchFamily="34" charset="-120"/>
-              </a:rPr>
-              <a:t>Account IDs, case references, policy numbers — anything that maps back to a specific record.</a:t>
-            </a:r>
-            <a:endParaRPr lang="en-US" sz="1150" dirty="0"/>
-          </a:p>
-        </p:txBody>
-      </p:sp>
-      <p:sp>
-        <p:nvSpPr>
-          <p:cNvPr id="14" name="Shape 9"/>
-          <p:cNvSpPr/>
-          <p:nvPr/>
-        </p:nvSpPr>
-        <p:spPr>
-          <a:xfrm>
-            <a:off x="640080" y="3611880"/>
-            <a:ext cx="5074920" cy="1783080"/>
-          </a:xfrm>
-          <a:prstGeom prst="roundRect">
-            <a:avLst>
-              <a:gd name="adj" fmla="val 6154"/>
-            </a:avLst>
-          </a:prstGeom>
-          <a:solidFill>
-            <a:srgbClr val="F2F5FA"/>
-          </a:solidFill>
-          <a:effectLst>
-            <a:outerShdw blurRad="76200" dist="25400" dir="5400000" algn="bl" rotWithShape="0">
-              <a:srgbClr val="000000">
-                <a:alpha val="8000"/>
-              </a:srgbClr>
-            </a:outerShdw>
-          </a:effectLst>
-        </p:spPr>
-      </p:sp>
-      <p:pic>
-        <p:nvPicPr>
-          <p:cNvPr id="15" name="Image 3" descr="/home/claude/work/assets/badge_gradient.png"/>
-          <p:cNvPicPr>
-            <a:picLocks noChangeAspect="1"/>
-          </p:cNvPicPr>
-          <p:nvPr/>
-        </p:nvPicPr>
-        <p:blipFill>
-          <a:blip r:embed="rId2"/>
-          <a:stretch>
-            <a:fillRect/>
-          </a:stretch>
-        </p:blipFill>
-        <p:spPr>
-          <a:xfrm>
-            <a:off x="896112" y="3840480"/>
-            <a:ext cx="457200" cy="457200"/>
-          </a:xfrm>
-          <a:prstGeom prst="rect">
-            <a:avLst/>
-          </a:prstGeom>
-          <a:effectLst>
-            <a:outerShdw blurRad="76200" dist="25400" dir="5400000" algn="bl" rotWithShape="0">
-              <a:srgbClr val="3A2E6E">
-                <a:alpha val="30000"/>
-              </a:srgbClr>
-            </a:outerShdw>
-          </a:effectLst>
-        </p:spPr>
-      </p:pic>
-      <p:sp>
-        <p:nvSpPr>
-          <p:cNvPr id="16" name="Text 10"/>
-          <p:cNvSpPr txBox="1"/>
-          <p:nvPr/>
-        </p:nvSpPr>
-        <p:spPr>
-          <a:xfrm>
-            <a:off x="896112" y="3840480"/>
-            <a:ext cx="457200" cy="457200"/>
-          </a:xfrm>
-          <a:prstGeom prst="rect">
-            <a:avLst/>
-          </a:prstGeom>
-          <a:noFill/>
-        </p:spPr>
-        <p:txBody>
-          <a:bodyPr wrap="square" lIns="0" tIns="0" rIns="0" bIns="0" rtlCol="0" anchor="ctr"/>
-          <a:lstStyle/>
-          <a:p>
-            <a:pPr marL="0" indent="0" algn="ctr">
-              <a:buNone/>
-            </a:pPr>
-            <a:r>
-              <a:rPr lang="en-US" sz="1600" b="1" dirty="0">
-                <a:solidFill>
-                  <a:srgbClr val="FFFFFF"/>
-                </a:solidFill>
-                <a:latin typeface="Arial" panose="020B0604020202020204" pitchFamily="34" charset="0"/>
-                <a:ea typeface="Arial" panose="020B0604020202020204" pitchFamily="34" charset="-122"/>
-                <a:cs typeface="Arial" panose="020B0604020202020204" pitchFamily="34" charset="-120"/>
-              </a:rPr>
-              <a:t>3</a:t>
-            </a:r>
-            <a:endParaRPr lang="en-US" sz="1600" dirty="0"/>
-          </a:p>
-        </p:txBody>
-      </p:sp>
-      <p:sp>
-        <p:nvSpPr>
-          <p:cNvPr id="17" name="Text 11"/>
-          <p:cNvSpPr txBox="1"/>
-          <p:nvPr/>
-        </p:nvSpPr>
-        <p:spPr>
-          <a:xfrm>
-            <a:off x="1536192" y="3813048"/>
-            <a:ext cx="3931920" cy="457200"/>
-          </a:xfrm>
-          <a:prstGeom prst="rect">
-            <a:avLst/>
-          </a:prstGeom>
-          <a:noFill/>
-        </p:spPr>
-        <p:txBody>
-          <a:bodyPr wrap="square" lIns="0" tIns="0" rIns="0" bIns="0" rtlCol="0" anchor="ctr"/>
-          <a:lstStyle/>
-          <a:p>
-            <a:pPr marL="0" indent="0">
-              <a:buNone/>
-            </a:pPr>
-            <a:r>
-              <a:rPr lang="en-US" sz="1600" b="1" dirty="0">
-                <a:solidFill>
-                  <a:srgbClr val="00081D"/>
-                </a:solidFill>
-                <a:latin typeface="Arial" panose="020B0604020202020204" pitchFamily="34" charset="0"/>
-                <a:ea typeface="Arial" panose="020B0604020202020204" pitchFamily="34" charset="-122"/>
-                <a:cs typeface="Arial" panose="020B0604020202020204" pitchFamily="34" charset="-120"/>
-              </a:rPr>
-              <a:t>Exact financial figures</a:t>
-            </a:r>
-            <a:endParaRPr lang="en-US" sz="1600" dirty="0"/>
-          </a:p>
-        </p:txBody>
-      </p:sp>
-      <p:sp>
-        <p:nvSpPr>
-          <p:cNvPr id="18" name="Text 12"/>
-          <p:cNvSpPr txBox="1"/>
-          <p:nvPr/>
-        </p:nvSpPr>
-        <p:spPr>
-          <a:xfrm>
-            <a:off x="932688" y="4343400"/>
-            <a:ext cx="4489704" cy="868680"/>
-          </a:xfrm>
-          <a:prstGeom prst="rect">
-            <a:avLst/>
-          </a:prstGeom>
-          <a:noFill/>
-        </p:spPr>
-        <p:txBody>
-          <a:bodyPr wrap="square" lIns="0" tIns="0" rIns="0" bIns="0" rtlCol="0" anchor="ctr"/>
-          <a:lstStyle/>
-          <a:p>
-            <a:pPr marL="0" indent="0">
-              <a:lnSpc>
-                <a:spcPts val="1550"/>
-              </a:lnSpc>
-              <a:buNone/>
-            </a:pPr>
-            <a:r>
-              <a:rPr lang="en-US" sz="1150" dirty="0">
-                <a:solidFill>
-                  <a:srgbClr val="56606E"/>
-                </a:solidFill>
-                <a:latin typeface="Arial" panose="020B0604020202020204" pitchFamily="34" charset="0"/>
-                <a:ea typeface="Arial" panose="020B0604020202020204" pitchFamily="34" charset="-122"/>
-                <a:cs typeface="Arial" panose="020B0604020202020204" pitchFamily="34" charset="-120"/>
-              </a:rPr>
-              <a:t>Real balances, amounts, dates or valuations — round them or describe them instead.</a:t>
-            </a:r>
-            <a:endParaRPr lang="en-US" sz="1150" dirty="0"/>
-          </a:p>
-        </p:txBody>
-      </p:sp>
-      <p:sp>
-        <p:nvSpPr>
-          <p:cNvPr id="19" name="Shape 13"/>
-          <p:cNvSpPr/>
-          <p:nvPr/>
-        </p:nvSpPr>
-        <p:spPr>
-          <a:xfrm>
-            <a:off x="6172200" y="3611880"/>
-            <a:ext cx="5074920" cy="1783080"/>
-          </a:xfrm>
-          <a:prstGeom prst="roundRect">
-            <a:avLst>
-              <a:gd name="adj" fmla="val 6154"/>
-            </a:avLst>
-          </a:prstGeom>
-          <a:solidFill>
-            <a:srgbClr val="F2F5FA"/>
-          </a:solidFill>
-          <a:effectLst>
-            <a:outerShdw blurRad="76200" dist="25400" dir="5400000" algn="bl" rotWithShape="0">
-              <a:srgbClr val="000000">
-                <a:alpha val="8000"/>
-              </a:srgbClr>
-            </a:outerShdw>
-          </a:effectLst>
-        </p:spPr>
-      </p:sp>
-      <p:pic>
-        <p:nvPicPr>
-          <p:cNvPr id="20" name="Image 4" descr="/home/claude/work/assets/badge_gradient.png"/>
-          <p:cNvPicPr>
-            <a:picLocks noChangeAspect="1"/>
-          </p:cNvPicPr>
-          <p:nvPr/>
-        </p:nvPicPr>
-        <p:blipFill>
-          <a:blip r:embed="rId2"/>
-          <a:stretch>
-            <a:fillRect/>
-          </a:stretch>
-        </p:blipFill>
-        <p:spPr>
-          <a:xfrm>
-            <a:off x="6428232" y="3840480"/>
-            <a:ext cx="457200" cy="457200"/>
-          </a:xfrm>
-          <a:prstGeom prst="rect">
-            <a:avLst/>
-          </a:prstGeom>
-          <a:effectLst>
-            <a:outerShdw blurRad="76200" dist="25400" dir="5400000" algn="bl" rotWithShape="0">
-              <a:srgbClr val="3A2E6E">
-                <a:alpha val="30000"/>
-              </a:srgbClr>
-            </a:outerShdw>
-          </a:effectLst>
-        </p:spPr>
-      </p:pic>
-      <p:sp>
-        <p:nvSpPr>
-          <p:cNvPr id="21" name="Text 14"/>
-          <p:cNvSpPr txBox="1"/>
-          <p:nvPr/>
-        </p:nvSpPr>
-        <p:spPr>
-          <a:xfrm>
-            <a:off x="6428232" y="3840480"/>
-            <a:ext cx="457200" cy="457200"/>
-          </a:xfrm>
-          <a:prstGeom prst="rect">
-            <a:avLst/>
-          </a:prstGeom>
-          <a:noFill/>
-        </p:spPr>
-        <p:txBody>
-          <a:bodyPr wrap="square" lIns="0" tIns="0" rIns="0" bIns="0" rtlCol="0" anchor="ctr"/>
-          <a:lstStyle/>
-          <a:p>
-            <a:pPr marL="0" indent="0" algn="ctr">
-              <a:buNone/>
-            </a:pPr>
-            <a:r>
-              <a:rPr lang="en-US" sz="1600" b="1" dirty="0">
-                <a:solidFill>
-                  <a:srgbClr val="FFFFFF"/>
-                </a:solidFill>
-                <a:latin typeface="Arial" panose="020B0604020202020204" pitchFamily="34" charset="0"/>
-                <a:ea typeface="Arial" panose="020B0604020202020204" pitchFamily="34" charset="-122"/>
-                <a:cs typeface="Arial" panose="020B0604020202020204" pitchFamily="34" charset="-120"/>
-              </a:rPr>
-              <a:t>4</a:t>
-            </a:r>
-            <a:endParaRPr lang="en-US" sz="1600" dirty="0"/>
-          </a:p>
-        </p:txBody>
-      </p:sp>
-      <p:sp>
-        <p:nvSpPr>
-          <p:cNvPr id="22" name="Text 15"/>
-          <p:cNvSpPr txBox="1"/>
-          <p:nvPr/>
-        </p:nvSpPr>
-        <p:spPr>
-          <a:xfrm>
-            <a:off x="7068312" y="3813048"/>
-            <a:ext cx="3931920" cy="457200"/>
-          </a:xfrm>
-          <a:prstGeom prst="rect">
-            <a:avLst/>
-          </a:prstGeom>
-          <a:noFill/>
-        </p:spPr>
-        <p:txBody>
-          <a:bodyPr wrap="square" lIns="0" tIns="0" rIns="0" bIns="0" rtlCol="0" anchor="ctr"/>
-          <a:lstStyle/>
-          <a:p>
-            <a:pPr marL="0" indent="0">
-              <a:buNone/>
-            </a:pPr>
-            <a:r>
-              <a:rPr lang="en-US" sz="1600" b="1" dirty="0">
-                <a:solidFill>
-                  <a:srgbClr val="00081D"/>
-                </a:solidFill>
-                <a:latin typeface="Arial" panose="020B0604020202020204" pitchFamily="34" charset="0"/>
-                <a:ea typeface="Arial" panose="020B0604020202020204" pitchFamily="34" charset="-122"/>
-                <a:cs typeface="Arial" panose="020B0604020202020204" pitchFamily="34" charset="-120"/>
-              </a:rPr>
-              <a:t>Credentials &amp; internal info</a:t>
-            </a:r>
-            <a:endParaRPr lang="en-US" sz="1600" dirty="0"/>
-          </a:p>
-        </p:txBody>
-      </p:sp>
-      <p:sp>
-        <p:nvSpPr>
-          <p:cNvPr id="23" name="Text 16"/>
-          <p:cNvSpPr txBox="1"/>
-          <p:nvPr/>
-        </p:nvSpPr>
-        <p:spPr>
-          <a:xfrm>
-            <a:off x="6464808" y="4343400"/>
-            <a:ext cx="4489704" cy="868680"/>
-          </a:xfrm>
-          <a:prstGeom prst="rect">
-            <a:avLst/>
-          </a:prstGeom>
-          <a:noFill/>
-        </p:spPr>
-        <p:txBody>
-          <a:bodyPr wrap="square" lIns="0" tIns="0" rIns="0" bIns="0" rtlCol="0" anchor="ctr"/>
-          <a:lstStyle/>
-          <a:p>
-            <a:pPr marL="0" indent="0">
-              <a:lnSpc>
-                <a:spcPts val="1550"/>
-              </a:lnSpc>
-              <a:buNone/>
-            </a:pPr>
-            <a:r>
-              <a:rPr lang="en-US" sz="1150" dirty="0">
-                <a:solidFill>
-                  <a:srgbClr val="56606E"/>
-                </a:solidFill>
-                <a:latin typeface="Arial" panose="020B0604020202020204" pitchFamily="34" charset="0"/>
-                <a:ea typeface="Arial" panose="020B0604020202020204" pitchFamily="34" charset="-122"/>
-                <a:cs typeface="Arial" panose="020B0604020202020204" pitchFamily="34" charset="-120"/>
-              </a:rPr>
-              <a:t>Logins, passwords, API keys, and anything not yet public: deals, strategy, unreleased results.</a:t>
-            </a:r>
-            <a:endParaRPr lang="en-US" sz="1150" dirty="0"/>
-          </a:p>
-        </p:txBody>
-      </p:sp>
-      <p:sp>
-        <p:nvSpPr>
-          <p:cNvPr id="24" name="Shape 17"/>
-          <p:cNvSpPr/>
-          <p:nvPr/>
-        </p:nvSpPr>
-        <p:spPr>
-          <a:xfrm>
-            <a:off x="640080" y="5623560"/>
-            <a:ext cx="10607040" cy="1005840"/>
-          </a:xfrm>
-          <a:prstGeom prst="roundRect">
-            <a:avLst>
-              <a:gd name="adj" fmla="val 10909"/>
-            </a:avLst>
-          </a:prstGeom>
-          <a:solidFill>
-            <a:srgbClr val="FEEDED"/>
-          </a:solidFill>
-          <a:effectLst>
-            <a:outerShdw blurRad="101600" dist="38100" dir="5400000" algn="bl" rotWithShape="0">
-              <a:srgbClr val="1A2B33">
-                <a:alpha val="12000"/>
-              </a:srgbClr>
-            </a:outerShdw>
-          </a:effectLst>
-        </p:spPr>
-      </p:sp>
-      <p:sp>
-        <p:nvSpPr>
-          <p:cNvPr id="25" name="Shape 18"/>
-          <p:cNvSpPr/>
-          <p:nvPr/>
-        </p:nvSpPr>
-        <p:spPr>
-          <a:xfrm>
-            <a:off x="896112" y="5879592"/>
-            <a:ext cx="457200" cy="457200"/>
-          </a:xfrm>
-          <a:prstGeom prst="ellipse">
-            <a:avLst/>
-          </a:prstGeom>
-          <a:solidFill>
-            <a:srgbClr val="FE5A5B"/>
-          </a:solidFill>
-        </p:spPr>
-      </p:sp>
-      <p:sp>
-        <p:nvSpPr>
-          <p:cNvPr id="26" name="Text 19"/>
-          <p:cNvSpPr txBox="1"/>
-          <p:nvPr/>
-        </p:nvSpPr>
-        <p:spPr>
-          <a:xfrm>
-            <a:off x="896112" y="5879592"/>
-            <a:ext cx="457200" cy="457200"/>
-          </a:xfrm>
-          <a:prstGeom prst="rect">
-            <a:avLst/>
-          </a:prstGeom>
-          <a:noFill/>
-        </p:spPr>
-        <p:txBody>
-          <a:bodyPr wrap="square" lIns="0" tIns="0" rIns="0" bIns="0" rtlCol="0" anchor="ctr"/>
-          <a:lstStyle/>
-          <a:p>
-            <a:pPr marL="0" indent="0" algn="ctr">
-              <a:buNone/>
-            </a:pPr>
-            <a:r>
-              <a:rPr lang="en-US" sz="1600" b="1" dirty="0">
-                <a:solidFill>
-                  <a:srgbClr val="FFFFFF"/>
-                </a:solidFill>
-                <a:latin typeface="Arial" panose="020B0604020202020204" pitchFamily="34" charset="0"/>
-                <a:ea typeface="Arial" panose="020B0604020202020204" pitchFamily="34" charset="-122"/>
-                <a:cs typeface="Arial" panose="020B0604020202020204" pitchFamily="34" charset="-120"/>
-              </a:rPr>
-              <a:t>!</a:t>
-            </a:r>
-            <a:endParaRPr lang="en-US" sz="1600" dirty="0"/>
-          </a:p>
-        </p:txBody>
-      </p:sp>
-      <p:sp>
-        <p:nvSpPr>
-          <p:cNvPr id="27" name="Text 20"/>
-          <p:cNvSpPr txBox="1"/>
-          <p:nvPr/>
-        </p:nvSpPr>
-        <p:spPr>
-          <a:xfrm>
-            <a:off x="1536192" y="5760720"/>
-            <a:ext cx="2743200" cy="731520"/>
-          </a:xfrm>
-          <a:prstGeom prst="rect">
-            <a:avLst/>
-          </a:prstGeom>
-          <a:noFill/>
-        </p:spPr>
-        <p:txBody>
-          <a:bodyPr wrap="square" lIns="0" tIns="0" rIns="0" bIns="0" rtlCol="0" anchor="ctr"/>
-          <a:lstStyle/>
-          <a:p>
-            <a:pPr marL="0" indent="0">
-              <a:buNone/>
-            </a:pPr>
-            <a:r>
-              <a:rPr lang="en-US" sz="1600" b="1" dirty="0">
-                <a:solidFill>
-                  <a:srgbClr val="FE5A5B"/>
-                </a:solidFill>
-                <a:latin typeface="Arial" panose="020B0604020202020204" pitchFamily="34" charset="0"/>
-                <a:ea typeface="Arial" panose="020B0604020202020204" pitchFamily="34" charset="-122"/>
-                <a:cs typeface="Arial" panose="020B0604020202020204" pitchFamily="34" charset="-120"/>
-              </a:rPr>
-              <a:t>Rule of thumb</a:t>
-            </a:r>
-            <a:endParaRPr lang="en-US" sz="1600" dirty="0"/>
-          </a:p>
-        </p:txBody>
-      </p:sp>
-      <p:sp>
-        <p:nvSpPr>
-          <p:cNvPr id="28" name="Text 21"/>
-          <p:cNvSpPr txBox="1"/>
-          <p:nvPr/>
-        </p:nvSpPr>
-        <p:spPr>
-          <a:xfrm>
-            <a:off x="4480560" y="5623560"/>
-            <a:ext cx="6492240" cy="1005840"/>
-          </a:xfrm>
-          <a:prstGeom prst="rect">
-            <a:avLst/>
-          </a:prstGeom>
-          <a:noFill/>
-        </p:spPr>
-        <p:txBody>
-          <a:bodyPr wrap="square" lIns="0" tIns="0" rIns="0" bIns="0" rtlCol="0" anchor="ctr"/>
-          <a:lstStyle/>
-          <a:p>
-            <a:pPr marL="0" indent="0">
-              <a:lnSpc>
-                <a:spcPts val="1550"/>
-              </a:lnSpc>
-              <a:buNone/>
-            </a:pPr>
-            <a:r>
-              <a:rPr lang="en-US" sz="1200" dirty="0">
-                <a:solidFill>
-                  <a:srgbClr val="0B1B33"/>
-                </a:solidFill>
-                <a:latin typeface="Arial" panose="020B0604020202020204" pitchFamily="34" charset="0"/>
-                <a:ea typeface="Arial" panose="020B0604020202020204" pitchFamily="34" charset="-122"/>
-                <a:cs typeface="Arial" panose="020B0604020202020204" pitchFamily="34" charset="-120"/>
-              </a:rPr>
-              <a:t>If you wouldn't post it on the company intranet for everyone to see, don't paste it into an AI chat tool either.</a:t>
-            </a:r>
-            <a:endParaRPr lang="en-US" sz="1200" dirty="0"/>
-          </a:p>
-        </p:txBody>
-      </p:sp>
-      <p:sp>
-        <p:nvSpPr>
-          <p:cNvPr id="29" name="Text 22"/>
-          <p:cNvSpPr txBox="1"/>
-          <p:nvPr/>
-        </p:nvSpPr>
-        <p:spPr>
-          <a:xfrm>
-            <a:off x="11320272" y="6556248"/>
-            <a:ext cx="457200" cy="256032"/>
-          </a:xfrm>
-          <a:prstGeom prst="rect">
-            <a:avLst/>
-          </a:prstGeom>
-          <a:noFill/>
-        </p:spPr>
-        <p:txBody>
-          <a:bodyPr wrap="square" lIns="0" tIns="0" rIns="0" bIns="0" rtlCol="0" anchor="ctr"/>
-          <a:lstStyle/>
-          <a:p>
-            <a:pPr marL="0" indent="0" algn="r">
-              <a:buNone/>
-            </a:pPr>
-            <a:r>
-              <a:rPr lang="en-US" sz="900" dirty="0">
-                <a:solidFill>
-                  <a:srgbClr val="8FA3B8"/>
-                </a:solidFill>
-                <a:latin typeface="Arial" panose="020B0604020202020204" pitchFamily="34" charset="0"/>
-                <a:ea typeface="Arial" panose="020B0604020202020204" pitchFamily="34" charset="-122"/>
-                <a:cs typeface="Arial" panose="020B0604020202020204" pitchFamily="34" charset="-120"/>
-              </a:rPr>
-              <a:t>9</a:t>
-            </a:r>
-            <a:endParaRPr lang="en-US" sz="900" dirty="0"/>
           </a:p>
         </p:txBody>
       </p:sp>
@@ -9761,37 +8759,262 @@
           </a:p>
         </p:txBody>
       </p:sp>
-      <p:pic>
-        <p:nvPicPr>
-          <p:cNvPr id="8" name="Image 1" descr="/home/claude/work/assets/viz_face.png"/>
-          <p:cNvPicPr>
-            <a:picLocks noChangeAspect="1"/>
-          </p:cNvPicPr>
-          <p:nvPr/>
-        </p:nvPicPr>
-        <p:blipFill>
-          <a:blip r:embed="rId2"/>
-          <a:stretch>
-            <a:fillRect/>
-          </a:stretch>
-        </p:blipFill>
+      <p:sp>
+        <p:nvSpPr>
+          <p:cNvPr id="30" name="Shape Categories"/>
+          <p:cNvSpPr/>
+          <p:nvPr/>
+        </p:nvSpPr>
         <p:spPr>
           <a:xfrm>
             <a:off x="7635240" y="1600200"/>
             <a:ext cx="4114800" cy="3429000"/>
           </a:xfrm>
-          <a:prstGeom prst="rect">
-            <a:avLst/>
-          </a:prstGeom>
+          <a:prstGeom prst="roundRect">
+            <a:avLst>
+              <a:gd name="adj" fmla="val 4000"/>
+            </a:avLst>
+          </a:prstGeom>
+          <a:solidFill>
+            <a:srgbClr val="F2F5FA"/>
+          </a:solidFill>
           <a:effectLst>
-            <a:outerShdw blurRad="152400" dist="50800" dir="5400000" algn="bl" rotWithShape="0">
-              <a:srgbClr val="0A2A4A">
-                <a:alpha val="25000"/>
+            <a:outerShdw blurRad="76200" dist="25400" dir="5400000" algn="bl" rotWithShape="0">
+              <a:srgbClr val="000000">
+                <a:alpha val="8000"/>
               </a:srgbClr>
             </a:outerShdw>
           </a:effectLst>
         </p:spPr>
-      </p:pic>
+      </p:sp>
+      <p:sp>
+        <p:nvSpPr>
+          <p:cNvPr id="31" name="Text Categories Heading"/>
+          <p:cNvSpPr txBox="1"/>
+          <p:nvPr/>
+        </p:nvSpPr>
+        <p:spPr>
+          <a:xfrm>
+            <a:off x="7864920" y="1874520"/>
+            <a:ext cx="3657600" cy="274320"/>
+          </a:xfrm>
+          <a:prstGeom prst="rect">
+            <a:avLst/>
+          </a:prstGeom>
+          <a:noFill/>
+        </p:spPr>
+        <p:txBody>
+          <a:bodyPr wrap="square" lIns="0" tIns="0" rIns="0" bIns="0" rtlCol="0" anchor="ctr"/>
+          <a:lstStyle/>
+          <a:p>
+            <a:pPr marL="0" indent="0">
+              <a:buNone/>
+            </a:pPr>
+            <a:r>
+              <a:rPr lang="en-US" sz="1100" b="1" dirty="0">
+                <a:solidFill>
+                  <a:srgbClr val="0B1B33"/>
+                </a:solidFill>
+                <a:latin typeface="Arial" panose="020B0604020202020204" pitchFamily="34" charset="0"/>
+              </a:rPr>
+              <a:t>Also treat as sensitive:</a:t>
+            </a:r>
+            <a:endParaRPr lang="en-US" sz="1100" dirty="0"/>
+          </a:p>
+        </p:txBody>
+      </p:sp>
+      <p:sp>
+        <p:nvSpPr>
+          <p:cNvPr id="32" name="Text Cat1"/>
+          <p:cNvSpPr txBox="1"/>
+          <p:nvPr/>
+        </p:nvSpPr>
+        <p:spPr>
+          <a:xfrm>
+            <a:off x="7864920" y="2240280"/>
+            <a:ext cx="3657600" cy="594360"/>
+          </a:xfrm>
+          <a:prstGeom prst="rect">
+            <a:avLst/>
+          </a:prstGeom>
+          <a:noFill/>
+        </p:spPr>
+        <p:txBody>
+          <a:bodyPr wrap="square" lIns="0" tIns="0" rIns="0" bIns="0" rtlCol="0" anchor="t"/>
+          <a:lstStyle/>
+          <a:p>
+            <a:pPr marL="0" indent="0">
+              <a:lnSpc>
+                <a:spcPts val="1400"/>
+              </a:lnSpc>
+              <a:buNone/>
+            </a:pPr>
+            <a:r>
+              <a:rPr lang="en-US" sz="1000" b="1" dirty="0">
+                <a:solidFill>
+                  <a:srgbClr val="0B1B33"/>
+                </a:solidFill>
+                <a:latin typeface="Arial" panose="020B0604020202020204" pitchFamily="34" charset="0"/>
+              </a:rPr>
+              <a:t>Client &amp; personal data </a:t>
+            </a:r>
+            <a:r>
+              <a:rPr lang="en-US" sz="950" dirty="0">
+                <a:solidFill>
+                  <a:srgbClr val="56606E"/>
+                </a:solidFill>
+                <a:latin typeface="Arial" panose="020B0604020202020204" pitchFamily="34" charset="0"/>
+              </a:rPr>
+              <a:t>— names, employers, contact details.</a:t>
+            </a:r>
+            <a:endParaRPr lang="en-US" sz="950" dirty="0"/>
+          </a:p>
+        </p:txBody>
+      </p:sp>
+      <p:sp>
+        <p:nvSpPr>
+          <p:cNvPr id="33" name="Text Cat2"/>
+          <p:cNvSpPr txBox="1"/>
+          <p:nvPr/>
+        </p:nvSpPr>
+        <p:spPr>
+          <a:xfrm>
+            <a:off x="7864920" y="2926080"/>
+            <a:ext cx="3657600" cy="594360"/>
+          </a:xfrm>
+          <a:prstGeom prst="rect">
+            <a:avLst/>
+          </a:prstGeom>
+          <a:noFill/>
+        </p:spPr>
+        <p:txBody>
+          <a:bodyPr wrap="square" lIns="0" tIns="0" rIns="0" bIns="0" rtlCol="0" anchor="t"/>
+          <a:lstStyle/>
+          <a:p>
+            <a:pPr marL="0" indent="0">
+              <a:lnSpc>
+                <a:spcPts val="1400"/>
+              </a:lnSpc>
+              <a:buNone/>
+            </a:pPr>
+            <a:r>
+              <a:rPr lang="en-US" sz="1000" b="1" dirty="0">
+                <a:solidFill>
+                  <a:srgbClr val="0B1B33"/>
+                </a:solidFill>
+                <a:latin typeface="Arial" panose="020B0604020202020204" pitchFamily="34" charset="0"/>
+              </a:rPr>
+              <a:t>Account &amp; case numbers </a:t>
+            </a:r>
+            <a:r>
+              <a:rPr lang="en-US" sz="950" dirty="0">
+                <a:solidFill>
+                  <a:srgbClr val="56606E"/>
+                </a:solidFill>
+                <a:latin typeface="Arial" panose="020B0604020202020204" pitchFamily="34" charset="0"/>
+              </a:rPr>
+              <a:t>— anything that maps to a record.</a:t>
+            </a:r>
+            <a:endParaRPr lang="en-US" sz="950" dirty="0"/>
+          </a:p>
+        </p:txBody>
+      </p:sp>
+      <p:sp>
+        <p:nvSpPr>
+          <p:cNvPr id="34" name="Text Cat3"/>
+          <p:cNvSpPr txBox="1"/>
+          <p:nvPr/>
+        </p:nvSpPr>
+        <p:spPr>
+          <a:xfrm>
+            <a:off x="7864920" y="3611880"/>
+            <a:ext cx="3657600" cy="594360"/>
+          </a:xfrm>
+          <a:prstGeom prst="rect">
+            <a:avLst/>
+          </a:prstGeom>
+          <a:noFill/>
+        </p:spPr>
+        <p:txBody>
+          <a:bodyPr wrap="square" lIns="0" tIns="0" rIns="0" bIns="0" rtlCol="0" anchor="t"/>
+          <a:lstStyle/>
+          <a:p>
+            <a:pPr marL="0" indent="0">
+              <a:lnSpc>
+                <a:spcPts val="1400"/>
+              </a:lnSpc>
+              <a:buNone/>
+            </a:pPr>
+            <a:r>
+              <a:rPr lang="en-US" sz="1000" b="1" dirty="0">
+                <a:solidFill>
+                  <a:srgbClr val="0B1B33"/>
+                </a:solidFill>
+                <a:latin typeface="Arial" panose="020B0604020202020204" pitchFamily="34" charset="0"/>
+              </a:rPr>
+              <a:t>Exact financial figures </a:t>
+            </a:r>
+            <a:r>
+              <a:rPr lang="en-US" sz="950" dirty="0">
+                <a:solidFill>
+                  <a:srgbClr val="56606E"/>
+                </a:solidFill>
+                <a:latin typeface="Arial" panose="020B0604020202020204" pitchFamily="34" charset="0"/>
+              </a:rPr>
+              <a:t>— round amounts or describe them instead.</a:t>
+            </a:r>
+            <a:endParaRPr lang="en-US" sz="950" dirty="0"/>
+          </a:p>
+        </p:txBody>
+      </p:sp>
+      <p:sp>
+        <p:nvSpPr>
+          <p:cNvPr id="35" name="Text Cat4"/>
+          <p:cNvSpPr txBox="1"/>
+          <p:nvPr/>
+        </p:nvSpPr>
+        <p:spPr>
+          <a:xfrm>
+            <a:off x="7864920" y="4297680"/>
+            <a:ext cx="3657600" cy="594360"/>
+          </a:xfrm>
+          <a:prstGeom prst="rect">
+            <a:avLst/>
+          </a:prstGeom>
+          <a:noFill/>
+        </p:spPr>
+        <p:txBody>
+          <a:bodyPr wrap="square" lIns="0" tIns="0" rIns="0" bIns="0" rtlCol="0" anchor="t"/>
+          <a:lstStyle/>
+          <a:p>
+            <a:pPr marL="0" indent="0">
+              <a:lnSpc>
+                <a:spcPts val="1400"/>
+              </a:lnSpc>
+              <a:buNone/>
+            </a:pPr>
+            <a:r>
+              <a:rPr lang="en-US" sz="1000" b="1" dirty="0">
+                <a:solidFill>
+                  <a:srgbClr val="0B1B33"/>
+                </a:solidFill>
+                <a:latin typeface="Arial" panose="020B0604020202020204" pitchFamily="34" charset="0"/>
+              </a:rPr>
+              <a:t>Credentials &amp; internal info </a:t>
+            </a:r>
+            <a:r>
+              <a:rPr lang="en-US" sz="950" dirty="0">
+                <a:solidFill>
+                  <a:srgbClr val="56606E"/>
+                </a:solidFill>
+                <a:latin typeface="Arial" panose="020B0604020202020204" pitchFamily="34" charset="0"/>
+              </a:rPr>
+              <a:t>— logins, keys, anything not yet public.</a:t>
+            </a:r>
+            <a:endParaRPr lang="en-US" sz="950" dirty="0"/>
+          </a:p>
+        </p:txBody>
+      </p:sp>
       <p:sp>
         <p:nvSpPr>
           <p:cNvPr id="9" name="Text 5"/>
@@ -10721,7 +9944,7 @@
                 <a:ea typeface="Arial" panose="020B0604020202020204" pitchFamily="34" charset="-122"/>
                 <a:cs typeface="Arial" panose="020B0604020202020204" pitchFamily="34" charset="-120"/>
               </a:rPr>
-              <a:t>10</a:t>
+              <a:t>9</a:t>
             </a:r>
             <a:endParaRPr lang="en-US" sz="900" dirty="0"/>
           </a:p>

</xml_diff>

<commit_message>
chore: sync pending Power BI project and deck changes
</commit_message>
<xml_diff>
--- a/AI At Work.pptx
+++ b/AI At Work.pptx
@@ -15,10 +15,11 @@
     <p:sldId id="259" r:id="rId8"/>
     <p:sldId id="260" r:id="rId9"/>
     <p:sldId id="261" r:id="rId10"/>
-    <p:sldId id="262" r:id="rId11"/>
-    <p:sldId id="263" r:id="rId12"/>
-    <p:sldId id="264" r:id="rId13"/>
-    <p:sldId id="266" r:id="rId14"/>
+    <p:sldId id="268" r:id="rId11"/>
+    <p:sldId id="262" r:id="rId12"/>
+    <p:sldId id="263" r:id="rId13"/>
+    <p:sldId id="264" r:id="rId14"/>
+    <p:sldId id="266" r:id="rId15"/>
   </p:sldIdLst>
   <p:sldSz cx="12192000" cy="6858000"/>
   <p:notesSz cx="6858000" cy="12192000"/>
@@ -1803,7 +1804,7 @@
               <a:buNone/>
             </a:pPr>
             <a:r>
-              <a:rPr lang="en-US" sz="3000" dirty="0">
+              <a:rPr lang="en-US" sz="2600" dirty="0">
                 <a:solidFill>
                   <a:srgbClr val="FFFFFF"/>
                 </a:solidFill>
@@ -1811,9 +1812,9 @@
                 <a:ea typeface="Arial" panose="020B0604020202020204" pitchFamily="34" charset="-122"/>
                 <a:cs typeface="Arial" panose="020B0604020202020204" pitchFamily="34" charset="-120"/>
               </a:rPr>
-              <a:t>Who owns what it writes?</a:t>
-            </a:r>
-            <a:endParaRPr lang="en-US" sz="3000" dirty="0"/>
+              <a:t>Why AI makes things up (and how to reduce it)</a:t>
+            </a:r>
+            <a:endParaRPr lang="en-US" sz="2600" dirty="0"/>
           </a:p>
         </p:txBody>
       </p:sp>
@@ -1849,7 +1850,7 @@
                 <a:ea typeface="Arial" panose="020B0604020202020204" pitchFamily="34" charset="-122"/>
                 <a:cs typeface="Arial" panose="020B0604020202020204" pitchFamily="34" charset="-120"/>
               </a:rPr>
-              <a:t>Ownership of AI-written material is still an open legal question, treat it that way.</a:t>
+              <a:t>This matters most with an outside tool: there's no one behind it checking your specific answer.</a:t>
             </a:r>
             <a:endParaRPr lang="en-US" sz="1300" dirty="0"/>
           </a:p>
@@ -1857,7 +1858,7 @@
       </p:sp>
       <p:pic>
         <p:nvPicPr>
-          <p:cNvPr id="5" name="Image 1" descr="/home/claude/work/assets/panel_5.55x4.30.png"/>
+          <p:cNvPr id="5" name="Image 1" descr="/home/claude/work/assets/panel_5.55x3.75.png"/>
           <p:cNvPicPr>
             <a:picLocks noChangeAspect="1"/>
           </p:cNvPicPr>
@@ -1871,8 +1872,8 @@
         </p:blipFill>
         <p:spPr>
           <a:xfrm>
-            <a:off x="640080" y="1691640"/>
-            <a:ext cx="5074920" cy="3931920"/>
+            <a:off x="640080" y="1920240"/>
+            <a:ext cx="5074920" cy="3429000"/>
           </a:xfrm>
           <a:prstGeom prst="rect">
             <a:avLst/>
@@ -1894,7 +1895,7 @@
         </p:nvSpPr>
         <p:spPr>
           <a:xfrm>
-            <a:off x="914400" y="1965960"/>
+            <a:off x="914400" y="2176272"/>
             <a:ext cx="4526280" cy="320040"/>
           </a:xfrm>
           <a:prstGeom prst="rect">
@@ -1918,22 +1919,91 @@
                 <a:ea typeface="Arial" panose="020B0604020202020204" pitchFamily="34" charset="-122"/>
                 <a:cs typeface="Arial" panose="020B0604020202020204" pitchFamily="34" charset="-120"/>
               </a:rPr>
-              <a:t>THE SHORT VERSION</a:t>
+              <a:t>WHY IT HAPPENS</a:t>
             </a:r>
             <a:endParaRPr lang="en-US" sz="1250" dirty="0"/>
           </a:p>
         </p:txBody>
       </p:sp>
-      <p:sp>
-        <p:nvSpPr>
-          <p:cNvPr id="7" name="Text 3"/>
-          <p:cNvSpPr txBox="1"/>
-          <p:nvPr/>
-        </p:nvSpPr>
-        <p:spPr>
-          <a:xfrm>
-            <a:off x="914400" y="2423160"/>
-            <a:ext cx="4526280" cy="1463040"/>
+      <p:pic>
+        <p:nvPicPr>
+          <p:cNvPr id="7" name="Image 2" descr="/home/claude/work/assets/badge_gradient.png"/>
+          <p:cNvPicPr>
+            <a:picLocks noChangeAspect="1"/>
+          </p:cNvPicPr>
+          <p:nvPr/>
+        </p:nvPicPr>
+        <p:blipFill>
+          <a:blip r:embed="rId3"/>
+          <a:stretch>
+            <a:fillRect/>
+          </a:stretch>
+        </p:blipFill>
+        <p:spPr>
+          <a:xfrm>
+            <a:off x="914400" y="2633472"/>
+            <a:ext cx="310896" cy="310896"/>
+          </a:xfrm>
+          <a:prstGeom prst="rect">
+            <a:avLst/>
+          </a:prstGeom>
+          <a:effectLst>
+            <a:outerShdw blurRad="76200" dist="25400" dir="5400000" algn="bl" rotWithShape="0">
+              <a:srgbClr val="3A2E6E">
+                <a:alpha val="30000"/>
+              </a:srgbClr>
+            </a:outerShdw>
+          </a:effectLst>
+        </p:spPr>
+      </p:pic>
+      <p:sp>
+        <p:nvSpPr>
+          <p:cNvPr id="8" name="Text 3"/>
+          <p:cNvSpPr txBox="1"/>
+          <p:nvPr/>
+        </p:nvSpPr>
+        <p:spPr>
+          <a:xfrm>
+            <a:off x="914400" y="2633472"/>
+            <a:ext cx="310896" cy="310896"/>
+          </a:xfrm>
+          <a:prstGeom prst="rect">
+            <a:avLst/>
+          </a:prstGeom>
+          <a:noFill/>
+        </p:spPr>
+        <p:txBody>
+          <a:bodyPr wrap="square" lIns="0" tIns="0" rIns="0" bIns="0" rtlCol="0" anchor="ctr"/>
+          <a:lstStyle/>
+          <a:p>
+            <a:pPr marL="0" indent="0" algn="ctr">
+              <a:buNone/>
+            </a:pPr>
+            <a:r>
+              <a:rPr lang="en-US" sz="1200" b="1" dirty="0">
+                <a:solidFill>
+                  <a:srgbClr val="FFFFFF"/>
+                </a:solidFill>
+                <a:latin typeface="Arial" panose="020B0604020202020204" pitchFamily="34" charset="0"/>
+                <a:ea typeface="Arial" panose="020B0604020202020204" pitchFamily="34" charset="-122"/>
+                <a:cs typeface="Arial" panose="020B0604020202020204" pitchFamily="34" charset="-120"/>
+              </a:rPr>
+              <a:t>1</a:t>
+            </a:r>
+            <a:endParaRPr lang="en-US" sz="1200" dirty="0"/>
+          </a:p>
+        </p:txBody>
+      </p:sp>
+      <p:sp>
+        <p:nvSpPr>
+          <p:cNvPr id="9" name="Text 4"/>
+          <p:cNvSpPr txBox="1"/>
+          <p:nvPr/>
+        </p:nvSpPr>
+        <p:spPr>
+          <a:xfrm>
+            <a:off x="1353312" y="2523744"/>
+            <a:ext cx="4023360" cy="621792"/>
           </a:xfrm>
           <a:prstGeom prst="rect">
             <a:avLst/>
@@ -1946,12 +2016,12 @@
           <a:p>
             <a:pPr marL="0" indent="0">
               <a:lnSpc>
-                <a:spcPts val="1800"/>
+                <a:spcPts val="1400"/>
               </a:lnSpc>
               <a:buNone/>
             </a:pPr>
             <a:r>
-              <a:rPr lang="en-US" sz="1300" dirty="0">
+              <a:rPr lang="en-US" sz="1100" dirty="0">
                 <a:solidFill>
                   <a:srgbClr val="D6E6F5"/>
                 </a:solidFill>
@@ -1959,22 +2029,91 @@
                 <a:ea typeface="Arial" panose="020B0604020202020204" pitchFamily="34" charset="-122"/>
                 <a:cs typeface="Arial" panose="020B0604020202020204" pitchFamily="34" charset="-120"/>
               </a:rPr>
-              <a:t>Courts have been ruling that something purely AI-written isn't protected by copyright at all, only the parts where a person actually made the creative decisions. Typing a good prompt, or picking your favorite draft out of a few, doesn't count as authorship on its own.</a:t>
-            </a:r>
-            <a:endParaRPr lang="en-US" sz="1300" dirty="0"/>
-          </a:p>
-        </p:txBody>
-      </p:sp>
-      <p:sp>
-        <p:nvSpPr>
-          <p:cNvPr id="8" name="Text 4"/>
-          <p:cNvSpPr txBox="1"/>
-          <p:nvPr/>
-        </p:nvSpPr>
-        <p:spPr>
-          <a:xfrm>
-            <a:off x="914400" y="4572000"/>
-            <a:ext cx="4526280" cy="868680"/>
+              <a:t>No access to our systems, it only knows what you tell it.</a:t>
+            </a:r>
+            <a:endParaRPr lang="en-US" sz="1100" dirty="0"/>
+          </a:p>
+        </p:txBody>
+      </p:sp>
+      <p:pic>
+        <p:nvPicPr>
+          <p:cNvPr id="10" name="Image 3" descr="/home/claude/work/assets/badge_gradient.png"/>
+          <p:cNvPicPr>
+            <a:picLocks noChangeAspect="1"/>
+          </p:cNvPicPr>
+          <p:nvPr/>
+        </p:nvPicPr>
+        <p:blipFill>
+          <a:blip r:embed="rId3"/>
+          <a:stretch>
+            <a:fillRect/>
+          </a:stretch>
+        </p:blipFill>
+        <p:spPr>
+          <a:xfrm>
+            <a:off x="914400" y="3300984"/>
+            <a:ext cx="310896" cy="310896"/>
+          </a:xfrm>
+          <a:prstGeom prst="rect">
+            <a:avLst/>
+          </a:prstGeom>
+          <a:effectLst>
+            <a:outerShdw blurRad="76200" dist="25400" dir="5400000" algn="bl" rotWithShape="0">
+              <a:srgbClr val="3A2E6E">
+                <a:alpha val="30000"/>
+              </a:srgbClr>
+            </a:outerShdw>
+          </a:effectLst>
+        </p:spPr>
+      </p:pic>
+      <p:sp>
+        <p:nvSpPr>
+          <p:cNvPr id="11" name="Text 5"/>
+          <p:cNvSpPr txBox="1"/>
+          <p:nvPr/>
+        </p:nvSpPr>
+        <p:spPr>
+          <a:xfrm>
+            <a:off x="914400" y="3300984"/>
+            <a:ext cx="310896" cy="310896"/>
+          </a:xfrm>
+          <a:prstGeom prst="rect">
+            <a:avLst/>
+          </a:prstGeom>
+          <a:noFill/>
+        </p:spPr>
+        <p:txBody>
+          <a:bodyPr wrap="square" lIns="0" tIns="0" rIns="0" bIns="0" rtlCol="0" anchor="ctr"/>
+          <a:lstStyle/>
+          <a:p>
+            <a:pPr marL="0" indent="0" algn="ctr">
+              <a:buNone/>
+            </a:pPr>
+            <a:r>
+              <a:rPr lang="en-US" sz="1200" b="1" dirty="0">
+                <a:solidFill>
+                  <a:srgbClr val="FFFFFF"/>
+                </a:solidFill>
+                <a:latin typeface="Arial" panose="020B0604020202020204" pitchFamily="34" charset="0"/>
+                <a:ea typeface="Arial" panose="020B0604020202020204" pitchFamily="34" charset="-122"/>
+                <a:cs typeface="Arial" panose="020B0604020202020204" pitchFamily="34" charset="-120"/>
+              </a:rPr>
+              <a:t>2</a:t>
+            </a:r>
+            <a:endParaRPr lang="en-US" sz="1200" dirty="0"/>
+          </a:p>
+        </p:txBody>
+      </p:sp>
+      <p:sp>
+        <p:nvSpPr>
+          <p:cNvPr id="12" name="Text 6"/>
+          <p:cNvSpPr txBox="1"/>
+          <p:nvPr/>
+        </p:nvSpPr>
+        <p:spPr>
+          <a:xfrm>
+            <a:off x="1353312" y="3191256"/>
+            <a:ext cx="4023360" cy="621792"/>
           </a:xfrm>
           <a:prstGeom prst="rect">
             <a:avLst/>
@@ -1987,12 +2126,12 @@
           <a:p>
             <a:pPr marL="0" indent="0">
               <a:lnSpc>
-                <a:spcPts val="1600"/>
+                <a:spcPts val="1400"/>
               </a:lnSpc>
               <a:buNone/>
             </a:pPr>
             <a:r>
-              <a:rPr lang="en-US" sz="1200" i="1" dirty="0">
+              <a:rPr lang="en-US" sz="1100" dirty="0">
                 <a:solidFill>
                   <a:srgbClr val="D6E6F5"/>
                 </a:solidFill>
@@ -2000,7 +2139,76 @@
                 <a:ea typeface="Arial" panose="020B0604020202020204" pitchFamily="34" charset="-122"/>
                 <a:cs typeface="Arial" panose="020B0604020202020204" pitchFamily="34" charset="-120"/>
               </a:rPr>
-              <a:t>In practice: a report or client note that's mostly untouched AI output may not be something the company can fully claim as its own work, or stop someone else from copying.</a:t>
+              <a:t>It has a cutoff date, a new rule or updated circular might not be in there yet.</a:t>
+            </a:r>
+            <a:endParaRPr lang="en-US" sz="1100" dirty="0"/>
+          </a:p>
+        </p:txBody>
+      </p:sp>
+      <p:pic>
+        <p:nvPicPr>
+          <p:cNvPr id="13" name="Image 4" descr="/home/claude/work/assets/badge_gradient.png"/>
+          <p:cNvPicPr>
+            <a:picLocks noChangeAspect="1"/>
+          </p:cNvPicPr>
+          <p:nvPr/>
+        </p:nvPicPr>
+        <p:blipFill>
+          <a:blip r:embed="rId3"/>
+          <a:stretch>
+            <a:fillRect/>
+          </a:stretch>
+        </p:blipFill>
+        <p:spPr>
+          <a:xfrm>
+            <a:off x="914400" y="3968496"/>
+            <a:ext cx="310896" cy="310896"/>
+          </a:xfrm>
+          <a:prstGeom prst="rect">
+            <a:avLst/>
+          </a:prstGeom>
+          <a:effectLst>
+            <a:outerShdw blurRad="76200" dist="25400" dir="5400000" algn="bl" rotWithShape="0">
+              <a:srgbClr val="3A2E6E">
+                <a:alpha val="30000"/>
+              </a:srgbClr>
+            </a:outerShdw>
+          </a:effectLst>
+        </p:spPr>
+      </p:pic>
+      <p:sp>
+        <p:nvSpPr>
+          <p:cNvPr id="14" name="Text 7"/>
+          <p:cNvSpPr txBox="1"/>
+          <p:nvPr/>
+        </p:nvSpPr>
+        <p:spPr>
+          <a:xfrm>
+            <a:off x="914400" y="3968496"/>
+            <a:ext cx="310896" cy="310896"/>
+          </a:xfrm>
+          <a:prstGeom prst="rect">
+            <a:avLst/>
+          </a:prstGeom>
+          <a:noFill/>
+        </p:spPr>
+        <p:txBody>
+          <a:bodyPr wrap="square" lIns="0" tIns="0" rIns="0" bIns="0" rtlCol="0" anchor="ctr"/>
+          <a:lstStyle/>
+          <a:p>
+            <a:pPr marL="0" indent="0" algn="ctr">
+              <a:buNone/>
+            </a:pPr>
+            <a:r>
+              <a:rPr lang="en-US" sz="1200" b="1" dirty="0">
+                <a:solidFill>
+                  <a:srgbClr val="FFFFFF"/>
+                </a:solidFill>
+                <a:latin typeface="Arial" panose="020B0604020202020204" pitchFamily="34" charset="0"/>
+                <a:ea typeface="Arial" panose="020B0604020202020204" pitchFamily="34" charset="-122"/>
+                <a:cs typeface="Arial" panose="020B0604020202020204" pitchFamily="34" charset="-120"/>
+              </a:rPr>
+              <a:t>3</a:t>
             </a:r>
             <a:endParaRPr lang="en-US" sz="1200" dirty="0"/>
           </a:p>
@@ -2008,18 +2216,169 @@
       </p:sp>
       <p:sp>
         <p:nvSpPr>
-          <p:cNvPr id="9" name="Shape 5"/>
+          <p:cNvPr id="15" name="Text 8"/>
+          <p:cNvSpPr txBox="1"/>
+          <p:nvPr/>
+        </p:nvSpPr>
+        <p:spPr>
+          <a:xfrm>
+            <a:off x="1353312" y="3858768"/>
+            <a:ext cx="4023360" cy="621792"/>
+          </a:xfrm>
+          <a:prstGeom prst="rect">
+            <a:avLst/>
+          </a:prstGeom>
+          <a:noFill/>
+        </p:spPr>
+        <p:txBody>
+          <a:bodyPr wrap="square" lIns="0" tIns="0" rIns="0" bIns="0" rtlCol="0" anchor="ctr"/>
+          <a:lstStyle/>
+          <a:p>
+            <a:pPr marL="0" indent="0">
+              <a:lnSpc>
+                <a:spcPts val="1400"/>
+              </a:lnSpc>
+              <a:buNone/>
+            </a:pPr>
+            <a:r>
+              <a:rPr lang="en-US" sz="1100" dirty="0">
+                <a:solidFill>
+                  <a:srgbClr val="D6E6F5"/>
+                </a:solidFill>
+                <a:latin typeface="Arial" panose="020B0604020202020204" pitchFamily="34" charset="0"/>
+                <a:ea typeface="Arial" panose="020B0604020202020204" pitchFamily="34" charset="-122"/>
+                <a:cs typeface="Arial" panose="020B0604020202020204" pitchFamily="34" charset="-120"/>
+              </a:rPr>
+              <a:t>It's built to sound fluent, not to flag doubt: the tone is the same whether it's sure or just making something up.</a:t>
+            </a:r>
+            <a:endParaRPr lang="en-US" sz="1100" dirty="0"/>
+          </a:p>
+        </p:txBody>
+      </p:sp>
+      <p:pic>
+        <p:nvPicPr>
+          <p:cNvPr id="16" name="Image 5" descr="/home/claude/work/assets/badge_gradient.png"/>
+          <p:cNvPicPr>
+            <a:picLocks noChangeAspect="1"/>
+          </p:cNvPicPr>
+          <p:nvPr/>
+        </p:nvPicPr>
+        <p:blipFill>
+          <a:blip r:embed="rId3"/>
+          <a:stretch>
+            <a:fillRect/>
+          </a:stretch>
+        </p:blipFill>
+        <p:spPr>
+          <a:xfrm>
+            <a:off x="914400" y="4636008"/>
+            <a:ext cx="310896" cy="310896"/>
+          </a:xfrm>
+          <a:prstGeom prst="rect">
+            <a:avLst/>
+          </a:prstGeom>
+          <a:effectLst>
+            <a:outerShdw blurRad="76200" dist="25400" dir="5400000" algn="bl" rotWithShape="0">
+              <a:srgbClr val="3A2E6E">
+                <a:alpha val="30000"/>
+              </a:srgbClr>
+            </a:outerShdw>
+          </a:effectLst>
+        </p:spPr>
+      </p:pic>
+      <p:sp>
+        <p:nvSpPr>
+          <p:cNvPr id="17" name="Text 9"/>
+          <p:cNvSpPr txBox="1"/>
+          <p:nvPr/>
+        </p:nvSpPr>
+        <p:spPr>
+          <a:xfrm>
+            <a:off x="914400" y="4636008"/>
+            <a:ext cx="310896" cy="310896"/>
+          </a:xfrm>
+          <a:prstGeom prst="rect">
+            <a:avLst/>
+          </a:prstGeom>
+          <a:noFill/>
+        </p:spPr>
+        <p:txBody>
+          <a:bodyPr wrap="square" lIns="0" tIns="0" rIns="0" bIns="0" rtlCol="0" anchor="ctr"/>
+          <a:lstStyle/>
+          <a:p>
+            <a:pPr marL="0" indent="0" algn="ctr">
+              <a:buNone/>
+            </a:pPr>
+            <a:r>
+              <a:rPr lang="en-US" sz="1200" b="1" dirty="0">
+                <a:solidFill>
+                  <a:srgbClr val="FFFFFF"/>
+                </a:solidFill>
+                <a:latin typeface="Arial" panose="020B0604020202020204" pitchFamily="34" charset="0"/>
+                <a:ea typeface="Arial" panose="020B0604020202020204" pitchFamily="34" charset="-122"/>
+                <a:cs typeface="Arial" panose="020B0604020202020204" pitchFamily="34" charset="-120"/>
+              </a:rPr>
+              <a:t>4</a:t>
+            </a:r>
+            <a:endParaRPr lang="en-US" sz="1200" dirty="0"/>
+          </a:p>
+        </p:txBody>
+      </p:sp>
+      <p:sp>
+        <p:nvSpPr>
+          <p:cNvPr id="18" name="Text 10"/>
+          <p:cNvSpPr txBox="1"/>
+          <p:nvPr/>
+        </p:nvSpPr>
+        <p:spPr>
+          <a:xfrm>
+            <a:off x="1353312" y="4526280"/>
+            <a:ext cx="4023360" cy="621792"/>
+          </a:xfrm>
+          <a:prstGeom prst="rect">
+            <a:avLst/>
+          </a:prstGeom>
+          <a:noFill/>
+        </p:spPr>
+        <p:txBody>
+          <a:bodyPr wrap="square" lIns="0" tIns="0" rIns="0" bIns="0" rtlCol="0" anchor="ctr"/>
+          <a:lstStyle/>
+          <a:p>
+            <a:pPr marL="0" indent="0">
+              <a:lnSpc>
+                <a:spcPts val="1400"/>
+              </a:lnSpc>
+              <a:buNone/>
+            </a:pPr>
+            <a:r>
+              <a:rPr lang="en-US" sz="1100" dirty="0">
+                <a:solidFill>
+                  <a:srgbClr val="D6E6F5"/>
+                </a:solidFill>
+                <a:latin typeface="Arial" panose="020B0604020202020204" pitchFamily="34" charset="0"/>
+                <a:ea typeface="Arial" panose="020B0604020202020204" pitchFamily="34" charset="-122"/>
+                <a:cs typeface="Arial" panose="020B0604020202020204" pitchFamily="34" charset="-120"/>
+              </a:rPr>
+              <a:t>Disagreeing with it often makes it agree with you, which isn't the same as you being right.</a:t>
+            </a:r>
+            <a:endParaRPr lang="en-US" sz="1100" dirty="0"/>
+          </a:p>
+        </p:txBody>
+      </p:sp>
+      <p:sp>
+        <p:nvSpPr>
+          <p:cNvPr id="19" name="Shape 11"/>
           <p:cNvSpPr/>
           <p:nvPr/>
         </p:nvSpPr>
         <p:spPr>
           <a:xfrm>
-            <a:off x="6172200" y="1691640"/>
-            <a:ext cx="5074920" cy="3931920"/>
+            <a:off x="6172200" y="1920240"/>
+            <a:ext cx="5074920" cy="3429000"/>
           </a:xfrm>
           <a:prstGeom prst="roundRect">
             <a:avLst>
-              <a:gd name="adj" fmla="val 3488"/>
+              <a:gd name="adj" fmla="val 4000"/>
             </a:avLst>
           </a:prstGeom>
           <a:solidFill>
@@ -2036,13 +2395,13 @@
       </p:sp>
       <p:sp>
         <p:nvSpPr>
-          <p:cNvPr id="10" name="Text 6"/>
-          <p:cNvSpPr txBox="1"/>
-          <p:nvPr/>
-        </p:nvSpPr>
-        <p:spPr>
-          <a:xfrm>
-            <a:off x="6446520" y="1965960"/>
+          <p:cNvPr id="20" name="Text 12"/>
+          <p:cNvSpPr txBox="1"/>
+          <p:nvPr/>
+        </p:nvSpPr>
+        <p:spPr>
+          <a:xfrm>
+            <a:off x="6446520" y="2176272"/>
             <a:ext cx="4526280" cy="320040"/>
           </a:xfrm>
           <a:prstGeom prst="rect">
@@ -2066,129 +2425,94 @@
                 <a:ea typeface="Arial" panose="020B0604020202020204" pitchFamily="34" charset="-122"/>
                 <a:cs typeface="Arial" panose="020B0604020202020204" pitchFamily="34" charset="-120"/>
               </a:rPr>
-              <a:t>HOW TO STAY COVERED</a:t>
+              <a:t>HOW TO REDUCE IT: PROMPT FOR IT</a:t>
             </a:r>
             <a:endParaRPr lang="en-US" sz="1250" dirty="0"/>
           </a:p>
         </p:txBody>
       </p:sp>
-      <p:pic>
-        <p:nvPicPr>
-          <p:cNvPr id="11" name="Image 2" descr="/home/claude/work/assets/badge_gradient_teal.png"/>
-          <p:cNvPicPr>
-            <a:picLocks noChangeAspect="1"/>
-          </p:cNvPicPr>
-          <p:nvPr/>
-        </p:nvPicPr>
-        <p:blipFill>
-          <a:blip r:embed="rId3"/>
-          <a:stretch>
-            <a:fillRect/>
-          </a:stretch>
-        </p:blipFill>
-        <p:spPr>
-          <a:xfrm>
-            <a:off x="6446520" y="2468880"/>
-            <a:ext cx="365760" cy="365760"/>
-          </a:xfrm>
-          <a:prstGeom prst="rect">
-            <a:avLst/>
-          </a:prstGeom>
+      <p:sp>
+        <p:nvSpPr>
+          <p:cNvPr id="21" name="Text 13"/>
+          <p:cNvSpPr txBox="1"/>
+          <p:nvPr/>
+        </p:nvSpPr>
+        <p:spPr>
+          <a:xfrm>
+            <a:off x="6446520" y="2697480"/>
+            <a:ext cx="4526280" cy="320040"/>
+          </a:xfrm>
+          <a:prstGeom prst="rect">
+            <a:avLst/>
+          </a:prstGeom>
+          <a:noFill/>
+        </p:spPr>
+        <p:txBody>
+          <a:bodyPr wrap="square" lIns="0" tIns="0" rIns="0" bIns="0" rtlCol="0" anchor="ctr"/>
+          <a:lstStyle/>
+          <a:p>
+            <a:pPr marL="0" indent="0">
+              <a:buNone/>
+            </a:pPr>
+            <a:r>
+              <a:rPr lang="en-US" sz="1200" i="1" dirty="0">
+                <a:solidFill>
+                  <a:srgbClr val="56606E"/>
+                </a:solidFill>
+                <a:latin typeface="Arial" panose="020B0604020202020204" pitchFamily="34" charset="0"/>
+                <a:ea typeface="Arial" panose="020B0604020202020204" pitchFamily="34" charset="-122"/>
+                <a:cs typeface="Arial" panose="020B0604020202020204" pitchFamily="34" charset="-120"/>
+              </a:rPr>
+              <a:t>Try asking it this:</a:t>
+            </a:r>
+            <a:endParaRPr lang="en-US" sz="1200" dirty="0"/>
+          </a:p>
+        </p:txBody>
+      </p:sp>
+      <p:sp>
+        <p:nvSpPr>
+          <p:cNvPr id="22" name="Shape 14"/>
+          <p:cNvSpPr/>
+          <p:nvPr/>
+        </p:nvSpPr>
+        <p:spPr>
+          <a:xfrm>
+            <a:off x="6446520" y="3108960"/>
+            <a:ext cx="4526280" cy="1737360"/>
+          </a:xfrm>
+          <a:prstGeom prst="roundRect">
+            <a:avLst>
+              <a:gd name="adj" fmla="val 6316"/>
+            </a:avLst>
+          </a:prstGeom>
+          <a:solidFill>
+            <a:srgbClr val="FFFFFF"/>
+          </a:solidFill>
+          <a:ln w="12700">
+            <a:solidFill>
+              <a:srgbClr val="DCE4EF"/>
+            </a:solidFill>
+            <a:prstDash val="solid"/>
+          </a:ln>
           <a:effectLst>
-            <a:outerShdw blurRad="76200" dist="25400" dir="5400000" algn="bl" rotWithShape="0">
-              <a:srgbClr val="3A2E6E">
-                <a:alpha val="30000"/>
+            <a:outerShdw blurRad="101600" dist="38100" dir="5400000" algn="bl" rotWithShape="0">
+              <a:srgbClr val="1A2B33">
+                <a:alpha val="12000"/>
               </a:srgbClr>
             </a:outerShdw>
           </a:effectLst>
         </p:spPr>
-      </p:pic>
-      <p:sp>
-        <p:nvSpPr>
-          <p:cNvPr id="12" name="Text 7"/>
-          <p:cNvSpPr txBox="1"/>
-          <p:nvPr/>
-        </p:nvSpPr>
-        <p:spPr>
-          <a:xfrm>
-            <a:off x="6446520" y="2468880"/>
-            <a:ext cx="365760" cy="365760"/>
-          </a:xfrm>
-          <a:prstGeom prst="rect">
-            <a:avLst/>
-          </a:prstGeom>
-          <a:noFill/>
-        </p:spPr>
-        <p:txBody>
-          <a:bodyPr wrap="square" lIns="0" tIns="0" rIns="0" bIns="0" rtlCol="0" anchor="ctr"/>
-          <a:lstStyle/>
-          <a:p>
-            <a:pPr marL="0" indent="0" algn="ctr">
-              <a:buNone/>
-            </a:pPr>
-            <a:r>
-              <a:rPr lang="en-US" sz="1300" b="1" dirty="0">
-                <a:solidFill>
-                  <a:srgbClr val="FFFFFF"/>
-                </a:solidFill>
-                <a:latin typeface="Arial" panose="020B0604020202020204" pitchFamily="34" charset="0"/>
-                <a:ea typeface="Arial" panose="020B0604020202020204" pitchFamily="34" charset="-122"/>
-                <a:cs typeface="Arial" panose="020B0604020202020204" pitchFamily="34" charset="-120"/>
-              </a:rPr>
-              <a:t>1</a:t>
-            </a:r>
-            <a:endParaRPr lang="en-US" sz="1300" dirty="0"/>
-          </a:p>
-        </p:txBody>
-      </p:sp>
-      <p:sp>
-        <p:nvSpPr>
-          <p:cNvPr id="13" name="Text 8"/>
-          <p:cNvSpPr txBox="1"/>
-          <p:nvPr/>
-        </p:nvSpPr>
-        <p:spPr>
-          <a:xfrm>
-            <a:off x="6949440" y="2423160"/>
-            <a:ext cx="4023360" cy="274320"/>
-          </a:xfrm>
-          <a:prstGeom prst="rect">
-            <a:avLst/>
-          </a:prstGeom>
-          <a:noFill/>
-        </p:spPr>
-        <p:txBody>
-          <a:bodyPr wrap="square" lIns="0" tIns="0" rIns="0" bIns="0" rtlCol="0" anchor="ctr"/>
-          <a:lstStyle/>
-          <a:p>
-            <a:pPr marL="0" indent="0">
-              <a:buNone/>
-            </a:pPr>
-            <a:r>
-              <a:rPr lang="en-US" sz="1300" b="1" dirty="0">
-                <a:solidFill>
-                  <a:srgbClr val="00081D"/>
-                </a:solidFill>
-                <a:latin typeface="Arial" panose="020B0604020202020204" pitchFamily="34" charset="0"/>
-                <a:ea typeface="Arial" panose="020B0604020202020204" pitchFamily="34" charset="-122"/>
-                <a:cs typeface="Arial" panose="020B0604020202020204" pitchFamily="34" charset="-120"/>
-              </a:rPr>
-              <a:t>Edit it, don't just copy it.</a:t>
-            </a:r>
-            <a:endParaRPr lang="en-US" sz="1300" dirty="0"/>
-          </a:p>
-        </p:txBody>
-      </p:sp>
-      <p:sp>
-        <p:nvSpPr>
-          <p:cNvPr id="14" name="Text 9"/>
-          <p:cNvSpPr txBox="1"/>
-          <p:nvPr/>
-        </p:nvSpPr>
-        <p:spPr>
-          <a:xfrm>
-            <a:off x="6949440" y="2688336"/>
-            <a:ext cx="4023360" cy="457200"/>
+      </p:sp>
+      <p:sp>
+        <p:nvSpPr>
+          <p:cNvPr id="23" name="Text 15"/>
+          <p:cNvSpPr txBox="1"/>
+          <p:nvPr/>
+        </p:nvSpPr>
+        <p:spPr>
+          <a:xfrm>
+            <a:off x="6720840" y="3108960"/>
+            <a:ext cx="3977640" cy="1737360"/>
           </a:xfrm>
           <a:prstGeom prst="rect">
             <a:avLst/>
@@ -2201,119 +2525,12 @@
           <a:p>
             <a:pPr marL="0" indent="0">
               <a:lnSpc>
-                <a:spcPts val="1350"/>
+                <a:spcPts val="1900"/>
               </a:lnSpc>
               <a:buNone/>
             </a:pPr>
             <a:r>
-              <a:rPr lang="en-US" sz="1050" dirty="0">
-                <a:solidFill>
-                  <a:srgbClr val="56606E"/>
-                </a:solidFill>
-                <a:latin typeface="Arial" panose="020B0604020202020204" pitchFamily="34" charset="0"/>
-                <a:ea typeface="Arial" panose="020B0604020202020204" pitchFamily="34" charset="-122"/>
-                <a:cs typeface="Arial" panose="020B0604020202020204" pitchFamily="34" charset="-120"/>
-              </a:rPr>
-              <a:t>Real changes and choices are what make something actually yours.</a:t>
-            </a:r>
-            <a:endParaRPr lang="en-US" sz="1050" dirty="0"/>
-          </a:p>
-        </p:txBody>
-      </p:sp>
-      <p:pic>
-        <p:nvPicPr>
-          <p:cNvPr id="15" name="Image 3" descr="/home/claude/work/assets/badge_gradient_teal.png"/>
-          <p:cNvPicPr>
-            <a:picLocks noChangeAspect="1"/>
-          </p:cNvPicPr>
-          <p:nvPr/>
-        </p:nvPicPr>
-        <p:blipFill>
-          <a:blip r:embed="rId3"/>
-          <a:stretch>
-            <a:fillRect/>
-          </a:stretch>
-        </p:blipFill>
-        <p:spPr>
-          <a:xfrm>
-            <a:off x="6446520" y="3227832"/>
-            <a:ext cx="365760" cy="365760"/>
-          </a:xfrm>
-          <a:prstGeom prst="rect">
-            <a:avLst/>
-          </a:prstGeom>
-          <a:effectLst>
-            <a:outerShdw blurRad="76200" dist="25400" dir="5400000" algn="bl" rotWithShape="0">
-              <a:srgbClr val="3A2E6E">
-                <a:alpha val="30000"/>
-              </a:srgbClr>
-            </a:outerShdw>
-          </a:effectLst>
-        </p:spPr>
-      </p:pic>
-      <p:sp>
-        <p:nvSpPr>
-          <p:cNvPr id="16" name="Text 10"/>
-          <p:cNvSpPr txBox="1"/>
-          <p:nvPr/>
-        </p:nvSpPr>
-        <p:spPr>
-          <a:xfrm>
-            <a:off x="6446520" y="3227832"/>
-            <a:ext cx="365760" cy="365760"/>
-          </a:xfrm>
-          <a:prstGeom prst="rect">
-            <a:avLst/>
-          </a:prstGeom>
-          <a:noFill/>
-        </p:spPr>
-        <p:txBody>
-          <a:bodyPr wrap="square" lIns="0" tIns="0" rIns="0" bIns="0" rtlCol="0" anchor="ctr"/>
-          <a:lstStyle/>
-          <a:p>
-            <a:pPr marL="0" indent="0" algn="ctr">
-              <a:buNone/>
-            </a:pPr>
-            <a:r>
-              <a:rPr lang="en-US" sz="1300" b="1" dirty="0">
-                <a:solidFill>
-                  <a:srgbClr val="FFFFFF"/>
-                </a:solidFill>
-                <a:latin typeface="Arial" panose="020B0604020202020204" pitchFamily="34" charset="0"/>
-                <a:ea typeface="Arial" panose="020B0604020202020204" pitchFamily="34" charset="-122"/>
-                <a:cs typeface="Arial" panose="020B0604020202020204" pitchFamily="34" charset="-120"/>
-              </a:rPr>
-              <a:t>2</a:t>
-            </a:r>
-            <a:endParaRPr lang="en-US" sz="1300" dirty="0"/>
-          </a:p>
-        </p:txBody>
-      </p:sp>
-      <p:sp>
-        <p:nvSpPr>
-          <p:cNvPr id="17" name="Text 11"/>
-          <p:cNvSpPr txBox="1"/>
-          <p:nvPr/>
-        </p:nvSpPr>
-        <p:spPr>
-          <a:xfrm>
-            <a:off x="6949440" y="3182112"/>
-            <a:ext cx="4023360" cy="274320"/>
-          </a:xfrm>
-          <a:prstGeom prst="rect">
-            <a:avLst/>
-          </a:prstGeom>
-          <a:noFill/>
-        </p:spPr>
-        <p:txBody>
-          <a:bodyPr wrap="square" lIns="0" tIns="0" rIns="0" bIns="0" rtlCol="0" anchor="ctr"/>
-          <a:lstStyle/>
-          <a:p>
-            <a:pPr marL="0" indent="0">
-              <a:buNone/>
-            </a:pPr>
-            <a:r>
-              <a:rPr lang="en-US" sz="1300" b="1" dirty="0">
+              <a:rPr lang="en-US" sz="1350" i="1" dirty="0">
                 <a:solidFill>
                   <a:srgbClr val="00081D"/>
                 </a:solidFill>
@@ -2321,352 +2538,15 @@
                 <a:ea typeface="Arial" panose="020B0604020202020204" pitchFamily="34" charset="-122"/>
                 <a:cs typeface="Arial" panose="020B0604020202020204" pitchFamily="34" charset="-120"/>
               </a:rPr>
-              <a:t>Keep a record.</a:t>
-            </a:r>
-            <a:endParaRPr lang="en-US" sz="1300" dirty="0"/>
-          </a:p>
-        </p:txBody>
-      </p:sp>
-      <p:sp>
-        <p:nvSpPr>
-          <p:cNvPr id="18" name="Text 12"/>
-          <p:cNvSpPr txBox="1"/>
-          <p:nvPr/>
-        </p:nvSpPr>
-        <p:spPr>
-          <a:xfrm>
-            <a:off x="6949440" y="3447288"/>
-            <a:ext cx="4023360" cy="457200"/>
-          </a:xfrm>
-          <a:prstGeom prst="rect">
-            <a:avLst/>
-          </a:prstGeom>
-          <a:noFill/>
-        </p:spPr>
-        <p:txBody>
-          <a:bodyPr wrap="square" lIns="0" tIns="0" rIns="0" bIns="0" rtlCol="0" anchor="ctr"/>
-          <a:lstStyle/>
-          <a:p>
-            <a:pPr marL="0" indent="0">
-              <a:lnSpc>
-                <a:spcPts val="1350"/>
-              </a:lnSpc>
-              <a:buNone/>
-            </a:pPr>
-            <a:r>
-              <a:rPr lang="en-US" sz="1050" dirty="0">
-                <a:solidFill>
-                  <a:srgbClr val="56606E"/>
-                </a:solidFill>
-                <a:latin typeface="Arial" panose="020B0604020202020204" pitchFamily="34" charset="0"/>
-                <a:ea typeface="Arial" panose="020B0604020202020204" pitchFamily="34" charset="-122"/>
-                <a:cs typeface="Arial" panose="020B0604020202020204" pitchFamily="34" charset="-120"/>
-              </a:rPr>
-              <a:t>Note what was AI-drafted and what a person changed, especially for anything client-facing.</a:t>
-            </a:r>
-            <a:endParaRPr lang="en-US" sz="1050" dirty="0"/>
-          </a:p>
-        </p:txBody>
-      </p:sp>
-      <p:pic>
-        <p:nvPicPr>
-          <p:cNvPr id="19" name="Image 4" descr="/home/claude/work/assets/badge_gradient_teal.png"/>
-          <p:cNvPicPr>
-            <a:picLocks noChangeAspect="1"/>
-          </p:cNvPicPr>
-          <p:nvPr/>
-        </p:nvPicPr>
-        <p:blipFill>
-          <a:blip r:embed="rId3"/>
-          <a:stretch>
-            <a:fillRect/>
-          </a:stretch>
-        </p:blipFill>
-        <p:spPr>
-          <a:xfrm>
-            <a:off x="6446520" y="3986784"/>
-            <a:ext cx="365760" cy="365760"/>
-          </a:xfrm>
-          <a:prstGeom prst="rect">
-            <a:avLst/>
-          </a:prstGeom>
-          <a:effectLst>
-            <a:outerShdw blurRad="76200" dist="25400" dir="5400000" algn="bl" rotWithShape="0">
-              <a:srgbClr val="3A2E6E">
-                <a:alpha val="30000"/>
-              </a:srgbClr>
-            </a:outerShdw>
-          </a:effectLst>
-        </p:spPr>
-      </p:pic>
-      <p:sp>
-        <p:nvSpPr>
-          <p:cNvPr id="20" name="Text 13"/>
-          <p:cNvSpPr txBox="1"/>
-          <p:nvPr/>
-        </p:nvSpPr>
-        <p:spPr>
-          <a:xfrm>
-            <a:off x="6446520" y="3986784"/>
-            <a:ext cx="365760" cy="365760"/>
-          </a:xfrm>
-          <a:prstGeom prst="rect">
-            <a:avLst/>
-          </a:prstGeom>
-          <a:noFill/>
-        </p:spPr>
-        <p:txBody>
-          <a:bodyPr wrap="square" lIns="0" tIns="0" rIns="0" bIns="0" rtlCol="0" anchor="ctr"/>
-          <a:lstStyle/>
-          <a:p>
-            <a:pPr marL="0" indent="0" algn="ctr">
-              <a:buNone/>
-            </a:pPr>
-            <a:r>
-              <a:rPr lang="en-US" sz="1300" b="1" dirty="0">
-                <a:solidFill>
-                  <a:srgbClr val="FFFFFF"/>
-                </a:solidFill>
-                <a:latin typeface="Arial" panose="020B0604020202020204" pitchFamily="34" charset="0"/>
-                <a:ea typeface="Arial" panose="020B0604020202020204" pitchFamily="34" charset="-122"/>
-                <a:cs typeface="Arial" panose="020B0604020202020204" pitchFamily="34" charset="-120"/>
-              </a:rPr>
-              <a:t>3</a:t>
-            </a:r>
-            <a:endParaRPr lang="en-US" sz="1300" dirty="0"/>
-          </a:p>
-        </p:txBody>
-      </p:sp>
-      <p:sp>
-        <p:nvSpPr>
-          <p:cNvPr id="21" name="Text 14"/>
-          <p:cNvSpPr txBox="1"/>
-          <p:nvPr/>
-        </p:nvSpPr>
-        <p:spPr>
-          <a:xfrm>
-            <a:off x="6949440" y="3941064"/>
-            <a:ext cx="4023360" cy="274320"/>
-          </a:xfrm>
-          <a:prstGeom prst="rect">
-            <a:avLst/>
-          </a:prstGeom>
-          <a:noFill/>
-        </p:spPr>
-        <p:txBody>
-          <a:bodyPr wrap="square" lIns="0" tIns="0" rIns="0" bIns="0" rtlCol="0" anchor="ctr"/>
-          <a:lstStyle/>
-          <a:p>
-            <a:pPr marL="0" indent="0">
-              <a:buNone/>
-            </a:pPr>
-            <a:r>
-              <a:rPr lang="en-US" sz="1300" b="1" dirty="0">
-                <a:solidFill>
-                  <a:srgbClr val="00081D"/>
-                </a:solidFill>
-                <a:latin typeface="Arial" panose="020B0604020202020204" pitchFamily="34" charset="0"/>
-                <a:ea typeface="Arial" panose="020B0604020202020204" pitchFamily="34" charset="-122"/>
-                <a:cs typeface="Arial" panose="020B0604020202020204" pitchFamily="34" charset="-120"/>
-              </a:rPr>
-              <a:t>Don't publish it as-is.</a:t>
-            </a:r>
-            <a:endParaRPr lang="en-US" sz="1300" dirty="0"/>
-          </a:p>
-        </p:txBody>
-      </p:sp>
-      <p:sp>
-        <p:nvSpPr>
-          <p:cNvPr id="22" name="Text 15"/>
-          <p:cNvSpPr txBox="1"/>
-          <p:nvPr/>
-        </p:nvSpPr>
-        <p:spPr>
-          <a:xfrm>
-            <a:off x="6949440" y="4206240"/>
-            <a:ext cx="4023360" cy="457200"/>
-          </a:xfrm>
-          <a:prstGeom prst="rect">
-            <a:avLst/>
-          </a:prstGeom>
-          <a:noFill/>
-        </p:spPr>
-        <p:txBody>
-          <a:bodyPr wrap="square" lIns="0" tIns="0" rIns="0" bIns="0" rtlCol="0" anchor="ctr"/>
-          <a:lstStyle/>
-          <a:p>
-            <a:pPr marL="0" indent="0">
-              <a:lnSpc>
-                <a:spcPts val="1350"/>
-              </a:lnSpc>
-              <a:buNone/>
-            </a:pPr>
-            <a:r>
-              <a:rPr lang="en-US" sz="1050" dirty="0">
-                <a:solidFill>
-                  <a:srgbClr val="56606E"/>
-                </a:solidFill>
-                <a:latin typeface="Arial" panose="020B0604020202020204" pitchFamily="34" charset="0"/>
-                <a:ea typeface="Arial" panose="020B0604020202020204" pitchFamily="34" charset="-122"/>
-                <a:cs typeface="Arial" panose="020B0604020202020204" pitchFamily="34" charset="-120"/>
-              </a:rPr>
-              <a:t>Not under the company's name, for anything that matters legally or commercially.</a:t>
-            </a:r>
-            <a:endParaRPr lang="en-US" sz="1050" dirty="0"/>
-          </a:p>
-        </p:txBody>
-      </p:sp>
-      <p:pic>
-        <p:nvPicPr>
-          <p:cNvPr id="23" name="Image 5" descr="/home/claude/work/assets/badge_gradient_teal.png"/>
-          <p:cNvPicPr>
-            <a:picLocks noChangeAspect="1"/>
-          </p:cNvPicPr>
-          <p:nvPr/>
-        </p:nvPicPr>
-        <p:blipFill>
-          <a:blip r:embed="rId3"/>
-          <a:stretch>
-            <a:fillRect/>
-          </a:stretch>
-        </p:blipFill>
-        <p:spPr>
-          <a:xfrm>
-            <a:off x="6446520" y="4745736"/>
-            <a:ext cx="365760" cy="365760"/>
-          </a:xfrm>
-          <a:prstGeom prst="rect">
-            <a:avLst/>
-          </a:prstGeom>
-          <a:effectLst>
-            <a:outerShdw blurRad="76200" dist="25400" dir="5400000" algn="bl" rotWithShape="0">
-              <a:srgbClr val="3A2E6E">
-                <a:alpha val="30000"/>
-              </a:srgbClr>
-            </a:outerShdw>
-          </a:effectLst>
-        </p:spPr>
-      </p:pic>
+              <a:t>“Always tell me where this comes from. If you don't have a real source, or you're not sure, say so instead of guessing.”</a:t>
+            </a:r>
+            <a:endParaRPr lang="en-US" sz="1350" dirty="0"/>
+          </a:p>
+        </p:txBody>
+      </p:sp>
       <p:sp>
         <p:nvSpPr>
           <p:cNvPr id="24" name="Text 16"/>
-          <p:cNvSpPr txBox="1"/>
-          <p:nvPr/>
-        </p:nvSpPr>
-        <p:spPr>
-          <a:xfrm>
-            <a:off x="6446520" y="4745736"/>
-            <a:ext cx="365760" cy="365760"/>
-          </a:xfrm>
-          <a:prstGeom prst="rect">
-            <a:avLst/>
-          </a:prstGeom>
-          <a:noFill/>
-        </p:spPr>
-        <p:txBody>
-          <a:bodyPr wrap="square" lIns="0" tIns="0" rIns="0" bIns="0" rtlCol="0" anchor="ctr"/>
-          <a:lstStyle/>
-          <a:p>
-            <a:pPr marL="0" indent="0" algn="ctr">
-              <a:buNone/>
-            </a:pPr>
-            <a:r>
-              <a:rPr lang="en-US" sz="1300" b="1" dirty="0">
-                <a:solidFill>
-                  <a:srgbClr val="FFFFFF"/>
-                </a:solidFill>
-                <a:latin typeface="Arial" panose="020B0604020202020204" pitchFamily="34" charset="0"/>
-                <a:ea typeface="Arial" panose="020B0604020202020204" pitchFamily="34" charset="-122"/>
-                <a:cs typeface="Arial" panose="020B0604020202020204" pitchFamily="34" charset="-120"/>
-              </a:rPr>
-              <a:t>4</a:t>
-            </a:r>
-            <a:endParaRPr lang="en-US" sz="1300" dirty="0"/>
-          </a:p>
-        </p:txBody>
-      </p:sp>
-      <p:sp>
-        <p:nvSpPr>
-          <p:cNvPr id="25" name="Text 17"/>
-          <p:cNvSpPr txBox="1"/>
-          <p:nvPr/>
-        </p:nvSpPr>
-        <p:spPr>
-          <a:xfrm>
-            <a:off x="6949440" y="4700016"/>
-            <a:ext cx="4023360" cy="274320"/>
-          </a:xfrm>
-          <a:prstGeom prst="rect">
-            <a:avLst/>
-          </a:prstGeom>
-          <a:noFill/>
-        </p:spPr>
-        <p:txBody>
-          <a:bodyPr wrap="square" lIns="0" tIns="0" rIns="0" bIns="0" rtlCol="0" anchor="ctr"/>
-          <a:lstStyle/>
-          <a:p>
-            <a:pPr marL="0" indent="0">
-              <a:buNone/>
-            </a:pPr>
-            <a:r>
-              <a:rPr lang="en-US" sz="1300" b="1" dirty="0">
-                <a:solidFill>
-                  <a:srgbClr val="00081D"/>
-                </a:solidFill>
-                <a:latin typeface="Arial" panose="020B0604020202020204" pitchFamily="34" charset="0"/>
-                <a:ea typeface="Arial" panose="020B0604020202020204" pitchFamily="34" charset="-122"/>
-                <a:cs typeface="Arial" panose="020B0604020202020204" pitchFamily="34" charset="-120"/>
-              </a:rPr>
-              <a:t>Ask when it's not obvious.</a:t>
-            </a:r>
-            <a:endParaRPr lang="en-US" sz="1300" dirty="0"/>
-          </a:p>
-        </p:txBody>
-      </p:sp>
-      <p:sp>
-        <p:nvSpPr>
-          <p:cNvPr id="26" name="Text 18"/>
-          <p:cNvSpPr txBox="1"/>
-          <p:nvPr/>
-        </p:nvSpPr>
-        <p:spPr>
-          <a:xfrm>
-            <a:off x="6949440" y="4965192"/>
-            <a:ext cx="4023360" cy="457200"/>
-          </a:xfrm>
-          <a:prstGeom prst="rect">
-            <a:avLst/>
-          </a:prstGeom>
-          <a:noFill/>
-        </p:spPr>
-        <p:txBody>
-          <a:bodyPr wrap="square" lIns="0" tIns="0" rIns="0" bIns="0" rtlCol="0" anchor="ctr"/>
-          <a:lstStyle/>
-          <a:p>
-            <a:pPr marL="0" indent="0">
-              <a:lnSpc>
-                <a:spcPts val="1350"/>
-              </a:lnSpc>
-              <a:buNone/>
-            </a:pPr>
-            <a:r>
-              <a:rPr lang="en-US" sz="1050" dirty="0">
-                <a:solidFill>
-                  <a:srgbClr val="56606E"/>
-                </a:solidFill>
-                <a:latin typeface="Arial" panose="020B0604020202020204" pitchFamily="34" charset="0"/>
-                <a:ea typeface="Arial" panose="020B0604020202020204" pitchFamily="34" charset="-122"/>
-                <a:cs typeface="Arial" panose="020B0604020202020204" pitchFamily="34" charset="-120"/>
-              </a:rPr>
-              <a:t>Check with Legal or Compliance before your name, or the company's, goes on AI-written material.</a:t>
-            </a:r>
-            <a:endParaRPr lang="en-US" sz="1050" dirty="0"/>
-          </a:p>
-        </p:txBody>
-      </p:sp>
-      <p:sp>
-        <p:nvSpPr>
-          <p:cNvPr id="27" name="Text 19"/>
           <p:cNvSpPr txBox="1"/>
           <p:nvPr/>
         </p:nvSpPr>
@@ -2711,6 +2591,986 @@
 </file>
 
 <file path=ppt/slides/slide11.xml><?xml version="1.0" encoding="utf-8"?>
+<p:sld xmlns:a="http://schemas.openxmlformats.org/drawingml/2006/main" xmlns:r="http://schemas.openxmlformats.org/officeDocument/2006/relationships" xmlns:p="http://schemas.openxmlformats.org/presentationml/2006/main">
+  <p:cSld>
+    <p:bg>
+      <p:bgPr>
+        <a:solidFill>
+          <a:srgbClr val="FFFFFF"/>
+        </a:solidFill>
+        <a:effectLst/>
+      </p:bgPr>
+    </p:bg>
+    <p:spTree>
+      <p:nvGrpSpPr>
+        <p:cNvPr id="1" name=""/>
+        <p:cNvGrpSpPr/>
+        <p:nvPr/>
+      </p:nvGrpSpPr>
+      <p:grpSpPr>
+        <a:xfrm>
+          <a:off x="0" y="0"/>
+          <a:ext cx="0" cy="0"/>
+          <a:chOff x="0" y="0"/>
+          <a:chExt cx="0" cy="0"/>
+        </a:xfrm>
+      </p:grpSpPr>
+      <p:pic>
+        <p:nvPicPr>
+          <p:cNvPr id="2" name="Image 0" descr="/home/claude/work/assets/tpl_content.jpg"/>
+          <p:cNvPicPr>
+            <a:picLocks noChangeAspect="1"/>
+          </p:cNvPicPr>
+          <p:nvPr/>
+        </p:nvPicPr>
+        <p:blipFill>
+          <a:blip r:embed="rId1"/>
+          <a:stretch>
+            <a:fillRect/>
+          </a:stretch>
+        </p:blipFill>
+        <p:spPr>
+          <a:xfrm>
+            <a:off x="0" y="0"/>
+            <a:ext cx="12188952" cy="6858000"/>
+          </a:xfrm>
+          <a:prstGeom prst="rect">
+            <a:avLst/>
+          </a:prstGeom>
+        </p:spPr>
+      </p:pic>
+      <p:sp>
+        <p:nvSpPr>
+          <p:cNvPr id="3" name="Text 0"/>
+          <p:cNvSpPr txBox="1"/>
+          <p:nvPr/>
+        </p:nvSpPr>
+        <p:spPr>
+          <a:xfrm>
+            <a:off x="320040" y="219456"/>
+            <a:ext cx="10607040" cy="731520"/>
+          </a:xfrm>
+          <a:prstGeom prst="rect">
+            <a:avLst/>
+          </a:prstGeom>
+          <a:noFill/>
+        </p:spPr>
+        <p:txBody>
+          <a:bodyPr wrap="square" lIns="0" tIns="0" rIns="0" bIns="0" rtlCol="0" anchor="ctr"/>
+          <a:lstStyle/>
+          <a:p>
+            <a:pPr marL="0" indent="0" algn="ctr">
+              <a:buNone/>
+            </a:pPr>
+            <a:r>
+              <a:rPr lang="en-US" sz="3000" dirty="0">
+                <a:solidFill>
+                  <a:srgbClr val="FFFFFF"/>
+                </a:solidFill>
+                <a:latin typeface="Arial" panose="020B0604020202020204" pitchFamily="34" charset="0"/>
+                <a:ea typeface="Arial" panose="020B0604020202020204" pitchFamily="34" charset="-122"/>
+                <a:cs typeface="Arial" panose="020B0604020202020204" pitchFamily="34" charset="-120"/>
+              </a:rPr>
+              <a:t>Who owns what it writes?</a:t>
+            </a:r>
+            <a:endParaRPr lang="en-US" sz="3000" dirty="0"/>
+          </a:p>
+        </p:txBody>
+      </p:sp>
+      <p:sp>
+        <p:nvSpPr>
+          <p:cNvPr id="4" name="Text 1"/>
+          <p:cNvSpPr txBox="1"/>
+          <p:nvPr/>
+        </p:nvSpPr>
+        <p:spPr>
+          <a:xfrm>
+            <a:off x="640080" y="1298448"/>
+            <a:ext cx="10881360" cy="320040"/>
+          </a:xfrm>
+          <a:prstGeom prst="rect">
+            <a:avLst/>
+          </a:prstGeom>
+          <a:noFill/>
+        </p:spPr>
+        <p:txBody>
+          <a:bodyPr wrap="square" lIns="0" tIns="0" rIns="0" bIns="0" rtlCol="0" anchor="ctr"/>
+          <a:lstStyle/>
+          <a:p>
+            <a:pPr marL="0" indent="0" algn="ctr">
+              <a:buNone/>
+            </a:pPr>
+            <a:r>
+              <a:rPr lang="en-US" sz="1300" i="1" dirty="0">
+                <a:solidFill>
+                  <a:srgbClr val="56606E"/>
+                </a:solidFill>
+                <a:latin typeface="Arial" panose="020B0604020202020204" pitchFamily="34" charset="0"/>
+                <a:ea typeface="Arial" panose="020B0604020202020204" pitchFamily="34" charset="-122"/>
+                <a:cs typeface="Arial" panose="020B0604020202020204" pitchFamily="34" charset="-120"/>
+              </a:rPr>
+              <a:t>Ownership of AI-written material is still an open legal question, treat it that way.</a:t>
+            </a:r>
+            <a:endParaRPr lang="en-US" sz="1300" dirty="0"/>
+          </a:p>
+        </p:txBody>
+      </p:sp>
+      <p:pic>
+        <p:nvPicPr>
+          <p:cNvPr id="5" name="Image 1" descr="/home/claude/work/assets/panel_5.55x4.30.png"/>
+          <p:cNvPicPr>
+            <a:picLocks noChangeAspect="1"/>
+          </p:cNvPicPr>
+          <p:nvPr/>
+        </p:nvPicPr>
+        <p:blipFill>
+          <a:blip r:embed="rId2"/>
+          <a:stretch>
+            <a:fillRect/>
+          </a:stretch>
+        </p:blipFill>
+        <p:spPr>
+          <a:xfrm>
+            <a:off x="640080" y="1691640"/>
+            <a:ext cx="5074920" cy="3931920"/>
+          </a:xfrm>
+          <a:prstGeom prst="rect">
+            <a:avLst/>
+          </a:prstGeom>
+          <a:effectLst>
+            <a:outerShdw blurRad="203200" dist="63500" dir="5400000" algn="bl" rotWithShape="0">
+              <a:srgbClr val="3A2E6E">
+                <a:alpha val="35000"/>
+              </a:srgbClr>
+            </a:outerShdw>
+          </a:effectLst>
+        </p:spPr>
+      </p:pic>
+      <p:sp>
+        <p:nvSpPr>
+          <p:cNvPr id="6" name="Text 2"/>
+          <p:cNvSpPr txBox="1"/>
+          <p:nvPr/>
+        </p:nvSpPr>
+        <p:spPr>
+          <a:xfrm>
+            <a:off x="914400" y="1965960"/>
+            <a:ext cx="4526280" cy="320040"/>
+          </a:xfrm>
+          <a:prstGeom prst="rect">
+            <a:avLst/>
+          </a:prstGeom>
+          <a:noFill/>
+        </p:spPr>
+        <p:txBody>
+          <a:bodyPr wrap="square" lIns="0" tIns="0" rIns="0" bIns="0" rtlCol="0" anchor="ctr"/>
+          <a:lstStyle/>
+          <a:p>
+            <a:pPr marL="0" indent="0">
+              <a:buNone/>
+            </a:pPr>
+            <a:r>
+              <a:rPr lang="en-US" sz="1250" b="1" kern="0" spc="100" dirty="0">
+                <a:solidFill>
+                  <a:srgbClr val="4592EF"/>
+                </a:solidFill>
+                <a:latin typeface="Arial" panose="020B0604020202020204" pitchFamily="34" charset="0"/>
+                <a:ea typeface="Arial" panose="020B0604020202020204" pitchFamily="34" charset="-122"/>
+                <a:cs typeface="Arial" panose="020B0604020202020204" pitchFamily="34" charset="-120"/>
+              </a:rPr>
+              <a:t>THE SHORT VERSION</a:t>
+            </a:r>
+            <a:endParaRPr lang="en-US" sz="1250" dirty="0"/>
+          </a:p>
+        </p:txBody>
+      </p:sp>
+      <p:sp>
+        <p:nvSpPr>
+          <p:cNvPr id="7" name="Text 3"/>
+          <p:cNvSpPr txBox="1"/>
+          <p:nvPr/>
+        </p:nvSpPr>
+        <p:spPr>
+          <a:xfrm>
+            <a:off x="914400" y="2423160"/>
+            <a:ext cx="4526280" cy="1463040"/>
+          </a:xfrm>
+          <a:prstGeom prst="rect">
+            <a:avLst/>
+          </a:prstGeom>
+          <a:noFill/>
+        </p:spPr>
+        <p:txBody>
+          <a:bodyPr wrap="square" lIns="0" tIns="0" rIns="0" bIns="0" rtlCol="0" anchor="ctr"/>
+          <a:lstStyle/>
+          <a:p>
+            <a:pPr marL="0" indent="0">
+              <a:lnSpc>
+                <a:spcPts val="1800"/>
+              </a:lnSpc>
+              <a:buNone/>
+            </a:pPr>
+            <a:r>
+              <a:rPr lang="en-US" sz="1300" dirty="0">
+                <a:solidFill>
+                  <a:srgbClr val="D6E6F5"/>
+                </a:solidFill>
+                <a:latin typeface="Arial" panose="020B0604020202020204" pitchFamily="34" charset="0"/>
+                <a:ea typeface="Arial" panose="020B0604020202020204" pitchFamily="34" charset="-122"/>
+                <a:cs typeface="Arial" panose="020B0604020202020204" pitchFamily="34" charset="-120"/>
+              </a:rPr>
+              <a:t>Courts have been ruling that something purely AI-written isn't protected by copyright at all, only the parts where a person actually made the creative decisions. Typing a good prompt, or picking your favorite draft out of a few, doesn't count as authorship on its own.</a:t>
+            </a:r>
+            <a:endParaRPr lang="en-US" sz="1300" dirty="0"/>
+          </a:p>
+        </p:txBody>
+      </p:sp>
+      <p:sp>
+        <p:nvSpPr>
+          <p:cNvPr id="8" name="Text 4"/>
+          <p:cNvSpPr txBox="1"/>
+          <p:nvPr/>
+        </p:nvSpPr>
+        <p:spPr>
+          <a:xfrm>
+            <a:off x="914400" y="4572000"/>
+            <a:ext cx="4526280" cy="868680"/>
+          </a:xfrm>
+          <a:prstGeom prst="rect">
+            <a:avLst/>
+          </a:prstGeom>
+          <a:noFill/>
+        </p:spPr>
+        <p:txBody>
+          <a:bodyPr wrap="square" lIns="0" tIns="0" rIns="0" bIns="0" rtlCol="0" anchor="ctr"/>
+          <a:lstStyle/>
+          <a:p>
+            <a:pPr marL="0" indent="0">
+              <a:lnSpc>
+                <a:spcPts val="1600"/>
+              </a:lnSpc>
+              <a:buNone/>
+            </a:pPr>
+            <a:r>
+              <a:rPr lang="en-US" sz="1200" i="1" dirty="0">
+                <a:solidFill>
+                  <a:srgbClr val="D6E6F5"/>
+                </a:solidFill>
+                <a:latin typeface="Arial" panose="020B0604020202020204" pitchFamily="34" charset="0"/>
+                <a:ea typeface="Arial" panose="020B0604020202020204" pitchFamily="34" charset="-122"/>
+                <a:cs typeface="Arial" panose="020B0604020202020204" pitchFamily="34" charset="-120"/>
+              </a:rPr>
+              <a:t>In practice: a report or client note that's mostly untouched AI output may not be something the company can fully claim as its own work, or stop someone else from copying.</a:t>
+            </a:r>
+            <a:endParaRPr lang="en-US" sz="1200" dirty="0"/>
+          </a:p>
+        </p:txBody>
+      </p:sp>
+      <p:sp>
+        <p:nvSpPr>
+          <p:cNvPr id="9" name="Shape 5"/>
+          <p:cNvSpPr/>
+          <p:nvPr/>
+        </p:nvSpPr>
+        <p:spPr>
+          <a:xfrm>
+            <a:off x="6172200" y="1691640"/>
+            <a:ext cx="5074920" cy="3931920"/>
+          </a:xfrm>
+          <a:prstGeom prst="roundRect">
+            <a:avLst>
+              <a:gd name="adj" fmla="val 3488"/>
+            </a:avLst>
+          </a:prstGeom>
+          <a:solidFill>
+            <a:srgbClr val="F2F5FA"/>
+          </a:solidFill>
+          <a:effectLst>
+            <a:outerShdw blurRad="101600" dist="38100" dir="5400000" algn="bl" rotWithShape="0">
+              <a:srgbClr val="1A2B33">
+                <a:alpha val="12000"/>
+              </a:srgbClr>
+            </a:outerShdw>
+          </a:effectLst>
+        </p:spPr>
+      </p:sp>
+      <p:sp>
+        <p:nvSpPr>
+          <p:cNvPr id="10" name="Text 6"/>
+          <p:cNvSpPr txBox="1"/>
+          <p:nvPr/>
+        </p:nvSpPr>
+        <p:spPr>
+          <a:xfrm>
+            <a:off x="6446520" y="1965960"/>
+            <a:ext cx="4526280" cy="320040"/>
+          </a:xfrm>
+          <a:prstGeom prst="rect">
+            <a:avLst/>
+          </a:prstGeom>
+          <a:noFill/>
+        </p:spPr>
+        <p:txBody>
+          <a:bodyPr wrap="square" lIns="0" tIns="0" rIns="0" bIns="0" rtlCol="0" anchor="ctr"/>
+          <a:lstStyle/>
+          <a:p>
+            <a:pPr marL="0" indent="0">
+              <a:buNone/>
+            </a:pPr>
+            <a:r>
+              <a:rPr lang="en-US" sz="1250" b="1" kern="0" spc="100" dirty="0">
+                <a:solidFill>
+                  <a:srgbClr val="2CB2D7"/>
+                </a:solidFill>
+                <a:latin typeface="Arial" panose="020B0604020202020204" pitchFamily="34" charset="0"/>
+                <a:ea typeface="Arial" panose="020B0604020202020204" pitchFamily="34" charset="-122"/>
+                <a:cs typeface="Arial" panose="020B0604020202020204" pitchFamily="34" charset="-120"/>
+              </a:rPr>
+              <a:t>HOW TO STAY COVERED</a:t>
+            </a:r>
+            <a:endParaRPr lang="en-US" sz="1250" dirty="0"/>
+          </a:p>
+        </p:txBody>
+      </p:sp>
+      <p:pic>
+        <p:nvPicPr>
+          <p:cNvPr id="11" name="Image 2" descr="/home/claude/work/assets/badge_gradient_teal.png"/>
+          <p:cNvPicPr>
+            <a:picLocks noChangeAspect="1"/>
+          </p:cNvPicPr>
+          <p:nvPr/>
+        </p:nvPicPr>
+        <p:blipFill>
+          <a:blip r:embed="rId3"/>
+          <a:stretch>
+            <a:fillRect/>
+          </a:stretch>
+        </p:blipFill>
+        <p:spPr>
+          <a:xfrm>
+            <a:off x="6446520" y="2468880"/>
+            <a:ext cx="365760" cy="365760"/>
+          </a:xfrm>
+          <a:prstGeom prst="rect">
+            <a:avLst/>
+          </a:prstGeom>
+          <a:effectLst>
+            <a:outerShdw blurRad="76200" dist="25400" dir="5400000" algn="bl" rotWithShape="0">
+              <a:srgbClr val="3A2E6E">
+                <a:alpha val="30000"/>
+              </a:srgbClr>
+            </a:outerShdw>
+          </a:effectLst>
+        </p:spPr>
+      </p:pic>
+      <p:sp>
+        <p:nvSpPr>
+          <p:cNvPr id="12" name="Text 7"/>
+          <p:cNvSpPr txBox="1"/>
+          <p:nvPr/>
+        </p:nvSpPr>
+        <p:spPr>
+          <a:xfrm>
+            <a:off x="6446520" y="2468880"/>
+            <a:ext cx="365760" cy="365760"/>
+          </a:xfrm>
+          <a:prstGeom prst="rect">
+            <a:avLst/>
+          </a:prstGeom>
+          <a:noFill/>
+        </p:spPr>
+        <p:txBody>
+          <a:bodyPr wrap="square" lIns="0" tIns="0" rIns="0" bIns="0" rtlCol="0" anchor="ctr"/>
+          <a:lstStyle/>
+          <a:p>
+            <a:pPr marL="0" indent="0" algn="ctr">
+              <a:buNone/>
+            </a:pPr>
+            <a:r>
+              <a:rPr lang="en-US" sz="1300" b="1" dirty="0">
+                <a:solidFill>
+                  <a:srgbClr val="FFFFFF"/>
+                </a:solidFill>
+                <a:latin typeface="Arial" panose="020B0604020202020204" pitchFamily="34" charset="0"/>
+                <a:ea typeface="Arial" panose="020B0604020202020204" pitchFamily="34" charset="-122"/>
+                <a:cs typeface="Arial" panose="020B0604020202020204" pitchFamily="34" charset="-120"/>
+              </a:rPr>
+              <a:t>1</a:t>
+            </a:r>
+            <a:endParaRPr lang="en-US" sz="1300" dirty="0"/>
+          </a:p>
+        </p:txBody>
+      </p:sp>
+      <p:sp>
+        <p:nvSpPr>
+          <p:cNvPr id="13" name="Text 8"/>
+          <p:cNvSpPr txBox="1"/>
+          <p:nvPr/>
+        </p:nvSpPr>
+        <p:spPr>
+          <a:xfrm>
+            <a:off x="6949440" y="2423160"/>
+            <a:ext cx="4023360" cy="274320"/>
+          </a:xfrm>
+          <a:prstGeom prst="rect">
+            <a:avLst/>
+          </a:prstGeom>
+          <a:noFill/>
+        </p:spPr>
+        <p:txBody>
+          <a:bodyPr wrap="square" lIns="0" tIns="0" rIns="0" bIns="0" rtlCol="0" anchor="ctr"/>
+          <a:lstStyle/>
+          <a:p>
+            <a:pPr marL="0" indent="0">
+              <a:buNone/>
+            </a:pPr>
+            <a:r>
+              <a:rPr lang="en-US" sz="1300" b="1" dirty="0">
+                <a:solidFill>
+                  <a:srgbClr val="00081D"/>
+                </a:solidFill>
+                <a:latin typeface="Arial" panose="020B0604020202020204" pitchFamily="34" charset="0"/>
+                <a:ea typeface="Arial" panose="020B0604020202020204" pitchFamily="34" charset="-122"/>
+                <a:cs typeface="Arial" panose="020B0604020202020204" pitchFamily="34" charset="-120"/>
+              </a:rPr>
+              <a:t>Edit it, don't just copy it.</a:t>
+            </a:r>
+            <a:endParaRPr lang="en-US" sz="1300" dirty="0"/>
+          </a:p>
+        </p:txBody>
+      </p:sp>
+      <p:sp>
+        <p:nvSpPr>
+          <p:cNvPr id="14" name="Text 9"/>
+          <p:cNvSpPr txBox="1"/>
+          <p:nvPr/>
+        </p:nvSpPr>
+        <p:spPr>
+          <a:xfrm>
+            <a:off x="6949440" y="2688336"/>
+            <a:ext cx="4023360" cy="457200"/>
+          </a:xfrm>
+          <a:prstGeom prst="rect">
+            <a:avLst/>
+          </a:prstGeom>
+          <a:noFill/>
+        </p:spPr>
+        <p:txBody>
+          <a:bodyPr wrap="square" lIns="0" tIns="0" rIns="0" bIns="0" rtlCol="0" anchor="ctr"/>
+          <a:lstStyle/>
+          <a:p>
+            <a:pPr marL="0" indent="0">
+              <a:lnSpc>
+                <a:spcPts val="1350"/>
+              </a:lnSpc>
+              <a:buNone/>
+            </a:pPr>
+            <a:r>
+              <a:rPr lang="en-US" sz="1050" dirty="0">
+                <a:solidFill>
+                  <a:srgbClr val="56606E"/>
+                </a:solidFill>
+                <a:latin typeface="Arial" panose="020B0604020202020204" pitchFamily="34" charset="0"/>
+                <a:ea typeface="Arial" panose="020B0604020202020204" pitchFamily="34" charset="-122"/>
+                <a:cs typeface="Arial" panose="020B0604020202020204" pitchFamily="34" charset="-120"/>
+              </a:rPr>
+              <a:t>Real changes and choices are what make something actually yours.</a:t>
+            </a:r>
+            <a:endParaRPr lang="en-US" sz="1050" dirty="0"/>
+          </a:p>
+        </p:txBody>
+      </p:sp>
+      <p:pic>
+        <p:nvPicPr>
+          <p:cNvPr id="15" name="Image 3" descr="/home/claude/work/assets/badge_gradient_teal.png"/>
+          <p:cNvPicPr>
+            <a:picLocks noChangeAspect="1"/>
+          </p:cNvPicPr>
+          <p:nvPr/>
+        </p:nvPicPr>
+        <p:blipFill>
+          <a:blip r:embed="rId3"/>
+          <a:stretch>
+            <a:fillRect/>
+          </a:stretch>
+        </p:blipFill>
+        <p:spPr>
+          <a:xfrm>
+            <a:off x="6446520" y="3227832"/>
+            <a:ext cx="365760" cy="365760"/>
+          </a:xfrm>
+          <a:prstGeom prst="rect">
+            <a:avLst/>
+          </a:prstGeom>
+          <a:effectLst>
+            <a:outerShdw blurRad="76200" dist="25400" dir="5400000" algn="bl" rotWithShape="0">
+              <a:srgbClr val="3A2E6E">
+                <a:alpha val="30000"/>
+              </a:srgbClr>
+            </a:outerShdw>
+          </a:effectLst>
+        </p:spPr>
+      </p:pic>
+      <p:sp>
+        <p:nvSpPr>
+          <p:cNvPr id="16" name="Text 10"/>
+          <p:cNvSpPr txBox="1"/>
+          <p:nvPr/>
+        </p:nvSpPr>
+        <p:spPr>
+          <a:xfrm>
+            <a:off x="6446520" y="3227832"/>
+            <a:ext cx="365760" cy="365760"/>
+          </a:xfrm>
+          <a:prstGeom prst="rect">
+            <a:avLst/>
+          </a:prstGeom>
+          <a:noFill/>
+        </p:spPr>
+        <p:txBody>
+          <a:bodyPr wrap="square" lIns="0" tIns="0" rIns="0" bIns="0" rtlCol="0" anchor="ctr"/>
+          <a:lstStyle/>
+          <a:p>
+            <a:pPr marL="0" indent="0" algn="ctr">
+              <a:buNone/>
+            </a:pPr>
+            <a:r>
+              <a:rPr lang="en-US" sz="1300" b="1" dirty="0">
+                <a:solidFill>
+                  <a:srgbClr val="FFFFFF"/>
+                </a:solidFill>
+                <a:latin typeface="Arial" panose="020B0604020202020204" pitchFamily="34" charset="0"/>
+                <a:ea typeface="Arial" panose="020B0604020202020204" pitchFamily="34" charset="-122"/>
+                <a:cs typeface="Arial" panose="020B0604020202020204" pitchFamily="34" charset="-120"/>
+              </a:rPr>
+              <a:t>2</a:t>
+            </a:r>
+            <a:endParaRPr lang="en-US" sz="1300" dirty="0"/>
+          </a:p>
+        </p:txBody>
+      </p:sp>
+      <p:sp>
+        <p:nvSpPr>
+          <p:cNvPr id="17" name="Text 11"/>
+          <p:cNvSpPr txBox="1"/>
+          <p:nvPr/>
+        </p:nvSpPr>
+        <p:spPr>
+          <a:xfrm>
+            <a:off x="6949440" y="3182112"/>
+            <a:ext cx="4023360" cy="274320"/>
+          </a:xfrm>
+          <a:prstGeom prst="rect">
+            <a:avLst/>
+          </a:prstGeom>
+          <a:noFill/>
+        </p:spPr>
+        <p:txBody>
+          <a:bodyPr wrap="square" lIns="0" tIns="0" rIns="0" bIns="0" rtlCol="0" anchor="ctr"/>
+          <a:lstStyle/>
+          <a:p>
+            <a:pPr marL="0" indent="0">
+              <a:buNone/>
+            </a:pPr>
+            <a:r>
+              <a:rPr lang="en-US" sz="1300" b="1" dirty="0">
+                <a:solidFill>
+                  <a:srgbClr val="00081D"/>
+                </a:solidFill>
+                <a:latin typeface="Arial" panose="020B0604020202020204" pitchFamily="34" charset="0"/>
+                <a:ea typeface="Arial" panose="020B0604020202020204" pitchFamily="34" charset="-122"/>
+                <a:cs typeface="Arial" panose="020B0604020202020204" pitchFamily="34" charset="-120"/>
+              </a:rPr>
+              <a:t>Keep a record.</a:t>
+            </a:r>
+            <a:endParaRPr lang="en-US" sz="1300" dirty="0"/>
+          </a:p>
+        </p:txBody>
+      </p:sp>
+      <p:sp>
+        <p:nvSpPr>
+          <p:cNvPr id="18" name="Text 12"/>
+          <p:cNvSpPr txBox="1"/>
+          <p:nvPr/>
+        </p:nvSpPr>
+        <p:spPr>
+          <a:xfrm>
+            <a:off x="6949440" y="3447288"/>
+            <a:ext cx="4023360" cy="457200"/>
+          </a:xfrm>
+          <a:prstGeom prst="rect">
+            <a:avLst/>
+          </a:prstGeom>
+          <a:noFill/>
+        </p:spPr>
+        <p:txBody>
+          <a:bodyPr wrap="square" lIns="0" tIns="0" rIns="0" bIns="0" rtlCol="0" anchor="ctr"/>
+          <a:lstStyle/>
+          <a:p>
+            <a:pPr marL="0" indent="0">
+              <a:lnSpc>
+                <a:spcPts val="1350"/>
+              </a:lnSpc>
+              <a:buNone/>
+            </a:pPr>
+            <a:r>
+              <a:rPr lang="en-US" sz="1050" dirty="0">
+                <a:solidFill>
+                  <a:srgbClr val="56606E"/>
+                </a:solidFill>
+                <a:latin typeface="Arial" panose="020B0604020202020204" pitchFamily="34" charset="0"/>
+                <a:ea typeface="Arial" panose="020B0604020202020204" pitchFamily="34" charset="-122"/>
+                <a:cs typeface="Arial" panose="020B0604020202020204" pitchFamily="34" charset="-120"/>
+              </a:rPr>
+              <a:t>Note what was AI-drafted and what a person changed, especially for anything client-facing.</a:t>
+            </a:r>
+            <a:endParaRPr lang="en-US" sz="1050" dirty="0"/>
+          </a:p>
+        </p:txBody>
+      </p:sp>
+      <p:pic>
+        <p:nvPicPr>
+          <p:cNvPr id="19" name="Image 4" descr="/home/claude/work/assets/badge_gradient_teal.png"/>
+          <p:cNvPicPr>
+            <a:picLocks noChangeAspect="1"/>
+          </p:cNvPicPr>
+          <p:nvPr/>
+        </p:nvPicPr>
+        <p:blipFill>
+          <a:blip r:embed="rId3"/>
+          <a:stretch>
+            <a:fillRect/>
+          </a:stretch>
+        </p:blipFill>
+        <p:spPr>
+          <a:xfrm>
+            <a:off x="6446520" y="3986784"/>
+            <a:ext cx="365760" cy="365760"/>
+          </a:xfrm>
+          <a:prstGeom prst="rect">
+            <a:avLst/>
+          </a:prstGeom>
+          <a:effectLst>
+            <a:outerShdw blurRad="76200" dist="25400" dir="5400000" algn="bl" rotWithShape="0">
+              <a:srgbClr val="3A2E6E">
+                <a:alpha val="30000"/>
+              </a:srgbClr>
+            </a:outerShdw>
+          </a:effectLst>
+        </p:spPr>
+      </p:pic>
+      <p:sp>
+        <p:nvSpPr>
+          <p:cNvPr id="20" name="Text 13"/>
+          <p:cNvSpPr txBox="1"/>
+          <p:nvPr/>
+        </p:nvSpPr>
+        <p:spPr>
+          <a:xfrm>
+            <a:off x="6446520" y="3986784"/>
+            <a:ext cx="365760" cy="365760"/>
+          </a:xfrm>
+          <a:prstGeom prst="rect">
+            <a:avLst/>
+          </a:prstGeom>
+          <a:noFill/>
+        </p:spPr>
+        <p:txBody>
+          <a:bodyPr wrap="square" lIns="0" tIns="0" rIns="0" bIns="0" rtlCol="0" anchor="ctr"/>
+          <a:lstStyle/>
+          <a:p>
+            <a:pPr marL="0" indent="0" algn="ctr">
+              <a:buNone/>
+            </a:pPr>
+            <a:r>
+              <a:rPr lang="en-US" sz="1300" b="1" dirty="0">
+                <a:solidFill>
+                  <a:srgbClr val="FFFFFF"/>
+                </a:solidFill>
+                <a:latin typeface="Arial" panose="020B0604020202020204" pitchFamily="34" charset="0"/>
+                <a:ea typeface="Arial" panose="020B0604020202020204" pitchFamily="34" charset="-122"/>
+                <a:cs typeface="Arial" panose="020B0604020202020204" pitchFamily="34" charset="-120"/>
+              </a:rPr>
+              <a:t>3</a:t>
+            </a:r>
+            <a:endParaRPr lang="en-US" sz="1300" dirty="0"/>
+          </a:p>
+        </p:txBody>
+      </p:sp>
+      <p:sp>
+        <p:nvSpPr>
+          <p:cNvPr id="21" name="Text 14"/>
+          <p:cNvSpPr txBox="1"/>
+          <p:nvPr/>
+        </p:nvSpPr>
+        <p:spPr>
+          <a:xfrm>
+            <a:off x="6949440" y="3941064"/>
+            <a:ext cx="4023360" cy="274320"/>
+          </a:xfrm>
+          <a:prstGeom prst="rect">
+            <a:avLst/>
+          </a:prstGeom>
+          <a:noFill/>
+        </p:spPr>
+        <p:txBody>
+          <a:bodyPr wrap="square" lIns="0" tIns="0" rIns="0" bIns="0" rtlCol="0" anchor="ctr"/>
+          <a:lstStyle/>
+          <a:p>
+            <a:pPr marL="0" indent="0">
+              <a:buNone/>
+            </a:pPr>
+            <a:r>
+              <a:rPr lang="en-US" sz="1300" b="1" dirty="0">
+                <a:solidFill>
+                  <a:srgbClr val="00081D"/>
+                </a:solidFill>
+                <a:latin typeface="Arial" panose="020B0604020202020204" pitchFamily="34" charset="0"/>
+                <a:ea typeface="Arial" panose="020B0604020202020204" pitchFamily="34" charset="-122"/>
+                <a:cs typeface="Arial" panose="020B0604020202020204" pitchFamily="34" charset="-120"/>
+              </a:rPr>
+              <a:t>Don't publish it as-is.</a:t>
+            </a:r>
+            <a:endParaRPr lang="en-US" sz="1300" dirty="0"/>
+          </a:p>
+        </p:txBody>
+      </p:sp>
+      <p:sp>
+        <p:nvSpPr>
+          <p:cNvPr id="22" name="Text 15"/>
+          <p:cNvSpPr txBox="1"/>
+          <p:nvPr/>
+        </p:nvSpPr>
+        <p:spPr>
+          <a:xfrm>
+            <a:off x="6949440" y="4206240"/>
+            <a:ext cx="4023360" cy="457200"/>
+          </a:xfrm>
+          <a:prstGeom prst="rect">
+            <a:avLst/>
+          </a:prstGeom>
+          <a:noFill/>
+        </p:spPr>
+        <p:txBody>
+          <a:bodyPr wrap="square" lIns="0" tIns="0" rIns="0" bIns="0" rtlCol="0" anchor="ctr"/>
+          <a:lstStyle/>
+          <a:p>
+            <a:pPr marL="0" indent="0">
+              <a:lnSpc>
+                <a:spcPts val="1350"/>
+              </a:lnSpc>
+              <a:buNone/>
+            </a:pPr>
+            <a:r>
+              <a:rPr lang="en-US" sz="1050" dirty="0">
+                <a:solidFill>
+                  <a:srgbClr val="56606E"/>
+                </a:solidFill>
+                <a:latin typeface="Arial" panose="020B0604020202020204" pitchFamily="34" charset="0"/>
+                <a:ea typeface="Arial" panose="020B0604020202020204" pitchFamily="34" charset="-122"/>
+                <a:cs typeface="Arial" panose="020B0604020202020204" pitchFamily="34" charset="-120"/>
+              </a:rPr>
+              <a:t>Not under the company's name, for anything that matters legally or commercially.</a:t>
+            </a:r>
+            <a:endParaRPr lang="en-US" sz="1050" dirty="0"/>
+          </a:p>
+        </p:txBody>
+      </p:sp>
+      <p:pic>
+        <p:nvPicPr>
+          <p:cNvPr id="23" name="Image 5" descr="/home/claude/work/assets/badge_gradient_teal.png"/>
+          <p:cNvPicPr>
+            <a:picLocks noChangeAspect="1"/>
+          </p:cNvPicPr>
+          <p:nvPr/>
+        </p:nvPicPr>
+        <p:blipFill>
+          <a:blip r:embed="rId3"/>
+          <a:stretch>
+            <a:fillRect/>
+          </a:stretch>
+        </p:blipFill>
+        <p:spPr>
+          <a:xfrm>
+            <a:off x="6446520" y="4745736"/>
+            <a:ext cx="365760" cy="365760"/>
+          </a:xfrm>
+          <a:prstGeom prst="rect">
+            <a:avLst/>
+          </a:prstGeom>
+          <a:effectLst>
+            <a:outerShdw blurRad="76200" dist="25400" dir="5400000" algn="bl" rotWithShape="0">
+              <a:srgbClr val="3A2E6E">
+                <a:alpha val="30000"/>
+              </a:srgbClr>
+            </a:outerShdw>
+          </a:effectLst>
+        </p:spPr>
+      </p:pic>
+      <p:sp>
+        <p:nvSpPr>
+          <p:cNvPr id="24" name="Text 16"/>
+          <p:cNvSpPr txBox="1"/>
+          <p:nvPr/>
+        </p:nvSpPr>
+        <p:spPr>
+          <a:xfrm>
+            <a:off x="6446520" y="4745736"/>
+            <a:ext cx="365760" cy="365760"/>
+          </a:xfrm>
+          <a:prstGeom prst="rect">
+            <a:avLst/>
+          </a:prstGeom>
+          <a:noFill/>
+        </p:spPr>
+        <p:txBody>
+          <a:bodyPr wrap="square" lIns="0" tIns="0" rIns="0" bIns="0" rtlCol="0" anchor="ctr"/>
+          <a:lstStyle/>
+          <a:p>
+            <a:pPr marL="0" indent="0" algn="ctr">
+              <a:buNone/>
+            </a:pPr>
+            <a:r>
+              <a:rPr lang="en-US" sz="1300" b="1" dirty="0">
+                <a:solidFill>
+                  <a:srgbClr val="FFFFFF"/>
+                </a:solidFill>
+                <a:latin typeface="Arial" panose="020B0604020202020204" pitchFamily="34" charset="0"/>
+                <a:ea typeface="Arial" panose="020B0604020202020204" pitchFamily="34" charset="-122"/>
+                <a:cs typeface="Arial" panose="020B0604020202020204" pitchFamily="34" charset="-120"/>
+              </a:rPr>
+              <a:t>4</a:t>
+            </a:r>
+            <a:endParaRPr lang="en-US" sz="1300" dirty="0"/>
+          </a:p>
+        </p:txBody>
+      </p:sp>
+      <p:sp>
+        <p:nvSpPr>
+          <p:cNvPr id="25" name="Text 17"/>
+          <p:cNvSpPr txBox="1"/>
+          <p:nvPr/>
+        </p:nvSpPr>
+        <p:spPr>
+          <a:xfrm>
+            <a:off x="6949440" y="4700016"/>
+            <a:ext cx="4023360" cy="274320"/>
+          </a:xfrm>
+          <a:prstGeom prst="rect">
+            <a:avLst/>
+          </a:prstGeom>
+          <a:noFill/>
+        </p:spPr>
+        <p:txBody>
+          <a:bodyPr wrap="square" lIns="0" tIns="0" rIns="0" bIns="0" rtlCol="0" anchor="ctr"/>
+          <a:lstStyle/>
+          <a:p>
+            <a:pPr marL="0" indent="0">
+              <a:buNone/>
+            </a:pPr>
+            <a:r>
+              <a:rPr lang="en-US" sz="1300" b="1" dirty="0">
+                <a:solidFill>
+                  <a:srgbClr val="00081D"/>
+                </a:solidFill>
+                <a:latin typeface="Arial" panose="020B0604020202020204" pitchFamily="34" charset="0"/>
+                <a:ea typeface="Arial" panose="020B0604020202020204" pitchFamily="34" charset="-122"/>
+                <a:cs typeface="Arial" panose="020B0604020202020204" pitchFamily="34" charset="-120"/>
+              </a:rPr>
+              <a:t>Ask when it's not obvious.</a:t>
+            </a:r>
+            <a:endParaRPr lang="en-US" sz="1300" dirty="0"/>
+          </a:p>
+        </p:txBody>
+      </p:sp>
+      <p:sp>
+        <p:nvSpPr>
+          <p:cNvPr id="26" name="Text 18"/>
+          <p:cNvSpPr txBox="1"/>
+          <p:nvPr/>
+        </p:nvSpPr>
+        <p:spPr>
+          <a:xfrm>
+            <a:off x="6949440" y="4965192"/>
+            <a:ext cx="4023360" cy="457200"/>
+          </a:xfrm>
+          <a:prstGeom prst="rect">
+            <a:avLst/>
+          </a:prstGeom>
+          <a:noFill/>
+        </p:spPr>
+        <p:txBody>
+          <a:bodyPr wrap="square" lIns="0" tIns="0" rIns="0" bIns="0" rtlCol="0" anchor="ctr"/>
+          <a:lstStyle/>
+          <a:p>
+            <a:pPr marL="0" indent="0">
+              <a:lnSpc>
+                <a:spcPts val="1350"/>
+              </a:lnSpc>
+              <a:buNone/>
+            </a:pPr>
+            <a:r>
+              <a:rPr lang="en-US" sz="1050" dirty="0">
+                <a:solidFill>
+                  <a:srgbClr val="56606E"/>
+                </a:solidFill>
+                <a:latin typeface="Arial" panose="020B0604020202020204" pitchFamily="34" charset="0"/>
+                <a:ea typeface="Arial" panose="020B0604020202020204" pitchFamily="34" charset="-122"/>
+                <a:cs typeface="Arial" panose="020B0604020202020204" pitchFamily="34" charset="-120"/>
+              </a:rPr>
+              <a:t>Check with Legal or Compliance before your name, or the company's, goes on AI-written material.</a:t>
+            </a:r>
+            <a:endParaRPr lang="en-US" sz="1050" dirty="0"/>
+          </a:p>
+        </p:txBody>
+      </p:sp>
+      <p:sp>
+        <p:nvSpPr>
+          <p:cNvPr id="27" name="Text 19"/>
+          <p:cNvSpPr txBox="1"/>
+          <p:nvPr/>
+        </p:nvSpPr>
+        <p:spPr>
+          <a:xfrm>
+            <a:off x="11320272" y="6556248"/>
+            <a:ext cx="457200" cy="256032"/>
+          </a:xfrm>
+          <a:prstGeom prst="rect">
+            <a:avLst/>
+          </a:prstGeom>
+          <a:noFill/>
+        </p:spPr>
+        <p:txBody>
+          <a:bodyPr wrap="square" lIns="0" tIns="0" rIns="0" bIns="0" rtlCol="0" anchor="ctr"/>
+          <a:lstStyle/>
+          <a:p>
+            <a:pPr marL="0" indent="0" algn="r">
+              <a:buNone/>
+            </a:pPr>
+            <a:r>
+              <a:rPr lang="en-US" sz="900" dirty="0">
+                <a:solidFill>
+                  <a:srgbClr val="8FA3B8"/>
+                </a:solidFill>
+                <a:latin typeface="Arial" panose="020B0604020202020204" pitchFamily="34" charset="0"/>
+                <a:ea typeface="Arial" panose="020B0604020202020204" pitchFamily="34" charset="-122"/>
+                <a:cs typeface="Arial" panose="020B0604020202020204" pitchFamily="34" charset="-120"/>
+              </a:rPr>
+              <a:t>11</a:t>
+            </a:r>
+            <a:endParaRPr lang="en-US" sz="900" dirty="0"/>
+          </a:p>
+        </p:txBody>
+      </p:sp>
+    </p:spTree>
+  </p:cSld>
+  <p:clrMapOvr>
+    <a:masterClrMapping/>
+  </p:clrMapOvr>
+</p:sld>
+</file>
+
+<file path=ppt/slides/slide12.xml><?xml version="1.0" encoding="utf-8"?>
 <p:sld xmlns:a="http://schemas.openxmlformats.org/drawingml/2006/main" xmlns:r="http://schemas.openxmlformats.org/officeDocument/2006/relationships" xmlns:p="http://schemas.openxmlformats.org/presentationml/2006/main">
   <p:cSld>
     <p:bg>
@@ -6970,7 +7830,7 @@
                 <a:ea typeface="Arial" panose="020B0604020202020204" pitchFamily="34" charset="-122"/>
                 <a:cs typeface="Arial" panose="020B0604020202020204" pitchFamily="34" charset="-120"/>
               </a:rPr>
-              <a:t xml:space="preserve"> </a:t>
+              <a:t> </a:t>
             </a:r>
             <a:endParaRPr lang="en-US" sz="1250" dirty="0"/>
           </a:p>
@@ -7039,7 +7899,7 @@
                 <a:ea typeface="Arial" panose="020B0604020202020204" pitchFamily="34" charset="-122"/>
                 <a:cs typeface="Arial" panose="020B0604020202020204" pitchFamily="34" charset="-120"/>
               </a:rPr>
-              <a:t xml:space="preserve">Disclaimer: </a:t>
+              <a:t>Disclaimer: </a:t>
             </a:r>
             <a:r>
               <a:rPr lang="en-US" dirty="0">
@@ -7093,7 +7953,7 @@
                 <a:ea typeface="Arial" panose="020B0604020202020204" pitchFamily="34" charset="-122"/>
                 <a:cs typeface="Arial" panose="020B0604020202020204" pitchFamily="34" charset="-120"/>
               </a:rPr>
-              <a:t xml:space="preserve"> data policy and go into its Data Controls yourself. Don't assume the default is doing what you want.</a:t>
+              <a:t> data policy and go into its Data Controls yourself. Don't assume the default is doing what you want.</a:t>
             </a:r>
             <a:endParaRPr lang="en-US" dirty="0">
               <a:solidFill>
@@ -8525,7 +9385,7 @@
                 <a:ea typeface="Arial" panose="020B0604020202020204" pitchFamily="34" charset="-122"/>
                 <a:cs typeface="Arial" panose="020B0604020202020204" pitchFamily="34" charset="-120"/>
               </a:rPr>
-              <a:t>Examples of what not to share</a:t>
+              <a:t>What generally counts as sensitive</a:t>
             </a:r>
             <a:endParaRPr lang="en-US" sz="3000" dirty="0"/>
           </a:p>
@@ -8540,11 +9400,715 @@
         <p:spPr>
           <a:xfrm>
             <a:off x="640080" y="1600200"/>
-            <a:ext cx="6583680" cy="3429000"/>
+            <a:ext cx="5074920" cy="1783080"/>
           </a:xfrm>
           <a:prstGeom prst="roundRect">
             <a:avLst>
-              <a:gd name="adj" fmla="val 4000"/>
+              <a:gd name="adj" fmla="val 6154"/>
+            </a:avLst>
+          </a:prstGeom>
+          <a:solidFill>
+            <a:srgbClr val="F2F5FA"/>
+          </a:solidFill>
+          <a:effectLst>
+            <a:outerShdw blurRad="76200" dist="25400" dir="5400000" algn="bl" rotWithShape="0">
+              <a:srgbClr val="000000">
+                <a:alpha val="8000"/>
+              </a:srgbClr>
+            </a:outerShdw>
+          </a:effectLst>
+        </p:spPr>
+      </p:sp>
+      <p:pic>
+        <p:nvPicPr>
+          <p:cNvPr id="5" name="Image 1" descr="/home/claude/work/assets/badge_gradient.png"/>
+          <p:cNvPicPr>
+            <a:picLocks noChangeAspect="1"/>
+          </p:cNvPicPr>
+          <p:nvPr/>
+        </p:nvPicPr>
+        <p:blipFill>
+          <a:blip r:embed="rId2"/>
+          <a:stretch>
+            <a:fillRect/>
+          </a:stretch>
+        </p:blipFill>
+        <p:spPr>
+          <a:xfrm>
+            <a:off x="896112" y="1828800"/>
+            <a:ext cx="457200" cy="457200"/>
+          </a:xfrm>
+          <a:prstGeom prst="rect">
+            <a:avLst/>
+          </a:prstGeom>
+          <a:effectLst>
+            <a:outerShdw blurRad="76200" dist="25400" dir="5400000" algn="bl" rotWithShape="0">
+              <a:srgbClr val="3A2E6E">
+                <a:alpha val="30000"/>
+              </a:srgbClr>
+            </a:outerShdw>
+          </a:effectLst>
+        </p:spPr>
+      </p:pic>
+      <p:sp>
+        <p:nvSpPr>
+          <p:cNvPr id="6" name="Text 2"/>
+          <p:cNvSpPr txBox="1"/>
+          <p:nvPr/>
+        </p:nvSpPr>
+        <p:spPr>
+          <a:xfrm>
+            <a:off x="896112" y="1828800"/>
+            <a:ext cx="457200" cy="457200"/>
+          </a:xfrm>
+          <a:prstGeom prst="rect">
+            <a:avLst/>
+          </a:prstGeom>
+          <a:noFill/>
+        </p:spPr>
+        <p:txBody>
+          <a:bodyPr wrap="square" lIns="0" tIns="0" rIns="0" bIns="0" rtlCol="0" anchor="ctr"/>
+          <a:lstStyle/>
+          <a:p>
+            <a:pPr marL="0" indent="0" algn="ctr">
+              <a:buNone/>
+            </a:pPr>
+            <a:r>
+              <a:rPr lang="en-US" sz="1600" b="1" dirty="0">
+                <a:solidFill>
+                  <a:srgbClr val="FFFFFF"/>
+                </a:solidFill>
+                <a:latin typeface="Arial" panose="020B0604020202020204" pitchFamily="34" charset="0"/>
+                <a:ea typeface="Arial" panose="020B0604020202020204" pitchFamily="34" charset="-122"/>
+                <a:cs typeface="Arial" panose="020B0604020202020204" pitchFamily="34" charset="-120"/>
+              </a:rPr>
+              <a:t>1</a:t>
+            </a:r>
+            <a:endParaRPr lang="en-US" sz="1600" dirty="0"/>
+          </a:p>
+        </p:txBody>
+      </p:sp>
+      <p:sp>
+        <p:nvSpPr>
+          <p:cNvPr id="7" name="Text 3"/>
+          <p:cNvSpPr txBox="1"/>
+          <p:nvPr/>
+        </p:nvSpPr>
+        <p:spPr>
+          <a:xfrm>
+            <a:off x="1536192" y="1801368"/>
+            <a:ext cx="3931920" cy="457200"/>
+          </a:xfrm>
+          <a:prstGeom prst="rect">
+            <a:avLst/>
+          </a:prstGeom>
+          <a:noFill/>
+        </p:spPr>
+        <p:txBody>
+          <a:bodyPr wrap="square" lIns="0" tIns="0" rIns="0" bIns="0" rtlCol="0" anchor="ctr"/>
+          <a:lstStyle/>
+          <a:p>
+            <a:pPr marL="0" indent="0">
+              <a:buNone/>
+            </a:pPr>
+            <a:r>
+              <a:rPr lang="en-US" sz="1600" b="1" dirty="0">
+                <a:solidFill>
+                  <a:srgbClr val="00081D"/>
+                </a:solidFill>
+                <a:latin typeface="Arial" panose="020B0604020202020204" pitchFamily="34" charset="0"/>
+                <a:ea typeface="Arial" panose="020B0604020202020204" pitchFamily="34" charset="-122"/>
+                <a:cs typeface="Arial" panose="020B0604020202020204" pitchFamily="34" charset="-120"/>
+              </a:rPr>
+              <a:t>Client &amp; personal data</a:t>
+            </a:r>
+            <a:endParaRPr lang="en-US" sz="1600" dirty="0"/>
+          </a:p>
+        </p:txBody>
+      </p:sp>
+      <p:sp>
+        <p:nvSpPr>
+          <p:cNvPr id="8" name="Text 4"/>
+          <p:cNvSpPr txBox="1"/>
+          <p:nvPr/>
+        </p:nvSpPr>
+        <p:spPr>
+          <a:xfrm>
+            <a:off x="932688" y="2331720"/>
+            <a:ext cx="4489704" cy="868680"/>
+          </a:xfrm>
+          <a:prstGeom prst="rect">
+            <a:avLst/>
+          </a:prstGeom>
+          <a:noFill/>
+        </p:spPr>
+        <p:txBody>
+          <a:bodyPr wrap="square" lIns="0" tIns="0" rIns="0" bIns="0" rtlCol="0" anchor="ctr"/>
+          <a:lstStyle/>
+          <a:p>
+            <a:pPr marL="0" indent="0">
+              <a:lnSpc>
+                <a:spcPts val="1550"/>
+              </a:lnSpc>
+              <a:buNone/>
+            </a:pPr>
+            <a:r>
+              <a:rPr lang="en-US" sz="1150" dirty="0">
+                <a:solidFill>
+                  <a:srgbClr val="56606E"/>
+                </a:solidFill>
+                <a:latin typeface="Arial" panose="020B0604020202020204" pitchFamily="34" charset="0"/>
+                <a:ea typeface="Arial" panose="020B0604020202020204" pitchFamily="34" charset="-122"/>
+                <a:cs typeface="Arial" panose="020B0604020202020204" pitchFamily="34" charset="-120"/>
+              </a:rPr>
+              <a:t>Names, employers, contact details — anyone identifiable, colleague or client.</a:t>
+            </a:r>
+            <a:endParaRPr lang="en-US" sz="1150" dirty="0"/>
+          </a:p>
+        </p:txBody>
+      </p:sp>
+      <p:sp>
+        <p:nvSpPr>
+          <p:cNvPr id="9" name="Shape 5"/>
+          <p:cNvSpPr/>
+          <p:nvPr/>
+        </p:nvSpPr>
+        <p:spPr>
+          <a:xfrm>
+            <a:off x="6172200" y="1600200"/>
+            <a:ext cx="5074920" cy="1783080"/>
+          </a:xfrm>
+          <a:prstGeom prst="roundRect">
+            <a:avLst>
+              <a:gd name="adj" fmla="val 6154"/>
+            </a:avLst>
+          </a:prstGeom>
+          <a:solidFill>
+            <a:srgbClr val="F2F5FA"/>
+          </a:solidFill>
+          <a:effectLst>
+            <a:outerShdw blurRad="76200" dist="25400" dir="5400000" algn="bl" rotWithShape="0">
+              <a:srgbClr val="000000">
+                <a:alpha val="8000"/>
+              </a:srgbClr>
+            </a:outerShdw>
+          </a:effectLst>
+        </p:spPr>
+      </p:sp>
+      <p:pic>
+        <p:nvPicPr>
+          <p:cNvPr id="10" name="Image 2" descr="/home/claude/work/assets/badge_gradient.png"/>
+          <p:cNvPicPr>
+            <a:picLocks noChangeAspect="1"/>
+          </p:cNvPicPr>
+          <p:nvPr/>
+        </p:nvPicPr>
+        <p:blipFill>
+          <a:blip r:embed="rId2"/>
+          <a:stretch>
+            <a:fillRect/>
+          </a:stretch>
+        </p:blipFill>
+        <p:spPr>
+          <a:xfrm>
+            <a:off x="6428232" y="1828800"/>
+            <a:ext cx="457200" cy="457200"/>
+          </a:xfrm>
+          <a:prstGeom prst="rect">
+            <a:avLst/>
+          </a:prstGeom>
+          <a:effectLst>
+            <a:outerShdw blurRad="76200" dist="25400" dir="5400000" algn="bl" rotWithShape="0">
+              <a:srgbClr val="3A2E6E">
+                <a:alpha val="30000"/>
+              </a:srgbClr>
+            </a:outerShdw>
+          </a:effectLst>
+        </p:spPr>
+      </p:pic>
+      <p:sp>
+        <p:nvSpPr>
+          <p:cNvPr id="11" name="Text 6"/>
+          <p:cNvSpPr txBox="1"/>
+          <p:nvPr/>
+        </p:nvSpPr>
+        <p:spPr>
+          <a:xfrm>
+            <a:off x="6428232" y="1828800"/>
+            <a:ext cx="457200" cy="457200"/>
+          </a:xfrm>
+          <a:prstGeom prst="rect">
+            <a:avLst/>
+          </a:prstGeom>
+          <a:noFill/>
+        </p:spPr>
+        <p:txBody>
+          <a:bodyPr wrap="square" lIns="0" tIns="0" rIns="0" bIns="0" rtlCol="0" anchor="ctr"/>
+          <a:lstStyle/>
+          <a:p>
+            <a:pPr marL="0" indent="0" algn="ctr">
+              <a:buNone/>
+            </a:pPr>
+            <a:r>
+              <a:rPr lang="en-US" sz="1600" b="1" dirty="0">
+                <a:solidFill>
+                  <a:srgbClr val="FFFFFF"/>
+                </a:solidFill>
+                <a:latin typeface="Arial" panose="020B0604020202020204" pitchFamily="34" charset="0"/>
+                <a:ea typeface="Arial" panose="020B0604020202020204" pitchFamily="34" charset="-122"/>
+                <a:cs typeface="Arial" panose="020B0604020202020204" pitchFamily="34" charset="-120"/>
+              </a:rPr>
+              <a:t>2</a:t>
+            </a:r>
+            <a:endParaRPr lang="en-US" sz="1600" dirty="0"/>
+          </a:p>
+        </p:txBody>
+      </p:sp>
+      <p:sp>
+        <p:nvSpPr>
+          <p:cNvPr id="12" name="Text 7"/>
+          <p:cNvSpPr txBox="1"/>
+          <p:nvPr/>
+        </p:nvSpPr>
+        <p:spPr>
+          <a:xfrm>
+            <a:off x="7068312" y="1801368"/>
+            <a:ext cx="3931920" cy="457200"/>
+          </a:xfrm>
+          <a:prstGeom prst="rect">
+            <a:avLst/>
+          </a:prstGeom>
+          <a:noFill/>
+        </p:spPr>
+        <p:txBody>
+          <a:bodyPr wrap="square" lIns="0" tIns="0" rIns="0" bIns="0" rtlCol="0" anchor="ctr"/>
+          <a:lstStyle/>
+          <a:p>
+            <a:pPr marL="0" indent="0">
+              <a:buNone/>
+            </a:pPr>
+            <a:r>
+              <a:rPr lang="en-US" sz="1600" b="1" dirty="0">
+                <a:solidFill>
+                  <a:srgbClr val="00081D"/>
+                </a:solidFill>
+                <a:latin typeface="Arial" panose="020B0604020202020204" pitchFamily="34" charset="0"/>
+                <a:ea typeface="Arial" panose="020B0604020202020204" pitchFamily="34" charset="-122"/>
+                <a:cs typeface="Arial" panose="020B0604020202020204" pitchFamily="34" charset="-120"/>
+              </a:rPr>
+              <a:t>Account &amp; case numbers</a:t>
+            </a:r>
+            <a:endParaRPr lang="en-US" sz="1600" dirty="0"/>
+          </a:p>
+        </p:txBody>
+      </p:sp>
+      <p:sp>
+        <p:nvSpPr>
+          <p:cNvPr id="13" name="Text 8"/>
+          <p:cNvSpPr txBox="1"/>
+          <p:nvPr/>
+        </p:nvSpPr>
+        <p:spPr>
+          <a:xfrm>
+            <a:off x="6464808" y="2331720"/>
+            <a:ext cx="4489704" cy="868680"/>
+          </a:xfrm>
+          <a:prstGeom prst="rect">
+            <a:avLst/>
+          </a:prstGeom>
+          <a:noFill/>
+        </p:spPr>
+        <p:txBody>
+          <a:bodyPr wrap="square" lIns="0" tIns="0" rIns="0" bIns="0" rtlCol="0" anchor="ctr"/>
+          <a:lstStyle/>
+          <a:p>
+            <a:pPr marL="0" indent="0">
+              <a:lnSpc>
+                <a:spcPts val="1550"/>
+              </a:lnSpc>
+              <a:buNone/>
+            </a:pPr>
+            <a:r>
+              <a:rPr lang="en-US" sz="1150" dirty="0">
+                <a:solidFill>
+                  <a:srgbClr val="56606E"/>
+                </a:solidFill>
+                <a:latin typeface="Arial" panose="020B0604020202020204" pitchFamily="34" charset="0"/>
+                <a:ea typeface="Arial" panose="020B0604020202020204" pitchFamily="34" charset="-122"/>
+                <a:cs typeface="Arial" panose="020B0604020202020204" pitchFamily="34" charset="-120"/>
+              </a:rPr>
+              <a:t>Account IDs, case references, policy numbers — anything that maps back to a specific record.</a:t>
+            </a:r>
+            <a:endParaRPr lang="en-US" sz="1150" dirty="0"/>
+          </a:p>
+        </p:txBody>
+      </p:sp>
+      <p:sp>
+        <p:nvSpPr>
+          <p:cNvPr id="14" name="Shape 9"/>
+          <p:cNvSpPr/>
+          <p:nvPr/>
+        </p:nvSpPr>
+        <p:spPr>
+          <a:xfrm>
+            <a:off x="640080" y="3611880"/>
+            <a:ext cx="5074920" cy="1783080"/>
+          </a:xfrm>
+          <a:prstGeom prst="roundRect">
+            <a:avLst>
+              <a:gd name="adj" fmla="val 6154"/>
+            </a:avLst>
+          </a:prstGeom>
+          <a:solidFill>
+            <a:srgbClr val="F2F5FA"/>
+          </a:solidFill>
+          <a:effectLst>
+            <a:outerShdw blurRad="76200" dist="25400" dir="5400000" algn="bl" rotWithShape="0">
+              <a:srgbClr val="000000">
+                <a:alpha val="8000"/>
+              </a:srgbClr>
+            </a:outerShdw>
+          </a:effectLst>
+        </p:spPr>
+      </p:sp>
+      <p:pic>
+        <p:nvPicPr>
+          <p:cNvPr id="15" name="Image 3" descr="/home/claude/work/assets/badge_gradient.png"/>
+          <p:cNvPicPr>
+            <a:picLocks noChangeAspect="1"/>
+          </p:cNvPicPr>
+          <p:nvPr/>
+        </p:nvPicPr>
+        <p:blipFill>
+          <a:blip r:embed="rId2"/>
+          <a:stretch>
+            <a:fillRect/>
+          </a:stretch>
+        </p:blipFill>
+        <p:spPr>
+          <a:xfrm>
+            <a:off x="896112" y="3840480"/>
+            <a:ext cx="457200" cy="457200"/>
+          </a:xfrm>
+          <a:prstGeom prst="rect">
+            <a:avLst/>
+          </a:prstGeom>
+          <a:effectLst>
+            <a:outerShdw blurRad="76200" dist="25400" dir="5400000" algn="bl" rotWithShape="0">
+              <a:srgbClr val="3A2E6E">
+                <a:alpha val="30000"/>
+              </a:srgbClr>
+            </a:outerShdw>
+          </a:effectLst>
+        </p:spPr>
+      </p:pic>
+      <p:sp>
+        <p:nvSpPr>
+          <p:cNvPr id="16" name="Text 10"/>
+          <p:cNvSpPr txBox="1"/>
+          <p:nvPr/>
+        </p:nvSpPr>
+        <p:spPr>
+          <a:xfrm>
+            <a:off x="896112" y="3840480"/>
+            <a:ext cx="457200" cy="457200"/>
+          </a:xfrm>
+          <a:prstGeom prst="rect">
+            <a:avLst/>
+          </a:prstGeom>
+          <a:noFill/>
+        </p:spPr>
+        <p:txBody>
+          <a:bodyPr wrap="square" lIns="0" tIns="0" rIns="0" bIns="0" rtlCol="0" anchor="ctr"/>
+          <a:lstStyle/>
+          <a:p>
+            <a:pPr marL="0" indent="0" algn="ctr">
+              <a:buNone/>
+            </a:pPr>
+            <a:r>
+              <a:rPr lang="en-US" sz="1600" b="1" dirty="0">
+                <a:solidFill>
+                  <a:srgbClr val="FFFFFF"/>
+                </a:solidFill>
+                <a:latin typeface="Arial" panose="020B0604020202020204" pitchFamily="34" charset="0"/>
+                <a:ea typeface="Arial" panose="020B0604020202020204" pitchFamily="34" charset="-122"/>
+                <a:cs typeface="Arial" panose="020B0604020202020204" pitchFamily="34" charset="-120"/>
+              </a:rPr>
+              <a:t>3</a:t>
+            </a:r>
+            <a:endParaRPr lang="en-US" sz="1600" dirty="0"/>
+          </a:p>
+        </p:txBody>
+      </p:sp>
+      <p:sp>
+        <p:nvSpPr>
+          <p:cNvPr id="17" name="Text 11"/>
+          <p:cNvSpPr txBox="1"/>
+          <p:nvPr/>
+        </p:nvSpPr>
+        <p:spPr>
+          <a:xfrm>
+            <a:off x="1536192" y="3813048"/>
+            <a:ext cx="3931920" cy="457200"/>
+          </a:xfrm>
+          <a:prstGeom prst="rect">
+            <a:avLst/>
+          </a:prstGeom>
+          <a:noFill/>
+        </p:spPr>
+        <p:txBody>
+          <a:bodyPr wrap="square" lIns="0" tIns="0" rIns="0" bIns="0" rtlCol="0" anchor="ctr"/>
+          <a:lstStyle/>
+          <a:p>
+            <a:pPr marL="0" indent="0">
+              <a:buNone/>
+            </a:pPr>
+            <a:r>
+              <a:rPr lang="en-US" sz="1600" b="1" dirty="0">
+                <a:solidFill>
+                  <a:srgbClr val="00081D"/>
+                </a:solidFill>
+                <a:latin typeface="Arial" panose="020B0604020202020204" pitchFamily="34" charset="0"/>
+                <a:ea typeface="Arial" panose="020B0604020202020204" pitchFamily="34" charset="-122"/>
+                <a:cs typeface="Arial" panose="020B0604020202020204" pitchFamily="34" charset="-120"/>
+              </a:rPr>
+              <a:t>Exact financial figures</a:t>
+            </a:r>
+            <a:endParaRPr lang="en-US" sz="1600" dirty="0"/>
+          </a:p>
+        </p:txBody>
+      </p:sp>
+      <p:sp>
+        <p:nvSpPr>
+          <p:cNvPr id="18" name="Text 12"/>
+          <p:cNvSpPr txBox="1"/>
+          <p:nvPr/>
+        </p:nvSpPr>
+        <p:spPr>
+          <a:xfrm>
+            <a:off x="932688" y="4343400"/>
+            <a:ext cx="4489704" cy="868680"/>
+          </a:xfrm>
+          <a:prstGeom prst="rect">
+            <a:avLst/>
+          </a:prstGeom>
+          <a:noFill/>
+        </p:spPr>
+        <p:txBody>
+          <a:bodyPr wrap="square" lIns="0" tIns="0" rIns="0" bIns="0" rtlCol="0" anchor="ctr"/>
+          <a:lstStyle/>
+          <a:p>
+            <a:pPr marL="0" indent="0">
+              <a:lnSpc>
+                <a:spcPts val="1550"/>
+              </a:lnSpc>
+              <a:buNone/>
+            </a:pPr>
+            <a:r>
+              <a:rPr lang="en-US" sz="1150" dirty="0">
+                <a:solidFill>
+                  <a:srgbClr val="56606E"/>
+                </a:solidFill>
+                <a:latin typeface="Arial" panose="020B0604020202020204" pitchFamily="34" charset="0"/>
+                <a:ea typeface="Arial" panose="020B0604020202020204" pitchFamily="34" charset="-122"/>
+                <a:cs typeface="Arial" panose="020B0604020202020204" pitchFamily="34" charset="-120"/>
+              </a:rPr>
+              <a:t>Real balances, amounts, dates or valuations — round them or describe them instead.</a:t>
+            </a:r>
+            <a:endParaRPr lang="en-US" sz="1150" dirty="0"/>
+          </a:p>
+        </p:txBody>
+      </p:sp>
+      <p:sp>
+        <p:nvSpPr>
+          <p:cNvPr id="19" name="Shape 13"/>
+          <p:cNvSpPr/>
+          <p:nvPr/>
+        </p:nvSpPr>
+        <p:spPr>
+          <a:xfrm>
+            <a:off x="6172200" y="3611880"/>
+            <a:ext cx="5074920" cy="1783080"/>
+          </a:xfrm>
+          <a:prstGeom prst="roundRect">
+            <a:avLst>
+              <a:gd name="adj" fmla="val 6154"/>
+            </a:avLst>
+          </a:prstGeom>
+          <a:solidFill>
+            <a:srgbClr val="F2F5FA"/>
+          </a:solidFill>
+          <a:effectLst>
+            <a:outerShdw blurRad="76200" dist="25400" dir="5400000" algn="bl" rotWithShape="0">
+              <a:srgbClr val="000000">
+                <a:alpha val="8000"/>
+              </a:srgbClr>
+            </a:outerShdw>
+          </a:effectLst>
+        </p:spPr>
+      </p:sp>
+      <p:pic>
+        <p:nvPicPr>
+          <p:cNvPr id="20" name="Image 4" descr="/home/claude/work/assets/badge_gradient.png"/>
+          <p:cNvPicPr>
+            <a:picLocks noChangeAspect="1"/>
+          </p:cNvPicPr>
+          <p:nvPr/>
+        </p:nvPicPr>
+        <p:blipFill>
+          <a:blip r:embed="rId2"/>
+          <a:stretch>
+            <a:fillRect/>
+          </a:stretch>
+        </p:blipFill>
+        <p:spPr>
+          <a:xfrm>
+            <a:off x="6428232" y="3840480"/>
+            <a:ext cx="457200" cy="457200"/>
+          </a:xfrm>
+          <a:prstGeom prst="rect">
+            <a:avLst/>
+          </a:prstGeom>
+          <a:effectLst>
+            <a:outerShdw blurRad="76200" dist="25400" dir="5400000" algn="bl" rotWithShape="0">
+              <a:srgbClr val="3A2E6E">
+                <a:alpha val="30000"/>
+              </a:srgbClr>
+            </a:outerShdw>
+          </a:effectLst>
+        </p:spPr>
+      </p:pic>
+      <p:sp>
+        <p:nvSpPr>
+          <p:cNvPr id="21" name="Text 14"/>
+          <p:cNvSpPr txBox="1"/>
+          <p:nvPr/>
+        </p:nvSpPr>
+        <p:spPr>
+          <a:xfrm>
+            <a:off x="6428232" y="3840480"/>
+            <a:ext cx="457200" cy="457200"/>
+          </a:xfrm>
+          <a:prstGeom prst="rect">
+            <a:avLst/>
+          </a:prstGeom>
+          <a:noFill/>
+        </p:spPr>
+        <p:txBody>
+          <a:bodyPr wrap="square" lIns="0" tIns="0" rIns="0" bIns="0" rtlCol="0" anchor="ctr"/>
+          <a:lstStyle/>
+          <a:p>
+            <a:pPr marL="0" indent="0" algn="ctr">
+              <a:buNone/>
+            </a:pPr>
+            <a:r>
+              <a:rPr lang="en-US" sz="1600" b="1" dirty="0">
+                <a:solidFill>
+                  <a:srgbClr val="FFFFFF"/>
+                </a:solidFill>
+                <a:latin typeface="Arial" panose="020B0604020202020204" pitchFamily="34" charset="0"/>
+                <a:ea typeface="Arial" panose="020B0604020202020204" pitchFamily="34" charset="-122"/>
+                <a:cs typeface="Arial" panose="020B0604020202020204" pitchFamily="34" charset="-120"/>
+              </a:rPr>
+              <a:t>4</a:t>
+            </a:r>
+            <a:endParaRPr lang="en-US" sz="1600" dirty="0"/>
+          </a:p>
+        </p:txBody>
+      </p:sp>
+      <p:sp>
+        <p:nvSpPr>
+          <p:cNvPr id="22" name="Text 15"/>
+          <p:cNvSpPr txBox="1"/>
+          <p:nvPr/>
+        </p:nvSpPr>
+        <p:spPr>
+          <a:xfrm>
+            <a:off x="7068312" y="3813048"/>
+            <a:ext cx="3931920" cy="457200"/>
+          </a:xfrm>
+          <a:prstGeom prst="rect">
+            <a:avLst/>
+          </a:prstGeom>
+          <a:noFill/>
+        </p:spPr>
+        <p:txBody>
+          <a:bodyPr wrap="square" lIns="0" tIns="0" rIns="0" bIns="0" rtlCol="0" anchor="ctr"/>
+          <a:lstStyle/>
+          <a:p>
+            <a:pPr marL="0" indent="0">
+              <a:buNone/>
+            </a:pPr>
+            <a:r>
+              <a:rPr lang="en-US" sz="1600" b="1" dirty="0">
+                <a:solidFill>
+                  <a:srgbClr val="00081D"/>
+                </a:solidFill>
+                <a:latin typeface="Arial" panose="020B0604020202020204" pitchFamily="34" charset="0"/>
+                <a:ea typeface="Arial" panose="020B0604020202020204" pitchFamily="34" charset="-122"/>
+                <a:cs typeface="Arial" panose="020B0604020202020204" pitchFamily="34" charset="-120"/>
+              </a:rPr>
+              <a:t>Credentials &amp; internal info</a:t>
+            </a:r>
+            <a:endParaRPr lang="en-US" sz="1600" dirty="0"/>
+          </a:p>
+        </p:txBody>
+      </p:sp>
+      <p:sp>
+        <p:nvSpPr>
+          <p:cNvPr id="23" name="Text 16"/>
+          <p:cNvSpPr txBox="1"/>
+          <p:nvPr/>
+        </p:nvSpPr>
+        <p:spPr>
+          <a:xfrm>
+            <a:off x="6464808" y="4343400"/>
+            <a:ext cx="4489704" cy="868680"/>
+          </a:xfrm>
+          <a:prstGeom prst="rect">
+            <a:avLst/>
+          </a:prstGeom>
+          <a:noFill/>
+        </p:spPr>
+        <p:txBody>
+          <a:bodyPr wrap="square" lIns="0" tIns="0" rIns="0" bIns="0" rtlCol="0" anchor="ctr"/>
+          <a:lstStyle/>
+          <a:p>
+            <a:pPr marL="0" indent="0">
+              <a:lnSpc>
+                <a:spcPts val="1550"/>
+              </a:lnSpc>
+              <a:buNone/>
+            </a:pPr>
+            <a:r>
+              <a:rPr lang="en-US" sz="1150" dirty="0">
+                <a:solidFill>
+                  <a:srgbClr val="56606E"/>
+                </a:solidFill>
+                <a:latin typeface="Arial" panose="020B0604020202020204" pitchFamily="34" charset="0"/>
+                <a:ea typeface="Arial" panose="020B0604020202020204" pitchFamily="34" charset="-122"/>
+                <a:cs typeface="Arial" panose="020B0604020202020204" pitchFamily="34" charset="-120"/>
+              </a:rPr>
+              <a:t>Logins, passwords, API keys, and anything not yet public: deals, strategy, unreleased results.</a:t>
+            </a:r>
+            <a:endParaRPr lang="en-US" sz="1150" dirty="0"/>
+          </a:p>
+        </p:txBody>
+      </p:sp>
+      <p:sp>
+        <p:nvSpPr>
+          <p:cNvPr id="24" name="Shape 17"/>
+          <p:cNvSpPr/>
+          <p:nvPr/>
+        </p:nvSpPr>
+        <p:spPr>
+          <a:xfrm>
+            <a:off x="640080" y="5623560"/>
+            <a:ext cx="10607040" cy="1005840"/>
+          </a:xfrm>
+          <a:prstGeom prst="roundRect">
+            <a:avLst>
+              <a:gd name="adj" fmla="val 10909"/>
             </a:avLst>
           </a:prstGeom>
           <a:solidFill>
@@ -8561,14 +10125,71 @@
       </p:sp>
       <p:sp>
         <p:nvSpPr>
-          <p:cNvPr id="5" name="Text 2"/>
-          <p:cNvSpPr txBox="1"/>
-          <p:nvPr/>
-        </p:nvSpPr>
-        <p:spPr>
-          <a:xfrm>
-            <a:off x="914400" y="1828800"/>
-            <a:ext cx="6035040" cy="320040"/>
+          <p:cNvPr id="25" name="Shape 18"/>
+          <p:cNvSpPr/>
+          <p:nvPr/>
+        </p:nvSpPr>
+        <p:spPr>
+          <a:xfrm>
+            <a:off x="896112" y="5879592"/>
+            <a:ext cx="457200" cy="457200"/>
+          </a:xfrm>
+          <a:prstGeom prst="ellipse">
+            <a:avLst/>
+          </a:prstGeom>
+          <a:solidFill>
+            <a:srgbClr val="FE5A5B"/>
+          </a:solidFill>
+        </p:spPr>
+      </p:sp>
+      <p:sp>
+        <p:nvSpPr>
+          <p:cNvPr id="26" name="Text 19"/>
+          <p:cNvSpPr txBox="1"/>
+          <p:nvPr/>
+        </p:nvSpPr>
+        <p:spPr>
+          <a:xfrm>
+            <a:off x="896112" y="5879592"/>
+            <a:ext cx="457200" cy="457200"/>
+          </a:xfrm>
+          <a:prstGeom prst="rect">
+            <a:avLst/>
+          </a:prstGeom>
+          <a:noFill/>
+        </p:spPr>
+        <p:txBody>
+          <a:bodyPr wrap="square" lIns="0" tIns="0" rIns="0" bIns="0" rtlCol="0" anchor="ctr"/>
+          <a:lstStyle/>
+          <a:p>
+            <a:pPr marL="0" indent="0" algn="ctr">
+              <a:buNone/>
+            </a:pPr>
+            <a:r>
+              <a:rPr lang="en-US" sz="1600" b="1" dirty="0">
+                <a:solidFill>
+                  <a:srgbClr val="FFFFFF"/>
+                </a:solidFill>
+                <a:latin typeface="Arial" panose="020B0604020202020204" pitchFamily="34" charset="0"/>
+                <a:ea typeface="Arial" panose="020B0604020202020204" pitchFamily="34" charset="-122"/>
+                <a:cs typeface="Arial" panose="020B0604020202020204" pitchFamily="34" charset="-120"/>
+              </a:rPr>
+              <a:t>!</a:t>
+            </a:r>
+            <a:endParaRPr lang="en-US" sz="1600" dirty="0"/>
+          </a:p>
+        </p:txBody>
+      </p:sp>
+      <p:sp>
+        <p:nvSpPr>
+          <p:cNvPr id="27" name="Text 20"/>
+          <p:cNvSpPr txBox="1"/>
+          <p:nvPr/>
+        </p:nvSpPr>
+        <p:spPr>
+          <a:xfrm>
+            <a:off x="1536192" y="5760720"/>
+            <a:ext cx="2743200" cy="731520"/>
           </a:xfrm>
           <a:prstGeom prst="rect">
             <a:avLst/>
@@ -8583,7 +10204,7 @@
               <a:buNone/>
             </a:pPr>
             <a:r>
-              <a:rPr lang="en-US" sz="1200" b="1" kern="0" spc="100" dirty="0">
+              <a:rPr lang="en-US" sz="1600" b="1" dirty="0">
                 <a:solidFill>
                   <a:srgbClr val="FE5A5B"/>
                 </a:solidFill>
@@ -8591,22 +10212,22 @@
                 <a:ea typeface="Arial" panose="020B0604020202020204" pitchFamily="34" charset="-122"/>
                 <a:cs typeface="Arial" panose="020B0604020202020204" pitchFamily="34" charset="-120"/>
               </a:rPr>
-              <a:t>NEVER PASTE THIS</a:t>
-            </a:r>
-            <a:endParaRPr lang="en-US" sz="1200" dirty="0"/>
-          </a:p>
-        </p:txBody>
-      </p:sp>
-      <p:sp>
-        <p:nvSpPr>
-          <p:cNvPr id="6" name="Text 3"/>
-          <p:cNvSpPr txBox="1"/>
-          <p:nvPr/>
-        </p:nvSpPr>
-        <p:spPr>
-          <a:xfrm>
-            <a:off x="914400" y="2240280"/>
-            <a:ext cx="6035040" cy="1691640"/>
+              <a:t>Rule of thumb</a:t>
+            </a:r>
+            <a:endParaRPr lang="en-US" sz="1600" dirty="0"/>
+          </a:p>
+        </p:txBody>
+      </p:sp>
+      <p:sp>
+        <p:nvSpPr>
+          <p:cNvPr id="28" name="Text 21"/>
+          <p:cNvSpPr txBox="1"/>
+          <p:nvPr/>
+        </p:nvSpPr>
+        <p:spPr>
+          <a:xfrm>
+            <a:off x="4480560" y="5623560"/>
+            <a:ext cx="6492240" cy="1005840"/>
           </a:xfrm>
           <a:prstGeom prst="rect">
             <a:avLst/>
@@ -8619,100 +10240,20 @@
           <a:p>
             <a:pPr marL="0" indent="0">
               <a:lnSpc>
-                <a:spcPts val="2000"/>
+                <a:spcPts val="1550"/>
               </a:lnSpc>
               <a:buNone/>
             </a:pPr>
             <a:r>
-              <a:rPr lang="en-US" sz="1200" b="1" dirty="0">
+              <a:rPr lang="en-US" sz="1200" dirty="0">
                 <a:solidFill>
                   <a:srgbClr val="0B1B33"/>
                 </a:solidFill>
-                <a:latin typeface="Courier New" panose="02070309020205020404" pitchFamily="34" charset="0"/>
-                <a:ea typeface="Courier New" panose="02070309020205020404" pitchFamily="34" charset="-122"/>
-                <a:cs typeface="Courier New" panose="02070309020205020404" pitchFamily="34" charset="-120"/>
-              </a:rPr>
-              <a:t xml:space="preserve">Client:    </a:t>
-            </a:r>
-            <a:r>
-              <a:rPr lang="en-US" sz="1200" dirty="0">
-                <a:solidFill>
-                  <a:srgbClr val="0B1B33"/>
-                </a:solidFill>
-                <a:latin typeface="Courier New" panose="02070309020205020404" pitchFamily="34" charset="0"/>
-                <a:ea typeface="Courier New" panose="02070309020205020404" pitchFamily="34" charset="-122"/>
-                <a:cs typeface="Courier New" panose="02070309020205020404" pitchFamily="34" charset="-120"/>
-              </a:rPr>
-              <a:t>Jane Doe, Acme Holdings Ltd
-</a:t>
-            </a:r>
-            <a:r>
-              <a:rPr lang="en-US" sz="1200" b="1" dirty="0">
-                <a:solidFill>
-                  <a:srgbClr val="0B1B33"/>
-                </a:solidFill>
-                <a:latin typeface="Courier New" panose="02070309020205020404" pitchFamily="34" charset="0"/>
-                <a:ea typeface="Courier New" panose="02070309020205020404" pitchFamily="34" charset="-122"/>
-                <a:cs typeface="Courier New" panose="02070309020205020404" pitchFamily="34" charset="-120"/>
-              </a:rPr>
-              <a:t xml:space="preserve">Account:   </a:t>
-            </a:r>
-            <a:r>
-              <a:rPr lang="en-US" sz="1200" dirty="0">
-                <a:solidFill>
-                  <a:srgbClr val="0B1B33"/>
-                </a:solidFill>
-                <a:latin typeface="Courier New" panose="02070309020205020404" pitchFamily="34" charset="0"/>
-                <a:ea typeface="Courier New" panose="02070309020205020404" pitchFamily="34" charset="-122"/>
-                <a:cs typeface="Courier New" panose="02070309020205020404" pitchFamily="34" charset="-120"/>
-              </a:rPr>
-              <a:t>88-4471-02
-</a:t>
-            </a:r>
-            <a:r>
-              <a:rPr lang="en-US" sz="1200" b="1" dirty="0">
-                <a:solidFill>
-                  <a:srgbClr val="0B1B33"/>
-                </a:solidFill>
-                <a:latin typeface="Courier New" panose="02070309020205020404" pitchFamily="34" charset="0"/>
-                <a:ea typeface="Courier New" panose="02070309020205020404" pitchFamily="34" charset="-122"/>
-                <a:cs typeface="Courier New" panose="02070309020205020404" pitchFamily="34" charset="-120"/>
-              </a:rPr>
-              <a:t xml:space="preserve">Amount:    </a:t>
-            </a:r>
-            <a:r>
-              <a:rPr lang="en-US" sz="1200" dirty="0">
-                <a:solidFill>
-                  <a:srgbClr val="0B1B33"/>
-                </a:solidFill>
-                <a:latin typeface="Courier New" panose="02070309020205020404" pitchFamily="34" charset="0"/>
-                <a:ea typeface="Courier New" panose="02070309020205020404" pitchFamily="34" charset="-122"/>
-                <a:cs typeface="Courier New" panose="02070309020205020404" pitchFamily="34" charset="-120"/>
-              </a:rPr>
-              <a:t>EUR 41,220, due 14 Mar
-</a:t>
-            </a:r>
-            <a:r>
-              <a:rPr lang="en-US" sz="1200" b="1" dirty="0">
-                <a:solidFill>
-                  <a:srgbClr val="0B1B33"/>
-                </a:solidFill>
-                <a:latin typeface="Courier New" panose="02070309020205020404" pitchFamily="34" charset="0"/>
-                <a:ea typeface="Courier New" panose="02070309020205020404" pitchFamily="34" charset="-122"/>
-                <a:cs typeface="Courier New" panose="02070309020205020404" pitchFamily="34" charset="-120"/>
-              </a:rPr>
-              <a:t xml:space="preserve">Login:     </a:t>
-            </a:r>
-            <a:r>
-              <a:rPr lang="en-US" sz="1200" dirty="0">
-                <a:solidFill>
-                  <a:srgbClr val="0B1B33"/>
-                </a:solidFill>
-                <a:latin typeface="Courier New" panose="02070309020205020404" pitchFamily="34" charset="0"/>
-                <a:ea typeface="Courier New" panose="02070309020205020404" pitchFamily="34" charset="-122"/>
-                <a:cs typeface="Courier New" panose="02070309020205020404" pitchFamily="34" charset="-120"/>
-              </a:rPr>
-              <a:t>j.doe / ••••••••</a:t>
+                <a:latin typeface="Arial" panose="020B0604020202020204" pitchFamily="34" charset="0"/>
+                <a:ea typeface="Arial" panose="020B0604020202020204" pitchFamily="34" charset="-122"/>
+                <a:cs typeface="Arial" panose="020B0604020202020204" pitchFamily="34" charset="-120"/>
+              </a:rPr>
+              <a:t>If you wouldn't post it on the company intranet for everyone to see, don't paste it into an AI chat tool either.</a:t>
             </a:r>
             <a:endParaRPr lang="en-US" sz="1200" dirty="0"/>
           </a:p>
@@ -8720,342 +10261,7 @@
       </p:sp>
       <p:sp>
         <p:nvSpPr>
-          <p:cNvPr id="7" name="Text 4"/>
-          <p:cNvSpPr txBox="1"/>
-          <p:nvPr/>
-        </p:nvSpPr>
-        <p:spPr>
-          <a:xfrm>
-            <a:off x="914400" y="4343400"/>
-            <a:ext cx="6035040" cy="548640"/>
-          </a:xfrm>
-          <a:prstGeom prst="rect">
-            <a:avLst/>
-          </a:prstGeom>
-          <a:noFill/>
-        </p:spPr>
-        <p:txBody>
-          <a:bodyPr wrap="square" lIns="0" tIns="0" rIns="0" bIns="0" rtlCol="0" anchor="ctr"/>
-          <a:lstStyle/>
-          <a:p>
-            <a:pPr marL="0" indent="0">
-              <a:lnSpc>
-                <a:spcPts val="1500"/>
-              </a:lnSpc>
-              <a:buNone/>
-            </a:pPr>
-            <a:r>
-              <a:rPr lang="en-US" sz="1150" i="1" dirty="0">
-                <a:solidFill>
-                  <a:srgbClr val="56606E"/>
-                </a:solidFill>
-                <a:latin typeface="Arial" panose="020B0604020202020204" pitchFamily="34" charset="0"/>
-                <a:ea typeface="Arial" panose="020B0604020202020204" pitchFamily="34" charset="-122"/>
-                <a:cs typeface="Arial" panose="020B0604020202020204" pitchFamily="34" charset="-120"/>
-              </a:rPr>
-              <a:t>Names a person, a company, an account number, an amount, and a login. Once it's sent, it can't be pulled back.</a:t>
-            </a:r>
-            <a:endParaRPr lang="en-US" sz="1150" dirty="0"/>
-          </a:p>
-        </p:txBody>
-      </p:sp>
-      <p:sp>
-        <p:nvSpPr>
-          <p:cNvPr id="30" name="Shape Categories"/>
-          <p:cNvSpPr/>
-          <p:nvPr/>
-        </p:nvSpPr>
-        <p:spPr>
-          <a:xfrm>
-            <a:off x="7635240" y="1600200"/>
-            <a:ext cx="4114800" cy="3429000"/>
-          </a:xfrm>
-          <a:prstGeom prst="roundRect">
-            <a:avLst>
-              <a:gd name="adj" fmla="val 4000"/>
-            </a:avLst>
-          </a:prstGeom>
-          <a:solidFill>
-            <a:srgbClr val="F2F5FA"/>
-          </a:solidFill>
-          <a:effectLst>
-            <a:outerShdw blurRad="76200" dist="25400" dir="5400000" algn="bl" rotWithShape="0">
-              <a:srgbClr val="000000">
-                <a:alpha val="8000"/>
-              </a:srgbClr>
-            </a:outerShdw>
-          </a:effectLst>
-        </p:spPr>
-      </p:sp>
-      <p:sp>
-        <p:nvSpPr>
-          <p:cNvPr id="31" name="Text Categories Heading"/>
-          <p:cNvSpPr txBox="1"/>
-          <p:nvPr/>
-        </p:nvSpPr>
-        <p:spPr>
-          <a:xfrm>
-            <a:off x="7864920" y="1874520"/>
-            <a:ext cx="3657600" cy="274320"/>
-          </a:xfrm>
-          <a:prstGeom prst="rect">
-            <a:avLst/>
-          </a:prstGeom>
-          <a:noFill/>
-        </p:spPr>
-        <p:txBody>
-          <a:bodyPr wrap="square" lIns="0" tIns="0" rIns="0" bIns="0" rtlCol="0" anchor="ctr"/>
-          <a:lstStyle/>
-          <a:p>
-            <a:pPr marL="0" indent="0">
-              <a:buNone/>
-            </a:pPr>
-            <a:r>
-              <a:rPr lang="en-US" sz="1100" b="1" dirty="0">
-                <a:solidFill>
-                  <a:srgbClr val="0B1B33"/>
-                </a:solidFill>
-                <a:latin typeface="Arial" panose="020B0604020202020204" pitchFamily="34" charset="0"/>
-              </a:rPr>
-              <a:t>Also treat as sensitive:</a:t>
-            </a:r>
-            <a:endParaRPr lang="en-US" sz="1100" dirty="0"/>
-          </a:p>
-        </p:txBody>
-      </p:sp>
-      <p:sp>
-        <p:nvSpPr>
-          <p:cNvPr id="32" name="Text Cat1"/>
-          <p:cNvSpPr txBox="1"/>
-          <p:nvPr/>
-        </p:nvSpPr>
-        <p:spPr>
-          <a:xfrm>
-            <a:off x="7864920" y="2240280"/>
-            <a:ext cx="3657600" cy="594360"/>
-          </a:xfrm>
-          <a:prstGeom prst="rect">
-            <a:avLst/>
-          </a:prstGeom>
-          <a:noFill/>
-        </p:spPr>
-        <p:txBody>
-          <a:bodyPr wrap="square" lIns="0" tIns="0" rIns="0" bIns="0" rtlCol="0" anchor="t"/>
-          <a:lstStyle/>
-          <a:p>
-            <a:pPr marL="0" indent="0">
-              <a:lnSpc>
-                <a:spcPts val="1400"/>
-              </a:lnSpc>
-              <a:buNone/>
-            </a:pPr>
-            <a:r>
-              <a:rPr lang="en-US" sz="1000" b="1" dirty="0">
-                <a:solidFill>
-                  <a:srgbClr val="0B1B33"/>
-                </a:solidFill>
-                <a:latin typeface="Arial" panose="020B0604020202020204" pitchFamily="34" charset="0"/>
-              </a:rPr>
-              <a:t>Client &amp; personal data </a:t>
-            </a:r>
-            <a:r>
-              <a:rPr lang="en-US" sz="950" dirty="0">
-                <a:solidFill>
-                  <a:srgbClr val="56606E"/>
-                </a:solidFill>
-                <a:latin typeface="Arial" panose="020B0604020202020204" pitchFamily="34" charset="0"/>
-              </a:rPr>
-              <a:t>— names, employers, contact details.</a:t>
-            </a:r>
-            <a:endParaRPr lang="en-US" sz="950" dirty="0"/>
-          </a:p>
-        </p:txBody>
-      </p:sp>
-      <p:sp>
-        <p:nvSpPr>
-          <p:cNvPr id="33" name="Text Cat2"/>
-          <p:cNvSpPr txBox="1"/>
-          <p:nvPr/>
-        </p:nvSpPr>
-        <p:spPr>
-          <a:xfrm>
-            <a:off x="7864920" y="2926080"/>
-            <a:ext cx="3657600" cy="594360"/>
-          </a:xfrm>
-          <a:prstGeom prst="rect">
-            <a:avLst/>
-          </a:prstGeom>
-          <a:noFill/>
-        </p:spPr>
-        <p:txBody>
-          <a:bodyPr wrap="square" lIns="0" tIns="0" rIns="0" bIns="0" rtlCol="0" anchor="t"/>
-          <a:lstStyle/>
-          <a:p>
-            <a:pPr marL="0" indent="0">
-              <a:lnSpc>
-                <a:spcPts val="1400"/>
-              </a:lnSpc>
-              <a:buNone/>
-            </a:pPr>
-            <a:r>
-              <a:rPr lang="en-US" sz="1000" b="1" dirty="0">
-                <a:solidFill>
-                  <a:srgbClr val="0B1B33"/>
-                </a:solidFill>
-                <a:latin typeface="Arial" panose="020B0604020202020204" pitchFamily="34" charset="0"/>
-              </a:rPr>
-              <a:t>Account &amp; case numbers </a:t>
-            </a:r>
-            <a:r>
-              <a:rPr lang="en-US" sz="950" dirty="0">
-                <a:solidFill>
-                  <a:srgbClr val="56606E"/>
-                </a:solidFill>
-                <a:latin typeface="Arial" panose="020B0604020202020204" pitchFamily="34" charset="0"/>
-              </a:rPr>
-              <a:t>— anything that maps to a record.</a:t>
-            </a:r>
-            <a:endParaRPr lang="en-US" sz="950" dirty="0"/>
-          </a:p>
-        </p:txBody>
-      </p:sp>
-      <p:sp>
-        <p:nvSpPr>
-          <p:cNvPr id="34" name="Text Cat3"/>
-          <p:cNvSpPr txBox="1"/>
-          <p:nvPr/>
-        </p:nvSpPr>
-        <p:spPr>
-          <a:xfrm>
-            <a:off x="7864920" y="3611880"/>
-            <a:ext cx="3657600" cy="594360"/>
-          </a:xfrm>
-          <a:prstGeom prst="rect">
-            <a:avLst/>
-          </a:prstGeom>
-          <a:noFill/>
-        </p:spPr>
-        <p:txBody>
-          <a:bodyPr wrap="square" lIns="0" tIns="0" rIns="0" bIns="0" rtlCol="0" anchor="t"/>
-          <a:lstStyle/>
-          <a:p>
-            <a:pPr marL="0" indent="0">
-              <a:lnSpc>
-                <a:spcPts val="1400"/>
-              </a:lnSpc>
-              <a:buNone/>
-            </a:pPr>
-            <a:r>
-              <a:rPr lang="en-US" sz="1000" b="1" dirty="0">
-                <a:solidFill>
-                  <a:srgbClr val="0B1B33"/>
-                </a:solidFill>
-                <a:latin typeface="Arial" panose="020B0604020202020204" pitchFamily="34" charset="0"/>
-              </a:rPr>
-              <a:t>Exact financial figures </a:t>
-            </a:r>
-            <a:r>
-              <a:rPr lang="en-US" sz="950" dirty="0">
-                <a:solidFill>
-                  <a:srgbClr val="56606E"/>
-                </a:solidFill>
-                <a:latin typeface="Arial" panose="020B0604020202020204" pitchFamily="34" charset="0"/>
-              </a:rPr>
-              <a:t>— round amounts or describe them instead.</a:t>
-            </a:r>
-            <a:endParaRPr lang="en-US" sz="950" dirty="0"/>
-          </a:p>
-        </p:txBody>
-      </p:sp>
-      <p:sp>
-        <p:nvSpPr>
-          <p:cNvPr id="35" name="Text Cat4"/>
-          <p:cNvSpPr txBox="1"/>
-          <p:nvPr/>
-        </p:nvSpPr>
-        <p:spPr>
-          <a:xfrm>
-            <a:off x="7864920" y="4297680"/>
-            <a:ext cx="3657600" cy="594360"/>
-          </a:xfrm>
-          <a:prstGeom prst="rect">
-            <a:avLst/>
-          </a:prstGeom>
-          <a:noFill/>
-        </p:spPr>
-        <p:txBody>
-          <a:bodyPr wrap="square" lIns="0" tIns="0" rIns="0" bIns="0" rtlCol="0" anchor="t"/>
-          <a:lstStyle/>
-          <a:p>
-            <a:pPr marL="0" indent="0">
-              <a:lnSpc>
-                <a:spcPts val="1400"/>
-              </a:lnSpc>
-              <a:buNone/>
-            </a:pPr>
-            <a:r>
-              <a:rPr lang="en-US" sz="1000" b="1" dirty="0">
-                <a:solidFill>
-                  <a:srgbClr val="0B1B33"/>
-                </a:solidFill>
-                <a:latin typeface="Arial" panose="020B0604020202020204" pitchFamily="34" charset="0"/>
-              </a:rPr>
-              <a:t>Credentials &amp; internal info </a:t>
-            </a:r>
-            <a:r>
-              <a:rPr lang="en-US" sz="950" dirty="0">
-                <a:solidFill>
-                  <a:srgbClr val="56606E"/>
-                </a:solidFill>
-                <a:latin typeface="Arial" panose="020B0604020202020204" pitchFamily="34" charset="0"/>
-              </a:rPr>
-              <a:t>— logins, keys, anything not yet public.</a:t>
-            </a:r>
-            <a:endParaRPr lang="en-US" sz="950" dirty="0"/>
-          </a:p>
-        </p:txBody>
-      </p:sp>
-      <p:sp>
-        <p:nvSpPr>
-          <p:cNvPr id="9" name="Text 5"/>
-          <p:cNvSpPr txBox="1"/>
-          <p:nvPr/>
-        </p:nvSpPr>
-        <p:spPr>
-          <a:xfrm>
-            <a:off x="640080" y="5440680"/>
-            <a:ext cx="10881360" cy="548640"/>
-          </a:xfrm>
-          <a:prstGeom prst="rect">
-            <a:avLst/>
-          </a:prstGeom>
-          <a:noFill/>
-        </p:spPr>
-        <p:txBody>
-          <a:bodyPr wrap="square" lIns="0" tIns="0" rIns="0" bIns="0" rtlCol="0" anchor="ctr"/>
-          <a:lstStyle/>
-          <a:p>
-            <a:pPr marL="0" indent="0" algn="ctr">
-              <a:buNone/>
-            </a:pPr>
-            <a:r>
-              <a:rPr lang="en-US" sz="1400" b="1" dirty="0">
-                <a:solidFill>
-                  <a:srgbClr val="00081D"/>
-                </a:solidFill>
-                <a:latin typeface="Arial" panose="020B0604020202020204" pitchFamily="34" charset="0"/>
-                <a:ea typeface="Arial" panose="020B0604020202020204" pitchFamily="34" charset="-122"/>
-                <a:cs typeface="Arial" panose="020B0604020202020204" pitchFamily="34" charset="-120"/>
-              </a:rPr>
-              <a:t>Take out the who, keep the what. Names, account numbers and exact amounts come out; the actual problem stays in.</a:t>
-            </a:r>
-            <a:endParaRPr lang="en-US" sz="1400" dirty="0"/>
-          </a:p>
-        </p:txBody>
-      </p:sp>
-      <p:sp>
-        <p:nvSpPr>
-          <p:cNvPr id="10" name="Text 6"/>
+          <p:cNvPr id="29" name="Text 22"/>
           <p:cNvSpPr txBox="1"/>
           <p:nvPr/>
         </p:nvSpPr>
@@ -9085,7 +10291,7 @@
                 <a:ea typeface="Arial" panose="020B0604020202020204" pitchFamily="34" charset="-122"/>
                 <a:cs typeface="Arial" panose="020B0604020202020204" pitchFamily="34" charset="-120"/>
               </a:rPr>
-              <a:t>8</a:t>
+              <a:t>9</a:t>
             </a:r>
             <a:endParaRPr lang="en-US" sz="900" dirty="0"/>
           </a:p>
@@ -9172,7 +10378,7 @@
               <a:buNone/>
             </a:pPr>
             <a:r>
-              <a:rPr lang="en-US" sz="2600" dirty="0">
+              <a:rPr lang="en-US" sz="3000" dirty="0">
                 <a:solidFill>
                   <a:srgbClr val="FFFFFF"/>
                 </a:solidFill>
@@ -9180,569 +10386,22 @@
                 <a:ea typeface="Arial" panose="020B0604020202020204" pitchFamily="34" charset="-122"/>
                 <a:cs typeface="Arial" panose="020B0604020202020204" pitchFamily="34" charset="-120"/>
               </a:rPr>
-              <a:t>Why AI makes things up (and how to reduce it)</a:t>
-            </a:r>
-            <a:endParaRPr lang="en-US" sz="2600" dirty="0"/>
-          </a:p>
-        </p:txBody>
-      </p:sp>
-      <p:sp>
-        <p:nvSpPr>
-          <p:cNvPr id="4" name="Text 1"/>
-          <p:cNvSpPr txBox="1"/>
-          <p:nvPr/>
-        </p:nvSpPr>
-        <p:spPr>
-          <a:xfrm>
-            <a:off x="640080" y="1298448"/>
-            <a:ext cx="10881360" cy="320040"/>
-          </a:xfrm>
-          <a:prstGeom prst="rect">
-            <a:avLst/>
-          </a:prstGeom>
-          <a:noFill/>
-        </p:spPr>
-        <p:txBody>
-          <a:bodyPr wrap="square" lIns="0" tIns="0" rIns="0" bIns="0" rtlCol="0" anchor="ctr"/>
-          <a:lstStyle/>
-          <a:p>
-            <a:pPr marL="0" indent="0" algn="ctr">
-              <a:buNone/>
-            </a:pPr>
-            <a:r>
-              <a:rPr lang="en-US" sz="1300" i="1" dirty="0">
-                <a:solidFill>
-                  <a:srgbClr val="56606E"/>
-                </a:solidFill>
-                <a:latin typeface="Arial" panose="020B0604020202020204" pitchFamily="34" charset="0"/>
-                <a:ea typeface="Arial" panose="020B0604020202020204" pitchFamily="34" charset="-122"/>
-                <a:cs typeface="Arial" panose="020B0604020202020204" pitchFamily="34" charset="-120"/>
-              </a:rPr>
-              <a:t>This matters most with an outside tool: there's no one behind it checking your specific answer.</a:t>
-            </a:r>
-            <a:endParaRPr lang="en-US" sz="1300" dirty="0"/>
-          </a:p>
-        </p:txBody>
-      </p:sp>
-      <p:pic>
-        <p:nvPicPr>
-          <p:cNvPr id="5" name="Image 1" descr="/home/claude/work/assets/panel_5.55x3.75.png"/>
-          <p:cNvPicPr>
-            <a:picLocks noChangeAspect="1"/>
-          </p:cNvPicPr>
-          <p:nvPr/>
-        </p:nvPicPr>
-        <p:blipFill>
-          <a:blip r:embed="rId2"/>
-          <a:stretch>
-            <a:fillRect/>
-          </a:stretch>
-        </p:blipFill>
-        <p:spPr>
-          <a:xfrm>
-            <a:off x="640080" y="1920240"/>
-            <a:ext cx="5074920" cy="3429000"/>
-          </a:xfrm>
-          <a:prstGeom prst="rect">
-            <a:avLst/>
-          </a:prstGeom>
-          <a:effectLst>
-            <a:outerShdw blurRad="203200" dist="63500" dir="5400000" algn="bl" rotWithShape="0">
-              <a:srgbClr val="3A2E6E">
-                <a:alpha val="35000"/>
-              </a:srgbClr>
-            </a:outerShdw>
-          </a:effectLst>
-        </p:spPr>
-      </p:pic>
-      <p:sp>
-        <p:nvSpPr>
-          <p:cNvPr id="6" name="Text 2"/>
-          <p:cNvSpPr txBox="1"/>
-          <p:nvPr/>
-        </p:nvSpPr>
-        <p:spPr>
-          <a:xfrm>
-            <a:off x="914400" y="2176272"/>
-            <a:ext cx="4526280" cy="320040"/>
-          </a:xfrm>
-          <a:prstGeom prst="rect">
-            <a:avLst/>
-          </a:prstGeom>
-          <a:noFill/>
-        </p:spPr>
-        <p:txBody>
-          <a:bodyPr wrap="square" lIns="0" tIns="0" rIns="0" bIns="0" rtlCol="0" anchor="ctr"/>
-          <a:lstStyle/>
-          <a:p>
-            <a:pPr marL="0" indent="0">
-              <a:buNone/>
-            </a:pPr>
-            <a:r>
-              <a:rPr lang="en-US" sz="1250" b="1" kern="0" spc="100" dirty="0">
-                <a:solidFill>
-                  <a:srgbClr val="4592EF"/>
-                </a:solidFill>
-                <a:latin typeface="Arial" panose="020B0604020202020204" pitchFamily="34" charset="0"/>
-                <a:ea typeface="Arial" panose="020B0604020202020204" pitchFamily="34" charset="-122"/>
-                <a:cs typeface="Arial" panose="020B0604020202020204" pitchFamily="34" charset="-120"/>
-              </a:rPr>
-              <a:t>WHY IT HAPPENS</a:t>
-            </a:r>
-            <a:endParaRPr lang="en-US" sz="1250" dirty="0"/>
-          </a:p>
-        </p:txBody>
-      </p:sp>
-      <p:pic>
-        <p:nvPicPr>
-          <p:cNvPr id="7" name="Image 2" descr="/home/claude/work/assets/badge_gradient.png"/>
-          <p:cNvPicPr>
-            <a:picLocks noChangeAspect="1"/>
-          </p:cNvPicPr>
-          <p:nvPr/>
-        </p:nvPicPr>
-        <p:blipFill>
-          <a:blip r:embed="rId3"/>
-          <a:stretch>
-            <a:fillRect/>
-          </a:stretch>
-        </p:blipFill>
-        <p:spPr>
-          <a:xfrm>
-            <a:off x="914400" y="2633472"/>
-            <a:ext cx="310896" cy="310896"/>
-          </a:xfrm>
-          <a:prstGeom prst="rect">
-            <a:avLst/>
-          </a:prstGeom>
-          <a:effectLst>
-            <a:outerShdw blurRad="76200" dist="25400" dir="5400000" algn="bl" rotWithShape="0">
-              <a:srgbClr val="3A2E6E">
-                <a:alpha val="30000"/>
-              </a:srgbClr>
-            </a:outerShdw>
-          </a:effectLst>
-        </p:spPr>
-      </p:pic>
-      <p:sp>
-        <p:nvSpPr>
-          <p:cNvPr id="8" name="Text 3"/>
-          <p:cNvSpPr txBox="1"/>
-          <p:nvPr/>
-        </p:nvSpPr>
-        <p:spPr>
-          <a:xfrm>
-            <a:off x="914400" y="2633472"/>
-            <a:ext cx="310896" cy="310896"/>
-          </a:xfrm>
-          <a:prstGeom prst="rect">
-            <a:avLst/>
-          </a:prstGeom>
-          <a:noFill/>
-        </p:spPr>
-        <p:txBody>
-          <a:bodyPr wrap="square" lIns="0" tIns="0" rIns="0" bIns="0" rtlCol="0" anchor="ctr"/>
-          <a:lstStyle/>
-          <a:p>
-            <a:pPr marL="0" indent="0" algn="ctr">
-              <a:buNone/>
-            </a:pPr>
-            <a:r>
-              <a:rPr lang="en-US" sz="1200" b="1" dirty="0">
-                <a:solidFill>
-                  <a:srgbClr val="FFFFFF"/>
-                </a:solidFill>
-                <a:latin typeface="Arial" panose="020B0604020202020204" pitchFamily="34" charset="0"/>
-                <a:ea typeface="Arial" panose="020B0604020202020204" pitchFamily="34" charset="-122"/>
-                <a:cs typeface="Arial" panose="020B0604020202020204" pitchFamily="34" charset="-120"/>
-              </a:rPr>
-              <a:t>1</a:t>
-            </a:r>
-            <a:endParaRPr lang="en-US" sz="1200" dirty="0"/>
-          </a:p>
-        </p:txBody>
-      </p:sp>
-      <p:sp>
-        <p:nvSpPr>
-          <p:cNvPr id="9" name="Text 4"/>
-          <p:cNvSpPr txBox="1"/>
-          <p:nvPr/>
-        </p:nvSpPr>
-        <p:spPr>
-          <a:xfrm>
-            <a:off x="1353312" y="2523744"/>
-            <a:ext cx="4023360" cy="621792"/>
-          </a:xfrm>
-          <a:prstGeom prst="rect">
-            <a:avLst/>
-          </a:prstGeom>
-          <a:noFill/>
-        </p:spPr>
-        <p:txBody>
-          <a:bodyPr wrap="square" lIns="0" tIns="0" rIns="0" bIns="0" rtlCol="0" anchor="ctr"/>
-          <a:lstStyle/>
-          <a:p>
-            <a:pPr marL="0" indent="0">
-              <a:lnSpc>
-                <a:spcPts val="1400"/>
-              </a:lnSpc>
-              <a:buNone/>
-            </a:pPr>
-            <a:r>
-              <a:rPr lang="en-US" sz="1100" dirty="0">
-                <a:solidFill>
-                  <a:srgbClr val="D6E6F5"/>
-                </a:solidFill>
-                <a:latin typeface="Arial" panose="020B0604020202020204" pitchFamily="34" charset="0"/>
-                <a:ea typeface="Arial" panose="020B0604020202020204" pitchFamily="34" charset="-122"/>
-                <a:cs typeface="Arial" panose="020B0604020202020204" pitchFamily="34" charset="-120"/>
-              </a:rPr>
-              <a:t>No access to our systems, it only knows what you tell it.</a:t>
-            </a:r>
-            <a:endParaRPr lang="en-US" sz="1100" dirty="0"/>
-          </a:p>
-        </p:txBody>
-      </p:sp>
-      <p:pic>
-        <p:nvPicPr>
-          <p:cNvPr id="10" name="Image 3" descr="/home/claude/work/assets/badge_gradient.png"/>
-          <p:cNvPicPr>
-            <a:picLocks noChangeAspect="1"/>
-          </p:cNvPicPr>
-          <p:nvPr/>
-        </p:nvPicPr>
-        <p:blipFill>
-          <a:blip r:embed="rId3"/>
-          <a:stretch>
-            <a:fillRect/>
-          </a:stretch>
-        </p:blipFill>
-        <p:spPr>
-          <a:xfrm>
-            <a:off x="914400" y="3300984"/>
-            <a:ext cx="310896" cy="310896"/>
-          </a:xfrm>
-          <a:prstGeom prst="rect">
-            <a:avLst/>
-          </a:prstGeom>
-          <a:effectLst>
-            <a:outerShdw blurRad="76200" dist="25400" dir="5400000" algn="bl" rotWithShape="0">
-              <a:srgbClr val="3A2E6E">
-                <a:alpha val="30000"/>
-              </a:srgbClr>
-            </a:outerShdw>
-          </a:effectLst>
-        </p:spPr>
-      </p:pic>
-      <p:sp>
-        <p:nvSpPr>
-          <p:cNvPr id="11" name="Text 5"/>
-          <p:cNvSpPr txBox="1"/>
-          <p:nvPr/>
-        </p:nvSpPr>
-        <p:spPr>
-          <a:xfrm>
-            <a:off x="914400" y="3300984"/>
-            <a:ext cx="310896" cy="310896"/>
-          </a:xfrm>
-          <a:prstGeom prst="rect">
-            <a:avLst/>
-          </a:prstGeom>
-          <a:noFill/>
-        </p:spPr>
-        <p:txBody>
-          <a:bodyPr wrap="square" lIns="0" tIns="0" rIns="0" bIns="0" rtlCol="0" anchor="ctr"/>
-          <a:lstStyle/>
-          <a:p>
-            <a:pPr marL="0" indent="0" algn="ctr">
-              <a:buNone/>
-            </a:pPr>
-            <a:r>
-              <a:rPr lang="en-US" sz="1200" b="1" dirty="0">
-                <a:solidFill>
-                  <a:srgbClr val="FFFFFF"/>
-                </a:solidFill>
-                <a:latin typeface="Arial" panose="020B0604020202020204" pitchFamily="34" charset="0"/>
-                <a:ea typeface="Arial" panose="020B0604020202020204" pitchFamily="34" charset="-122"/>
-                <a:cs typeface="Arial" panose="020B0604020202020204" pitchFamily="34" charset="-120"/>
-              </a:rPr>
-              <a:t>2</a:t>
-            </a:r>
-            <a:endParaRPr lang="en-US" sz="1200" dirty="0"/>
-          </a:p>
-        </p:txBody>
-      </p:sp>
-      <p:sp>
-        <p:nvSpPr>
-          <p:cNvPr id="12" name="Text 6"/>
-          <p:cNvSpPr txBox="1"/>
-          <p:nvPr/>
-        </p:nvSpPr>
-        <p:spPr>
-          <a:xfrm>
-            <a:off x="1353312" y="3191256"/>
-            <a:ext cx="4023360" cy="621792"/>
-          </a:xfrm>
-          <a:prstGeom prst="rect">
-            <a:avLst/>
-          </a:prstGeom>
-          <a:noFill/>
-        </p:spPr>
-        <p:txBody>
-          <a:bodyPr wrap="square" lIns="0" tIns="0" rIns="0" bIns="0" rtlCol="0" anchor="ctr"/>
-          <a:lstStyle/>
-          <a:p>
-            <a:pPr marL="0" indent="0">
-              <a:lnSpc>
-                <a:spcPts val="1400"/>
-              </a:lnSpc>
-              <a:buNone/>
-            </a:pPr>
-            <a:r>
-              <a:rPr lang="en-US" sz="1100" dirty="0">
-                <a:solidFill>
-                  <a:srgbClr val="D6E6F5"/>
-                </a:solidFill>
-                <a:latin typeface="Arial" panose="020B0604020202020204" pitchFamily="34" charset="0"/>
-                <a:ea typeface="Arial" panose="020B0604020202020204" pitchFamily="34" charset="-122"/>
-                <a:cs typeface="Arial" panose="020B0604020202020204" pitchFamily="34" charset="-120"/>
-              </a:rPr>
-              <a:t>It has a cutoff date, a new rule or updated circular might not be in there yet.</a:t>
-            </a:r>
-            <a:endParaRPr lang="en-US" sz="1100" dirty="0"/>
-          </a:p>
-        </p:txBody>
-      </p:sp>
-      <p:pic>
-        <p:nvPicPr>
-          <p:cNvPr id="13" name="Image 4" descr="/home/claude/work/assets/badge_gradient.png"/>
-          <p:cNvPicPr>
-            <a:picLocks noChangeAspect="1"/>
-          </p:cNvPicPr>
-          <p:nvPr/>
-        </p:nvPicPr>
-        <p:blipFill>
-          <a:blip r:embed="rId3"/>
-          <a:stretch>
-            <a:fillRect/>
-          </a:stretch>
-        </p:blipFill>
-        <p:spPr>
-          <a:xfrm>
-            <a:off x="914400" y="3968496"/>
-            <a:ext cx="310896" cy="310896"/>
-          </a:xfrm>
-          <a:prstGeom prst="rect">
-            <a:avLst/>
-          </a:prstGeom>
-          <a:effectLst>
-            <a:outerShdw blurRad="76200" dist="25400" dir="5400000" algn="bl" rotWithShape="0">
-              <a:srgbClr val="3A2E6E">
-                <a:alpha val="30000"/>
-              </a:srgbClr>
-            </a:outerShdw>
-          </a:effectLst>
-        </p:spPr>
-      </p:pic>
-      <p:sp>
-        <p:nvSpPr>
-          <p:cNvPr id="14" name="Text 7"/>
-          <p:cNvSpPr txBox="1"/>
-          <p:nvPr/>
-        </p:nvSpPr>
-        <p:spPr>
-          <a:xfrm>
-            <a:off x="914400" y="3968496"/>
-            <a:ext cx="310896" cy="310896"/>
-          </a:xfrm>
-          <a:prstGeom prst="rect">
-            <a:avLst/>
-          </a:prstGeom>
-          <a:noFill/>
-        </p:spPr>
-        <p:txBody>
-          <a:bodyPr wrap="square" lIns="0" tIns="0" rIns="0" bIns="0" rtlCol="0" anchor="ctr"/>
-          <a:lstStyle/>
-          <a:p>
-            <a:pPr marL="0" indent="0" algn="ctr">
-              <a:buNone/>
-            </a:pPr>
-            <a:r>
-              <a:rPr lang="en-US" sz="1200" b="1" dirty="0">
-                <a:solidFill>
-                  <a:srgbClr val="FFFFFF"/>
-                </a:solidFill>
-                <a:latin typeface="Arial" panose="020B0604020202020204" pitchFamily="34" charset="0"/>
-                <a:ea typeface="Arial" panose="020B0604020202020204" pitchFamily="34" charset="-122"/>
-                <a:cs typeface="Arial" panose="020B0604020202020204" pitchFamily="34" charset="-120"/>
-              </a:rPr>
-              <a:t>3</a:t>
-            </a:r>
-            <a:endParaRPr lang="en-US" sz="1200" dirty="0"/>
-          </a:p>
-        </p:txBody>
-      </p:sp>
-      <p:sp>
-        <p:nvSpPr>
-          <p:cNvPr id="15" name="Text 8"/>
-          <p:cNvSpPr txBox="1"/>
-          <p:nvPr/>
-        </p:nvSpPr>
-        <p:spPr>
-          <a:xfrm>
-            <a:off x="1353312" y="3858768"/>
-            <a:ext cx="4023360" cy="621792"/>
-          </a:xfrm>
-          <a:prstGeom prst="rect">
-            <a:avLst/>
-          </a:prstGeom>
-          <a:noFill/>
-        </p:spPr>
-        <p:txBody>
-          <a:bodyPr wrap="square" lIns="0" tIns="0" rIns="0" bIns="0" rtlCol="0" anchor="ctr"/>
-          <a:lstStyle/>
-          <a:p>
-            <a:pPr marL="0" indent="0">
-              <a:lnSpc>
-                <a:spcPts val="1400"/>
-              </a:lnSpc>
-              <a:buNone/>
-            </a:pPr>
-            <a:r>
-              <a:rPr lang="en-US" sz="1100" dirty="0">
-                <a:solidFill>
-                  <a:srgbClr val="D6E6F5"/>
-                </a:solidFill>
-                <a:latin typeface="Arial" panose="020B0604020202020204" pitchFamily="34" charset="0"/>
-                <a:ea typeface="Arial" panose="020B0604020202020204" pitchFamily="34" charset="-122"/>
-                <a:cs typeface="Arial" panose="020B0604020202020204" pitchFamily="34" charset="-120"/>
-              </a:rPr>
-              <a:t>It's built to sound fluent, not to flag doubt: the tone is the same whether it's sure or just making something up.</a:t>
-            </a:r>
-            <a:endParaRPr lang="en-US" sz="1100" dirty="0"/>
-          </a:p>
-        </p:txBody>
-      </p:sp>
-      <p:pic>
-        <p:nvPicPr>
-          <p:cNvPr id="16" name="Image 5" descr="/home/claude/work/assets/badge_gradient.png"/>
-          <p:cNvPicPr>
-            <a:picLocks noChangeAspect="1"/>
-          </p:cNvPicPr>
-          <p:nvPr/>
-        </p:nvPicPr>
-        <p:blipFill>
-          <a:blip r:embed="rId3"/>
-          <a:stretch>
-            <a:fillRect/>
-          </a:stretch>
-        </p:blipFill>
-        <p:spPr>
-          <a:xfrm>
-            <a:off x="914400" y="4636008"/>
-            <a:ext cx="310896" cy="310896"/>
-          </a:xfrm>
-          <a:prstGeom prst="rect">
-            <a:avLst/>
-          </a:prstGeom>
-          <a:effectLst>
-            <a:outerShdw blurRad="76200" dist="25400" dir="5400000" algn="bl" rotWithShape="0">
-              <a:srgbClr val="3A2E6E">
-                <a:alpha val="30000"/>
-              </a:srgbClr>
-            </a:outerShdw>
-          </a:effectLst>
-        </p:spPr>
-      </p:pic>
-      <p:sp>
-        <p:nvSpPr>
-          <p:cNvPr id="17" name="Text 9"/>
-          <p:cNvSpPr txBox="1"/>
-          <p:nvPr/>
-        </p:nvSpPr>
-        <p:spPr>
-          <a:xfrm>
-            <a:off x="914400" y="4636008"/>
-            <a:ext cx="310896" cy="310896"/>
-          </a:xfrm>
-          <a:prstGeom prst="rect">
-            <a:avLst/>
-          </a:prstGeom>
-          <a:noFill/>
-        </p:spPr>
-        <p:txBody>
-          <a:bodyPr wrap="square" lIns="0" tIns="0" rIns="0" bIns="0" rtlCol="0" anchor="ctr"/>
-          <a:lstStyle/>
-          <a:p>
-            <a:pPr marL="0" indent="0" algn="ctr">
-              <a:buNone/>
-            </a:pPr>
-            <a:r>
-              <a:rPr lang="en-US" sz="1200" b="1" dirty="0">
-                <a:solidFill>
-                  <a:srgbClr val="FFFFFF"/>
-                </a:solidFill>
-                <a:latin typeface="Arial" panose="020B0604020202020204" pitchFamily="34" charset="0"/>
-                <a:ea typeface="Arial" panose="020B0604020202020204" pitchFamily="34" charset="-122"/>
-                <a:cs typeface="Arial" panose="020B0604020202020204" pitchFamily="34" charset="-120"/>
-              </a:rPr>
-              <a:t>4</a:t>
-            </a:r>
-            <a:endParaRPr lang="en-US" sz="1200" dirty="0"/>
-          </a:p>
-        </p:txBody>
-      </p:sp>
-      <p:sp>
-        <p:nvSpPr>
-          <p:cNvPr id="18" name="Text 10"/>
-          <p:cNvSpPr txBox="1"/>
-          <p:nvPr/>
-        </p:nvSpPr>
-        <p:spPr>
-          <a:xfrm>
-            <a:off x="1353312" y="4526280"/>
-            <a:ext cx="4023360" cy="621792"/>
-          </a:xfrm>
-          <a:prstGeom prst="rect">
-            <a:avLst/>
-          </a:prstGeom>
-          <a:noFill/>
-        </p:spPr>
-        <p:txBody>
-          <a:bodyPr wrap="square" lIns="0" tIns="0" rIns="0" bIns="0" rtlCol="0" anchor="ctr"/>
-          <a:lstStyle/>
-          <a:p>
-            <a:pPr marL="0" indent="0">
-              <a:lnSpc>
-                <a:spcPts val="1400"/>
-              </a:lnSpc>
-              <a:buNone/>
-            </a:pPr>
-            <a:r>
-              <a:rPr lang="en-US" sz="1100" dirty="0">
-                <a:solidFill>
-                  <a:srgbClr val="D6E6F5"/>
-                </a:solidFill>
-                <a:latin typeface="Arial" panose="020B0604020202020204" pitchFamily="34" charset="0"/>
-                <a:ea typeface="Arial" panose="020B0604020202020204" pitchFamily="34" charset="-122"/>
-                <a:cs typeface="Arial" panose="020B0604020202020204" pitchFamily="34" charset="-120"/>
-              </a:rPr>
-              <a:t>Disagreeing with it often makes it agree with you, which isn't the same as you being right.</a:t>
-            </a:r>
-            <a:endParaRPr lang="en-US" sz="1100" dirty="0"/>
-          </a:p>
-        </p:txBody>
-      </p:sp>
-      <p:sp>
-        <p:nvSpPr>
-          <p:cNvPr id="19" name="Shape 11"/>
+              <a:t>Examples of what not to share</a:t>
+            </a:r>
+            <a:endParaRPr lang="en-US" sz="3000" dirty="0"/>
+          </a:p>
+        </p:txBody>
+      </p:sp>
+      <p:sp>
+        <p:nvSpPr>
+          <p:cNvPr id="4" name="Shape 1"/>
           <p:cNvSpPr/>
           <p:nvPr/>
         </p:nvSpPr>
         <p:spPr>
           <a:xfrm>
-            <a:off x="6172200" y="1920240"/>
-            <a:ext cx="5074920" cy="3429000"/>
+            <a:off x="640080" y="1600200"/>
+            <a:ext cx="6583680" cy="3429000"/>
           </a:xfrm>
           <a:prstGeom prst="roundRect">
             <a:avLst>
@@ -9750,7 +10409,7 @@
             </a:avLst>
           </a:prstGeom>
           <a:solidFill>
-            <a:srgbClr val="F2F5FA"/>
+            <a:srgbClr val="FEEDED"/>
           </a:solidFill>
           <a:effectLst>
             <a:outerShdw blurRad="101600" dist="38100" dir="5400000" algn="bl" rotWithShape="0">
@@ -9763,14 +10422,14 @@
       </p:sp>
       <p:sp>
         <p:nvSpPr>
-          <p:cNvPr id="20" name="Text 12"/>
-          <p:cNvSpPr txBox="1"/>
-          <p:nvPr/>
-        </p:nvSpPr>
-        <p:spPr>
-          <a:xfrm>
-            <a:off x="6446520" y="2176272"/>
-            <a:ext cx="4526280" cy="320040"/>
+          <p:cNvPr id="5" name="Text 2"/>
+          <p:cNvSpPr txBox="1"/>
+          <p:nvPr/>
+        </p:nvSpPr>
+        <p:spPr>
+          <a:xfrm>
+            <a:off x="914400" y="1828800"/>
+            <a:ext cx="6035040" cy="320040"/>
           </a:xfrm>
           <a:prstGeom prst="rect">
             <a:avLst/>
@@ -9785,30 +10444,30 @@
               <a:buNone/>
             </a:pPr>
             <a:r>
-              <a:rPr lang="en-US" sz="1250" b="1" kern="0" spc="100" dirty="0">
-                <a:solidFill>
-                  <a:srgbClr val="2CB2D7"/>
-                </a:solidFill>
-                <a:latin typeface="Arial" panose="020B0604020202020204" pitchFamily="34" charset="0"/>
-                <a:ea typeface="Arial" panose="020B0604020202020204" pitchFamily="34" charset="-122"/>
-                <a:cs typeface="Arial" panose="020B0604020202020204" pitchFamily="34" charset="-120"/>
-              </a:rPr>
-              <a:t>HOW TO REDUCE IT: PROMPT FOR IT</a:t>
-            </a:r>
-            <a:endParaRPr lang="en-US" sz="1250" dirty="0"/>
-          </a:p>
-        </p:txBody>
-      </p:sp>
-      <p:sp>
-        <p:nvSpPr>
-          <p:cNvPr id="21" name="Text 13"/>
-          <p:cNvSpPr txBox="1"/>
-          <p:nvPr/>
-        </p:nvSpPr>
-        <p:spPr>
-          <a:xfrm>
-            <a:off x="6446520" y="2697480"/>
-            <a:ext cx="4526280" cy="320040"/>
+              <a:rPr lang="en-US" sz="1200" b="1" kern="0" spc="100" dirty="0">
+                <a:solidFill>
+                  <a:srgbClr val="FE5A5B"/>
+                </a:solidFill>
+                <a:latin typeface="Arial" panose="020B0604020202020204" pitchFamily="34" charset="0"/>
+                <a:ea typeface="Arial" panose="020B0604020202020204" pitchFamily="34" charset="-122"/>
+                <a:cs typeface="Arial" panose="020B0604020202020204" pitchFamily="34" charset="-120"/>
+              </a:rPr>
+              <a:t>NEVER PASTE THIS</a:t>
+            </a:r>
+            <a:endParaRPr lang="en-US" sz="1200" dirty="0"/>
+          </a:p>
+        </p:txBody>
+      </p:sp>
+      <p:sp>
+        <p:nvSpPr>
+          <p:cNvPr id="6" name="Text 3"/>
+          <p:cNvSpPr txBox="1"/>
+          <p:nvPr/>
+        </p:nvSpPr>
+        <p:spPr>
+          <a:xfrm>
+            <a:off x="914400" y="2240280"/>
+            <a:ext cx="6035040" cy="1691640"/>
           </a:xfrm>
           <a:prstGeom prst="rect">
             <a:avLst/>
@@ -9820,10 +10479,134 @@
           <a:lstStyle/>
           <a:p>
             <a:pPr marL="0" indent="0">
-              <a:buNone/>
-            </a:pPr>
-            <a:r>
-              <a:rPr lang="en-US" sz="1200" i="1" dirty="0">
+              <a:lnSpc>
+                <a:spcPts val="2000"/>
+              </a:lnSpc>
+              <a:buNone/>
+            </a:pPr>
+            <a:r>
+              <a:rPr lang="en-US" sz="1200" b="1" dirty="0">
+                <a:solidFill>
+                  <a:srgbClr val="0B1B33"/>
+                </a:solidFill>
+                <a:latin typeface="Courier New" panose="02070309020205020404" pitchFamily="34" charset="0"/>
+                <a:ea typeface="Courier New" panose="02070309020205020404" pitchFamily="34" charset="-122"/>
+                <a:cs typeface="Courier New" panose="02070309020205020404" pitchFamily="34" charset="-120"/>
+              </a:rPr>
+              <a:t>Client:    </a:t>
+            </a:r>
+            <a:r>
+              <a:rPr lang="en-US" sz="1200" dirty="0">
+                <a:solidFill>
+                  <a:srgbClr val="0B1B33"/>
+                </a:solidFill>
+                <a:latin typeface="Courier New" panose="02070309020205020404" pitchFamily="34" charset="0"/>
+                <a:ea typeface="Courier New" panose="02070309020205020404" pitchFamily="34" charset="-122"/>
+                <a:cs typeface="Courier New" panose="02070309020205020404" pitchFamily="34" charset="-120"/>
+              </a:rPr>
+              <a:t>Jane Doe, Acme Holdings Ltd
+</a:t>
+            </a:r>
+            <a:r>
+              <a:rPr lang="en-US" sz="1200" b="1" dirty="0">
+                <a:solidFill>
+                  <a:srgbClr val="0B1B33"/>
+                </a:solidFill>
+                <a:latin typeface="Courier New" panose="02070309020205020404" pitchFamily="34" charset="0"/>
+                <a:ea typeface="Courier New" panose="02070309020205020404" pitchFamily="34" charset="-122"/>
+                <a:cs typeface="Courier New" panose="02070309020205020404" pitchFamily="34" charset="-120"/>
+              </a:rPr>
+              <a:t>Account:   </a:t>
+            </a:r>
+            <a:r>
+              <a:rPr lang="en-US" sz="1200" dirty="0">
+                <a:solidFill>
+                  <a:srgbClr val="0B1B33"/>
+                </a:solidFill>
+                <a:latin typeface="Courier New" panose="02070309020205020404" pitchFamily="34" charset="0"/>
+                <a:ea typeface="Courier New" panose="02070309020205020404" pitchFamily="34" charset="-122"/>
+                <a:cs typeface="Courier New" panose="02070309020205020404" pitchFamily="34" charset="-120"/>
+              </a:rPr>
+              <a:t>88-4471-02
+</a:t>
+            </a:r>
+            <a:r>
+              <a:rPr lang="en-US" sz="1200" b="1" dirty="0">
+                <a:solidFill>
+                  <a:srgbClr val="0B1B33"/>
+                </a:solidFill>
+                <a:latin typeface="Courier New" panose="02070309020205020404" pitchFamily="34" charset="0"/>
+                <a:ea typeface="Courier New" panose="02070309020205020404" pitchFamily="34" charset="-122"/>
+                <a:cs typeface="Courier New" panose="02070309020205020404" pitchFamily="34" charset="-120"/>
+              </a:rPr>
+              <a:t>Amount:    </a:t>
+            </a:r>
+            <a:r>
+              <a:rPr lang="en-US" sz="1200" dirty="0">
+                <a:solidFill>
+                  <a:srgbClr val="0B1B33"/>
+                </a:solidFill>
+                <a:latin typeface="Courier New" panose="02070309020205020404" pitchFamily="34" charset="0"/>
+                <a:ea typeface="Courier New" panose="02070309020205020404" pitchFamily="34" charset="-122"/>
+                <a:cs typeface="Courier New" panose="02070309020205020404" pitchFamily="34" charset="-120"/>
+              </a:rPr>
+              <a:t>EUR 41,220, due 14 Mar
+</a:t>
+            </a:r>
+            <a:r>
+              <a:rPr lang="en-US" sz="1200" b="1" dirty="0">
+                <a:solidFill>
+                  <a:srgbClr val="0B1B33"/>
+                </a:solidFill>
+                <a:latin typeface="Courier New" panose="02070309020205020404" pitchFamily="34" charset="0"/>
+                <a:ea typeface="Courier New" panose="02070309020205020404" pitchFamily="34" charset="-122"/>
+                <a:cs typeface="Courier New" panose="02070309020205020404" pitchFamily="34" charset="-120"/>
+              </a:rPr>
+              <a:t>Login:     </a:t>
+            </a:r>
+            <a:r>
+              <a:rPr lang="en-US" sz="1200" dirty="0">
+                <a:solidFill>
+                  <a:srgbClr val="0B1B33"/>
+                </a:solidFill>
+                <a:latin typeface="Courier New" panose="02070309020205020404" pitchFamily="34" charset="0"/>
+                <a:ea typeface="Courier New" panose="02070309020205020404" pitchFamily="34" charset="-122"/>
+                <a:cs typeface="Courier New" panose="02070309020205020404" pitchFamily="34" charset="-120"/>
+              </a:rPr>
+              <a:t>j.doe / ••••••••</a:t>
+            </a:r>
+            <a:endParaRPr lang="en-US" sz="1200" dirty="0"/>
+          </a:p>
+        </p:txBody>
+      </p:sp>
+      <p:sp>
+        <p:nvSpPr>
+          <p:cNvPr id="7" name="Text 4"/>
+          <p:cNvSpPr txBox="1"/>
+          <p:nvPr/>
+        </p:nvSpPr>
+        <p:spPr>
+          <a:xfrm>
+            <a:off x="914400" y="4343400"/>
+            <a:ext cx="6035040" cy="548640"/>
+          </a:xfrm>
+          <a:prstGeom prst="rect">
+            <a:avLst/>
+          </a:prstGeom>
+          <a:noFill/>
+        </p:spPr>
+        <p:txBody>
+          <a:bodyPr wrap="square" lIns="0" tIns="0" rIns="0" bIns="0" rtlCol="0" anchor="ctr"/>
+          <a:lstStyle/>
+          <a:p>
+            <a:pPr marL="0" indent="0">
+              <a:lnSpc>
+                <a:spcPts val="1500"/>
+              </a:lnSpc>
+              <a:buNone/>
+            </a:pPr>
+            <a:r>
+              <a:rPr lang="en-US" sz="1150" i="1" dirty="0">
                 <a:solidFill>
                   <a:srgbClr val="56606E"/>
                 </a:solidFill>
@@ -9831,74 +10614,68 @@
                 <a:ea typeface="Arial" panose="020B0604020202020204" pitchFamily="34" charset="-122"/>
                 <a:cs typeface="Arial" panose="020B0604020202020204" pitchFamily="34" charset="-120"/>
               </a:rPr>
-              <a:t>Try asking it this:</a:t>
-            </a:r>
-            <a:endParaRPr lang="en-US" sz="1200" dirty="0"/>
-          </a:p>
-        </p:txBody>
-      </p:sp>
-      <p:sp>
-        <p:nvSpPr>
-          <p:cNvPr id="22" name="Shape 14"/>
-          <p:cNvSpPr/>
-          <p:nvPr/>
-        </p:nvSpPr>
-        <p:spPr>
-          <a:xfrm>
-            <a:off x="6446520" y="3108960"/>
-            <a:ext cx="4526280" cy="1737360"/>
-          </a:xfrm>
-          <a:prstGeom prst="roundRect">
-            <a:avLst>
-              <a:gd name="adj" fmla="val 6316"/>
-            </a:avLst>
-          </a:prstGeom>
-          <a:solidFill>
-            <a:srgbClr val="FFFFFF"/>
-          </a:solidFill>
-          <a:ln w="12700">
-            <a:solidFill>
-              <a:srgbClr val="DCE4EF"/>
-            </a:solidFill>
-            <a:prstDash val="solid"/>
-          </a:ln>
+              <a:t>Names a person, a company, an account number, an amount, and a login. Once it's sent, it can't be pulled back.</a:t>
+            </a:r>
+            <a:endParaRPr lang="en-US" sz="1150" dirty="0"/>
+          </a:p>
+        </p:txBody>
+      </p:sp>
+      <p:pic>
+        <p:nvPicPr>
+          <p:cNvPr id="8" name="Image 1" descr="/home/claude/work/assets/viz_face.png"/>
+          <p:cNvPicPr>
+            <a:picLocks noChangeAspect="1"/>
+          </p:cNvPicPr>
+          <p:nvPr/>
+        </p:nvPicPr>
+        <p:blipFill>
+          <a:blip r:embed="rId2"/>
+          <a:stretch>
+            <a:fillRect/>
+          </a:stretch>
+        </p:blipFill>
+        <p:spPr>
+          <a:xfrm>
+            <a:off x="7635240" y="1600200"/>
+            <a:ext cx="4114800" cy="3429000"/>
+          </a:xfrm>
+          <a:prstGeom prst="rect">
+            <a:avLst/>
+          </a:prstGeom>
           <a:effectLst>
-            <a:outerShdw blurRad="101600" dist="38100" dir="5400000" algn="bl" rotWithShape="0">
-              <a:srgbClr val="1A2B33">
-                <a:alpha val="12000"/>
+            <a:outerShdw blurRad="152400" dist="50800" dir="5400000" algn="bl" rotWithShape="0">
+              <a:srgbClr val="0A2A4A">
+                <a:alpha val="25000"/>
               </a:srgbClr>
             </a:outerShdw>
           </a:effectLst>
         </p:spPr>
-      </p:sp>
-      <p:sp>
-        <p:nvSpPr>
-          <p:cNvPr id="23" name="Text 15"/>
-          <p:cNvSpPr txBox="1"/>
-          <p:nvPr/>
-        </p:nvSpPr>
-        <p:spPr>
-          <a:xfrm>
-            <a:off x="6720840" y="3108960"/>
-            <a:ext cx="3977640" cy="1737360"/>
-          </a:xfrm>
-          <a:prstGeom prst="rect">
-            <a:avLst/>
-          </a:prstGeom>
-          <a:noFill/>
-        </p:spPr>
-        <p:txBody>
-          <a:bodyPr wrap="square" lIns="0" tIns="0" rIns="0" bIns="0" rtlCol="0" anchor="ctr"/>
-          <a:lstStyle/>
-          <a:p>
-            <a:pPr marL="0" indent="0">
-              <a:lnSpc>
-                <a:spcPts val="1900"/>
-              </a:lnSpc>
-              <a:buNone/>
-            </a:pPr>
-            <a:r>
-              <a:rPr lang="en-US" sz="1350" i="1" dirty="0">
+      </p:pic>
+      <p:sp>
+        <p:nvSpPr>
+          <p:cNvPr id="9" name="Text 5"/>
+          <p:cNvSpPr txBox="1"/>
+          <p:nvPr/>
+        </p:nvSpPr>
+        <p:spPr>
+          <a:xfrm>
+            <a:off x="640080" y="5440680"/>
+            <a:ext cx="10881360" cy="548640"/>
+          </a:xfrm>
+          <a:prstGeom prst="rect">
+            <a:avLst/>
+          </a:prstGeom>
+          <a:noFill/>
+        </p:spPr>
+        <p:txBody>
+          <a:bodyPr wrap="square" lIns="0" tIns="0" rIns="0" bIns="0" rtlCol="0" anchor="ctr"/>
+          <a:lstStyle/>
+          <a:p>
+            <a:pPr marL="0" indent="0" algn="ctr">
+              <a:buNone/>
+            </a:pPr>
+            <a:r>
+              <a:rPr lang="en-US" sz="1400" b="1" dirty="0">
                 <a:solidFill>
                   <a:srgbClr val="00081D"/>
                 </a:solidFill>
@@ -9906,15 +10683,15 @@
                 <a:ea typeface="Arial" panose="020B0604020202020204" pitchFamily="34" charset="-122"/>
                 <a:cs typeface="Arial" panose="020B0604020202020204" pitchFamily="34" charset="-120"/>
               </a:rPr>
-              <a:t>“Always tell me where this comes from. If you don't have a real source, or you're not sure, say so instead of guessing.”</a:t>
-            </a:r>
-            <a:endParaRPr lang="en-US" sz="1350" dirty="0"/>
-          </a:p>
-        </p:txBody>
-      </p:sp>
-      <p:sp>
-        <p:nvSpPr>
-          <p:cNvPr id="24" name="Text 16"/>
+              <a:t>Take out the who, keep the what. Names, account numbers and exact amounts come out; the actual problem stays in.</a:t>
+            </a:r>
+            <a:endParaRPr lang="en-US" sz="1400" dirty="0"/>
+          </a:p>
+        </p:txBody>
+      </p:sp>
+      <p:sp>
+        <p:nvSpPr>
+          <p:cNvPr id="10" name="Text 6"/>
           <p:cNvSpPr txBox="1"/>
           <p:nvPr/>
         </p:nvSpPr>
@@ -9944,7 +10721,7 @@
                 <a:ea typeface="Arial" panose="020B0604020202020204" pitchFamily="34" charset="-122"/>
                 <a:cs typeface="Arial" panose="020B0604020202020204" pitchFamily="34" charset="-120"/>
               </a:rPr>
-              <a:t>9</a:t>
+              <a:t>8</a:t>
             </a:r>
             <a:endParaRPr lang="en-US" sz="900" dirty="0"/>
           </a:p>

</xml_diff>

<commit_message>
docs: remove 'Transaction team' label from the slide deck
</commit_message>
<xml_diff>
--- a/AI At Work.pptx
+++ b/AI At Work.pptx
@@ -1606,44 +1606,6 @@
           </a:prstGeom>
         </p:spPr>
       </p:pic>
-      <p:sp>
-        <p:nvSpPr>
-          <p:cNvPr id="3" name="Text 0"/>
-          <p:cNvSpPr txBox="1"/>
-          <p:nvPr/>
-        </p:nvSpPr>
-        <p:spPr>
-          <a:xfrm>
-            <a:off x="777240" y="1874520"/>
-            <a:ext cx="5486400" cy="320040"/>
-          </a:xfrm>
-          <a:prstGeom prst="rect">
-            <a:avLst/>
-          </a:prstGeom>
-          <a:noFill/>
-        </p:spPr>
-        <p:txBody>
-          <a:bodyPr wrap="square" lIns="0" tIns="0" rIns="0" bIns="0" rtlCol="0" anchor="ctr"/>
-          <a:lstStyle/>
-          <a:p>
-            <a:pPr marL="0" indent="0">
-              <a:buNone/>
-            </a:pPr>
-            <a:r>
-              <a:rPr lang="en-US" sz="1300" b="1" kern="0" spc="200" dirty="0">
-                <a:solidFill>
-                  <a:srgbClr val="2CB2D7"/>
-                </a:solidFill>
-                <a:latin typeface="Arial" panose="020B0604020202020204" pitchFamily="34" charset="0"/>
-                <a:ea typeface="Arial" panose="020B0604020202020204" pitchFamily="34" charset="-122"/>
-                <a:cs typeface="Arial" panose="020B0604020202020204" pitchFamily="34" charset="-120"/>
-              </a:rPr>
-              <a:t>TRANSACTION TEAM</a:t>
-            </a:r>
-            <a:endParaRPr lang="en-US" sz="1300" dirty="0"/>
-          </a:p>
-        </p:txBody>
-      </p:sp>
       <p:sp>
         <p:nvSpPr>
           <p:cNvPr id="4" name="Text 1"/>
@@ -7830,7 +7792,7 @@
                 <a:ea typeface="Arial" panose="020B0604020202020204" pitchFamily="34" charset="-122"/>
                 <a:cs typeface="Arial" panose="020B0604020202020204" pitchFamily="34" charset="-120"/>
               </a:rPr>
-              <a:t> </a:t>
+              <a:t xml:space="preserve"> </a:t>
             </a:r>
             <a:endParaRPr lang="en-US" sz="1250" dirty="0"/>
           </a:p>
@@ -7899,7 +7861,7 @@
                 <a:ea typeface="Arial" panose="020B0604020202020204" pitchFamily="34" charset="-122"/>
                 <a:cs typeface="Arial" panose="020B0604020202020204" pitchFamily="34" charset="-120"/>
               </a:rPr>
-              <a:t>Disclaimer: </a:t>
+              <a:t xml:space="preserve">Disclaimer: </a:t>
             </a:r>
             <a:r>
               <a:rPr lang="en-US" dirty="0">
@@ -7953,7 +7915,7 @@
                 <a:ea typeface="Arial" panose="020B0604020202020204" pitchFamily="34" charset="-122"/>
                 <a:cs typeface="Arial" panose="020B0604020202020204" pitchFamily="34" charset="-120"/>
               </a:rPr>
-              <a:t> data policy and go into its Data Controls yourself. Don't assume the default is doing what you want.</a:t>
+              <a:t xml:space="preserve"> data policy and go into its Data Controls yourself. Don't assume the default is doing what you want.</a:t>
             </a:r>
             <a:endParaRPr lang="en-US" dirty="0">
               <a:solidFill>
@@ -10493,7 +10455,7 @@
                 <a:ea typeface="Courier New" panose="02070309020205020404" pitchFamily="34" charset="-122"/>
                 <a:cs typeface="Courier New" panose="02070309020205020404" pitchFamily="34" charset="-120"/>
               </a:rPr>
-              <a:t>Client:    </a:t>
+              <a:t xml:space="preserve">Client:    </a:t>
             </a:r>
             <a:r>
               <a:rPr lang="en-US" sz="1200" dirty="0">
@@ -10516,7 +10478,7 @@
                 <a:ea typeface="Courier New" panose="02070309020205020404" pitchFamily="34" charset="-122"/>
                 <a:cs typeface="Courier New" panose="02070309020205020404" pitchFamily="34" charset="-120"/>
               </a:rPr>
-              <a:t>Account:   </a:t>
+              <a:t xml:space="preserve">Account:   </a:t>
             </a:r>
             <a:r>
               <a:rPr lang="en-US" sz="1200" dirty="0">
@@ -10539,7 +10501,7 @@
                 <a:ea typeface="Courier New" panose="02070309020205020404" pitchFamily="34" charset="-122"/>
                 <a:cs typeface="Courier New" panose="02070309020205020404" pitchFamily="34" charset="-120"/>
               </a:rPr>
-              <a:t>Amount:    </a:t>
+              <a:t xml:space="preserve">Amount:    </a:t>
             </a:r>
             <a:r>
               <a:rPr lang="en-US" sz="1200" dirty="0">
@@ -10562,7 +10524,7 @@
                 <a:ea typeface="Courier New" panose="02070309020205020404" pitchFamily="34" charset="-122"/>
                 <a:cs typeface="Courier New" panose="02070309020205020404" pitchFamily="34" charset="-120"/>
               </a:rPr>
-              <a:t>Login:     </a:t>
+              <a:t xml:space="preserve">Login:     </a:t>
             </a:r>
             <a:r>
               <a:rPr lang="en-US" sz="1200" dirty="0">

</xml_diff>

<commit_message>
feat: make the AI at work deck public ready and add a slide PDF
Reword team specific lines (our systems, IT built for us, Legal or Compliance) as
general advice, add a closing link to the dashboard, give the web deck the
PowerPoint title artwork, sharing tags and a Download PDF button, and export the
12 slides as a 16:9 PDF.
</commit_message>
<xml_diff>
--- a/AI At Work.pptx
+++ b/AI At Work.pptx
@@ -1679,7 +1679,7 @@
                 <a:ea typeface="Arial" panose="020B0604020202020204" pitchFamily="34" charset="-122"/>
                 <a:cs typeface="Arial" panose="020B0604020202020204" pitchFamily="34" charset="-120"/>
               </a:rPr>
-              <a:t>A few things to keep in mind about the AI chat tools we use day to day.</a:t>
+              <a:t>What to know before you paste work into an AI chat tool.</a:t>
             </a:r>
             <a:endParaRPr lang="en-US" sz="1400" dirty="0"/>
           </a:p>
@@ -1991,7 +1991,7 @@
                 <a:ea typeface="Arial" panose="020B0604020202020204" pitchFamily="34" charset="-122"/>
                 <a:cs typeface="Arial" panose="020B0604020202020204" pitchFamily="34" charset="-120"/>
               </a:rPr>
-              <a:t>No access to our systems, it only knows what you tell it.</a:t>
+              <a:t>It can't see your company's systems, only what you tell it.</a:t>
             </a:r>
             <a:endParaRPr lang="en-US" sz="1100" dirty="0"/>
           </a:p>
@@ -2101,7 +2101,7 @@
                 <a:ea typeface="Arial" panose="020B0604020202020204" pitchFamily="34" charset="-122"/>
                 <a:cs typeface="Arial" panose="020B0604020202020204" pitchFamily="34" charset="-120"/>
               </a:rPr>
-              <a:t>It has a cutoff date, a new rule or updated circular might not be in there yet.</a:t>
+              <a:t>It has a cutoff date, a new regulation or policy update might not be in there yet.</a:t>
             </a:r>
             <a:endParaRPr lang="en-US" sz="1100" dirty="0"/>
           </a:p>
@@ -3480,7 +3480,7 @@
                 <a:ea typeface="Arial" panose="020B0604020202020204" pitchFamily="34" charset="-122"/>
                 <a:cs typeface="Arial" panose="020B0604020202020204" pitchFamily="34" charset="-120"/>
               </a:rPr>
-              <a:t>Check with Legal or Compliance before your name, or the company's, goes on AI-written material.</a:t>
+              <a:t>Check your company's AI policy, or ask your legal team, before your name goes on AI-written material.</a:t>
             </a:r>
             <a:endParaRPr lang="en-US" sz="1050" dirty="0"/>
           </a:p>
@@ -3622,6 +3622,64 @@
           </a:p>
         </p:txBody>
       </p:sp>
+      <p:sp>
+        <p:nvSpPr>
+          <p:cNvPr id="4" name="Text 1"/>
+          <p:cNvSpPr txBox="1"/>
+          <p:nvPr/>
+        </p:nvSpPr>
+        <p:spPr>
+          <a:xfrm>
+            <a:off x="3352800" y="5638800"/>
+            <a:ext cx="5486400" cy="640080"/>
+          </a:xfrm>
+          <a:prstGeom prst="rect">
+            <a:avLst/>
+          </a:prstGeom>
+          <a:noFill/>
+        </p:spPr>
+        <p:txBody>
+          <a:bodyPr wrap="square" lIns="0" tIns="0" rIns="0" bIns="0" rtlCol="0" anchor="t"/>
+          <a:lstStyle/>
+          <a:p>
+            <a:pPr marL="0" indent="0" algn="ctr">
+              <a:buNone/>
+            </a:pPr>
+            <a:r>
+              <a:rPr lang="en-US" sz="1300" dirty="0">
+                <a:solidFill>
+                  <a:srgbClr val="0B1B33"/>
+                </a:solidFill>
+                <a:latin typeface="Arial" panose="020B0604020202020204" pitchFamily="34" charset="0"/>
+                <a:ea typeface="Arial" panose="020B0604020202020204" pitchFamily="34" charset="-122"/>
+                <a:cs typeface="Arial" panose="020B0604020202020204" pitchFamily="34" charset="-120"/>
+              </a:rPr>
+              <a:t>Explore the data behind this guide</a:t>
+            </a:r>
+          </a:p>
+          <a:p>
+            <a:pPr marL="0" indent="0" algn="ctr">
+              <a:spcBef>
+                <a:spcPts val="400"/>
+              </a:spcBef>
+              <a:buNone/>
+            </a:pPr>
+            <a:r>
+              <a:rPr lang="en-US" sz="1300" b="1" dirty="0">
+                <a:solidFill>
+                  <a:srgbClr val="1C5CAB"/>
+                </a:solidFill>
+                <a:latin typeface="Arial" panose="020B0604020202020204" pitchFamily="34" charset="0"/>
+                <a:ea typeface="Arial" panose="020B0604020202020204" pitchFamily="34" charset="-122"/>
+                <a:cs typeface="Arial" panose="020B0604020202020204" pitchFamily="34" charset="-120"/>
+                <a:hlinkClick r:id="rId4"/>
+              </a:rPr>
+              <a:t>sansanabria.github.io/ai-adoption-eu</a:t>
+            </a:r>
+            <a:endParaRPr lang="en-US" sz="1300" dirty="0"/>
+          </a:p>
+        </p:txBody>
+      </p:sp>
     </p:spTree>
   </p:cSld>
   <p:clrMapOvr>
@@ -3999,7 +4057,7 @@
         <p:spPr>
           <a:xfrm>
             <a:off x="1581912" y="4050791"/>
-            <a:ext cx="4206240" cy="566928"/>
+            <a:ext cx="4709160" cy="566928"/>
           </a:xfrm>
           <a:prstGeom prst="rect">
             <a:avLst/>
@@ -4024,7 +4082,7 @@
                 </a:solidFill>
                 <a:latin typeface="Arial" panose="020B0604020202020204"/>
               </a:rPr>
-              <a:t>AI tools and differences according to accounts</a:t>
+              <a:t>Your account type decides what happens to your data</a:t>
             </a:r>
             <a:endParaRPr sz="1400" b="1" i="0">
               <a:solidFill>
@@ -5892,7 +5950,7 @@
                 <a:ea typeface="Arial" panose="020B0604020202020204" pitchFamily="34" charset="-122"/>
                 <a:cs typeface="Arial" panose="020B0604020202020204" pitchFamily="34" charset="-120"/>
               </a:rPr>
-              <a:t>Our own AI agent</a:t>
+              <a:t>Your company's own AI tool</a:t>
             </a:r>
             <a:endParaRPr lang="en-US" sz="1900" dirty="0"/>
           </a:p>
@@ -5933,7 +5991,7 @@
                 <a:ea typeface="Arial" panose="020B0604020202020204" pitchFamily="34" charset="-122"/>
                 <a:cs typeface="Arial" panose="020B0604020202020204" pitchFamily="34" charset="-120"/>
               </a:rPr>
-              <a:t>Something the company sets up and controls itself. It might run on the same kind of model as any public AI chat tool under the hood, but it lives inside our own systems, with our own rules about what it can see and where the data goes.</a:t>
+              <a:t>Something the company sets up and controls itself. It might run on the same kind of model as any public AI chat tool under the hood, but it lives inside the company's own systems, with its own rules about what it can see and where the data goes.</a:t>
             </a:r>
             <a:endParaRPr lang="en-US" sz="1350" dirty="0"/>
           </a:p>
@@ -5974,7 +6032,7 @@
                 <a:ea typeface="Arial" panose="020B0604020202020204" pitchFamily="34" charset="-122"/>
                 <a:cs typeface="Arial" panose="020B0604020202020204" pitchFamily="34" charset="-120"/>
               </a:rPr>
-              <a:t>Examples: an internal assistant IT built for us, a tool wired directly into our own systems and data.</a:t>
+              <a:t>Examples: an assistant your IT team set up, or AI built into tools your company already manages.</a:t>
             </a:r>
             <a:endParaRPr lang="en-US" sz="1150" dirty="0"/>
           </a:p>
@@ -6368,7 +6426,7 @@
                 <a:ea typeface="Arial" panose="020B0604020202020204" pitchFamily="34" charset="-122"/>
                 <a:cs typeface="Arial" panose="020B0604020202020204" pitchFamily="34" charset="-120"/>
               </a:rPr>
-              <a:t>AI tools and differences according to accounts</a:t>
+              <a:t>Your account type decides what happens to your data</a:t>
             </a:r>
             <a:endParaRPr lang="en-US" sz="3000" dirty="0"/>
           </a:p>
@@ -7172,7 +7230,7 @@
                           <a:ea typeface="Arial" panose="020B0604020202020204" pitchFamily="34" charset="-122"/>
                           <a:cs typeface="Arial" panose="020B0604020202020204" pitchFamily="34" charset="-120"/>
                         </a:rPr>
-                        <a:t>Us, provider access is contractually limited</a:t>
+                        <a:t>Your company; provider access is limited by contract</a:t>
                       </a:r>
                       <a:endParaRPr lang="en-US" sz="1200" dirty="0">
                         <a:latin typeface="Arial" panose="020B0604020202020204" pitchFamily="34" charset="0"/>

</xml_diff>

<commit_message>
docs: remove every em dash from the README, dashboard, deck, PDF and report
Replace each with a comma, colon or full stop, regenerate the slides PDF and the
README banner so they match, and fix the one visual title inside the Power BI
report.
</commit_message>
<xml_diff>
--- a/AI At Work.pptx
+++ b/AI At Work.pptx
@@ -9581,7 +9581,7 @@
                 <a:ea typeface="Arial" panose="020B0604020202020204" pitchFamily="34" charset="-122"/>
                 <a:cs typeface="Arial" panose="020B0604020202020204" pitchFamily="34" charset="-120"/>
               </a:rPr>
-              <a:t>Names, employers, contact details — anyone identifiable, colleague or client.</a:t>
+              <a:t>Names, employers, contact details: anyone identifiable, colleague or client.</a:t>
             </a:r>
             <a:endParaRPr lang="en-US" sz="1150" dirty="0"/>
           </a:p>
@@ -9757,7 +9757,7 @@
                 <a:ea typeface="Arial" panose="020B0604020202020204" pitchFamily="34" charset="-122"/>
                 <a:cs typeface="Arial" panose="020B0604020202020204" pitchFamily="34" charset="-120"/>
               </a:rPr>
-              <a:t>Account IDs, case references, policy numbers — anything that maps back to a specific record.</a:t>
+              <a:t>Account IDs, case references, policy numbers: anything that maps back to a specific record.</a:t>
             </a:r>
             <a:endParaRPr lang="en-US" sz="1150" dirty="0"/>
           </a:p>
@@ -9933,7 +9933,7 @@
                 <a:ea typeface="Arial" panose="020B0604020202020204" pitchFamily="34" charset="-122"/>
                 <a:cs typeface="Arial" panose="020B0604020202020204" pitchFamily="34" charset="-120"/>
               </a:rPr>
-              <a:t>Real balances, amounts, dates or valuations — round them or describe them instead.</a:t>
+              <a:t>Real balances, amounts, dates or valuations: round them or describe them instead.</a:t>
             </a:r>
             <a:endParaRPr lang="en-US" sz="1150" dirty="0"/>
           </a:p>

</xml_diff>